<commit_message>
doc up to linking
</commit_message>
<xml_diff>
--- a/doc/images/Monomer.pptx
+++ b/doc/images/Monomer.pptx
@@ -3,11 +3,12 @@
 <p:presentation xmlns:a="http://schemas.openxmlformats.org/drawingml/2006/main" xmlns:p="http://schemas.openxmlformats.org/presentationml/2006/main" xmlns:r="http://schemas.openxmlformats.org/officeDocument/2006/relationships" xmlns:p14="http://schemas.microsoft.com/office/powerpoint/2010/main" xmlns:p15="http://schemas.microsoft.com/office/powerpoint/2012/main" xmlns:mc="http://schemas.openxmlformats.org/markup-compatibility/2006">
   <p:sldMasterIdLst>
     <p:sldMasterId id="2147483648" r:id="rId2"/>
+    <p:sldMasterId id="2147483650" r:id="rId3"/>
   </p:sldMasterIdLst>
   <p:sldIdLst>
-    <p:sldId id="256" r:id="rId3"/>
-    <p:sldId id="257" r:id="rId4"/>
-    <p:sldId id="258" r:id="rId5"/>
+    <p:sldId id="256" r:id="rId4"/>
+    <p:sldId id="257" r:id="rId5"/>
+    <p:sldId id="258" r:id="rId6"/>
   </p:sldIdLst>
   <p:sldSz cx="10080625" cy="5670550"/>
   <p:notesSz cx="7772400" cy="10058400"/>
@@ -44,7 +45,7 @@
         <p:spPr>
           <a:xfrm>
             <a:off x="504000" y="226080"/>
-            <a:ext cx="9071280" cy="946080"/>
+            <a:ext cx="9070920" cy="945720"/>
           </a:xfrm>
           <a:prstGeom prst="rect">
             <a:avLst/>
@@ -84,7 +85,7 @@
         <p:spPr>
           <a:xfrm>
             <a:off x="504000" y="1326600"/>
-            <a:ext cx="9072000" cy="3288600"/>
+            <a:ext cx="9071640" cy="3288240"/>
           </a:xfrm>
           <a:prstGeom prst="rect">
             <a:avLst/>
@@ -148,7 +149,7 @@
         <p:txBody>
           <a:bodyPr/>
           <a:p>
-            <a:fld id="{66546493-E960-41E8-BF1A-A8AB961A85BC}" type="slidenum">
+            <a:fld id="{72BC6089-C6A6-47A9-9EFD-A3D76CE093A7}" type="slidenum">
               <a:t>&lt;#&gt;</a:t>
             </a:fld>
           </a:p>
@@ -182,7 +183,7 @@
 
 <file path=ppt/slideLayouts/slideLayout2.xml><?xml version="1.0" encoding="utf-8"?>
 <p:sldLayout xmlns:a="http://schemas.openxmlformats.org/drawingml/2006/main" xmlns:p="http://schemas.openxmlformats.org/presentationml/2006/main" xmlns:r="http://schemas.openxmlformats.org/officeDocument/2006/relationships" xmlns:p14="http://schemas.microsoft.com/office/powerpoint/2010/main" xmlns:p15="http://schemas.microsoft.com/office/powerpoint/2012/main" xmlns:mc="http://schemas.openxmlformats.org/markup-compatibility/2006" type="title" preserve="1">
-  <p:cSld name="Default">
+  <p:cSld name="Default 1">
     <p:spTree>
       <p:nvGrpSpPr>
         <p:cNvPr id="1" name=""/>
@@ -199,7 +200,7 @@
       </p:grpSpPr>
       <p:sp>
         <p:nvSpPr>
-          <p:cNvPr id="7" name="PlaceHolder 1"/>
+          <p:cNvPr id="12" name="PlaceHolder 1"/>
           <p:cNvSpPr>
             <a:spLocks noGrp="1"/>
           </p:cNvSpPr>
@@ -210,7 +211,7 @@
         <p:spPr>
           <a:xfrm>
             <a:off x="504000" y="226080"/>
-            <a:ext cx="9071280" cy="946080"/>
+            <a:ext cx="9070920" cy="945720"/>
           </a:xfrm>
           <a:prstGeom prst="rect">
             <a:avLst/>
@@ -239,7 +240,7 @@
       </p:sp>
       <p:sp>
         <p:nvSpPr>
-          <p:cNvPr id="8" name="PlaceHolder 2"/>
+          <p:cNvPr id="13" name="PlaceHolder 2"/>
           <p:cNvSpPr>
             <a:spLocks noGrp="1"/>
           </p:cNvSpPr>
@@ -250,7 +251,7 @@
         <p:spPr>
           <a:xfrm>
             <a:off x="504000" y="1326600"/>
-            <a:ext cx="9072000" cy="3288600"/>
+            <a:ext cx="9071640" cy="3288240"/>
           </a:xfrm>
           <a:prstGeom prst="rect">
             <a:avLst/>
@@ -284,7 +285,7 @@
             <a:spLocks noGrp="1"/>
           </p:cNvSpPr>
           <p:nvPr>
-            <p:ph type="ftr" idx="1"/>
+            <p:ph type="ftr" idx="4"/>
           </p:nvPr>
         </p:nvSpPr>
         <p:spPr/>
@@ -304,14 +305,14 @@
             <a:spLocks noGrp="1"/>
           </p:cNvSpPr>
           <p:nvPr>
-            <p:ph type="sldNum" idx="2"/>
+            <p:ph type="sldNum" idx="5"/>
           </p:nvPr>
         </p:nvSpPr>
         <p:spPr/>
         <p:txBody>
           <a:bodyPr/>
           <a:p>
-            <a:fld id="{63F0DA53-777A-4EEE-B4CD-E96234AF2001}" type="slidenum">
+            <a:fld id="{20670438-1563-46AE-8A13-A8A306ADB9DC}" type="slidenum">
               <a:t>&lt;#&gt;</a:t>
             </a:fld>
           </a:p>
@@ -324,7 +325,7 @@
             <a:spLocks noGrp="1"/>
           </p:cNvSpPr>
           <p:nvPr>
-            <p:ph type="dt" idx="3"/>
+            <p:ph type="dt" idx="6"/>
           </p:nvPr>
         </p:nvSpPr>
         <p:spPr/>
@@ -373,7 +374,7 @@
         <p:spPr>
           <a:xfrm>
             <a:off x="504000" y="226080"/>
-            <a:ext cx="9071280" cy="946080"/>
+            <a:ext cx="9070920" cy="945720"/>
           </a:xfrm>
           <a:prstGeom prst="rect">
             <a:avLst/>
@@ -412,6 +413,231 @@
       <p:sp>
         <p:nvSpPr>
           <p:cNvPr id="1" name="PlaceHolder 2"/>
+          <p:cNvSpPr>
+            <a:spLocks noGrp="1"/>
+          </p:cNvSpPr>
+          <p:nvPr>
+            <p:ph type="body"/>
+          </p:nvPr>
+        </p:nvSpPr>
+        <p:spPr>
+          <a:xfrm>
+            <a:off x="504000" y="1326600"/>
+            <a:ext cx="9071640" cy="3288240"/>
+          </a:xfrm>
+          <a:prstGeom prst="rect">
+            <a:avLst/>
+          </a:prstGeom>
+          <a:noFill/>
+          <a:ln w="0">
+            <a:noFill/>
+          </a:ln>
+        </p:spPr>
+        <p:txBody>
+          <a:bodyPr lIns="0" rIns="0" tIns="0" bIns="0" anchor="t">
+            <a:normAutofit/>
+          </a:bodyPr>
+          <a:p>
+            <a:pPr marL="432000" indent="-324000">
+              <a:spcBef>
+                <a:spcPts val="1417"/>
+              </a:spcBef>
+              <a:buClr>
+                <a:srgbClr val="000000"/>
+              </a:buClr>
+              <a:buSzPct val="45000"/>
+              <a:buFont typeface="Wingdings" charset="2"/>
+              <a:buChar char=""/>
+            </a:pPr>
+            <a:r>
+              <a:rPr b="0" lang="en-US" sz="1800" spc="-1" strike="noStrike">
+                <a:solidFill>
+                  <a:srgbClr val="000000"/>
+                </a:solidFill>
+                <a:latin typeface="Arial"/>
+              </a:rPr>
+              <a:t>Click to edit the outline text format</a:t>
+            </a:r>
+            <a:endParaRPr b="0" lang="en-US" sz="1800" spc="-1" strike="noStrike">
+              <a:solidFill>
+                <a:srgbClr val="000000"/>
+              </a:solidFill>
+              <a:latin typeface="Arial"/>
+            </a:endParaRPr>
+          </a:p>
+          <a:p>
+            <a:pPr lvl="1" marL="864000" indent="-324000">
+              <a:spcBef>
+                <a:spcPts val="1134"/>
+              </a:spcBef>
+              <a:buClr>
+                <a:srgbClr val="000000"/>
+              </a:buClr>
+              <a:buSzPct val="75000"/>
+              <a:buFont typeface="Symbol" charset="2"/>
+              <a:buChar char=""/>
+            </a:pPr>
+            <a:r>
+              <a:rPr b="0" lang="en-US" sz="1800" spc="-1" strike="noStrike">
+                <a:solidFill>
+                  <a:srgbClr val="000000"/>
+                </a:solidFill>
+                <a:latin typeface="Arial"/>
+              </a:rPr>
+              <a:t>Second Outline Level</a:t>
+            </a:r>
+            <a:endParaRPr b="0" lang="en-US" sz="1800" spc="-1" strike="noStrike">
+              <a:solidFill>
+                <a:srgbClr val="000000"/>
+              </a:solidFill>
+              <a:latin typeface="Arial"/>
+            </a:endParaRPr>
+          </a:p>
+          <a:p>
+            <a:pPr lvl="2" marL="1296000" indent="-288000">
+              <a:spcBef>
+                <a:spcPts val="850"/>
+              </a:spcBef>
+              <a:buClr>
+                <a:srgbClr val="000000"/>
+              </a:buClr>
+              <a:buSzPct val="45000"/>
+              <a:buFont typeface="Wingdings" charset="2"/>
+              <a:buChar char=""/>
+            </a:pPr>
+            <a:r>
+              <a:rPr b="0" lang="en-US" sz="1800" spc="-1" strike="noStrike">
+                <a:solidFill>
+                  <a:srgbClr val="000000"/>
+                </a:solidFill>
+                <a:latin typeface="Arial"/>
+              </a:rPr>
+              <a:t>Third Outline Level</a:t>
+            </a:r>
+            <a:endParaRPr b="0" lang="en-US" sz="1800" spc="-1" strike="noStrike">
+              <a:solidFill>
+                <a:srgbClr val="000000"/>
+              </a:solidFill>
+              <a:latin typeface="Arial"/>
+            </a:endParaRPr>
+          </a:p>
+          <a:p>
+            <a:pPr lvl="3" marL="1728000" indent="-216000">
+              <a:spcBef>
+                <a:spcPts val="567"/>
+              </a:spcBef>
+              <a:buClr>
+                <a:srgbClr val="000000"/>
+              </a:buClr>
+              <a:buSzPct val="75000"/>
+              <a:buFont typeface="Symbol" charset="2"/>
+              <a:buChar char=""/>
+            </a:pPr>
+            <a:r>
+              <a:rPr b="0" lang="en-US" sz="1800" spc="-1" strike="noStrike">
+                <a:solidFill>
+                  <a:srgbClr val="000000"/>
+                </a:solidFill>
+                <a:latin typeface="Arial"/>
+              </a:rPr>
+              <a:t>Fourth Outline Level</a:t>
+            </a:r>
+            <a:endParaRPr b="0" lang="en-US" sz="1800" spc="-1" strike="noStrike">
+              <a:solidFill>
+                <a:srgbClr val="000000"/>
+              </a:solidFill>
+              <a:latin typeface="Arial"/>
+            </a:endParaRPr>
+          </a:p>
+          <a:p>
+            <a:pPr lvl="4" marL="2160000" indent="-216000">
+              <a:spcBef>
+                <a:spcPts val="283"/>
+              </a:spcBef>
+              <a:buClr>
+                <a:srgbClr val="000000"/>
+              </a:buClr>
+              <a:buSzPct val="45000"/>
+              <a:buFont typeface="Wingdings" charset="2"/>
+              <a:buChar char=""/>
+            </a:pPr>
+            <a:r>
+              <a:rPr b="0" lang="en-US" sz="1800" spc="-1" strike="noStrike">
+                <a:solidFill>
+                  <a:srgbClr val="000000"/>
+                </a:solidFill>
+                <a:latin typeface="Arial"/>
+              </a:rPr>
+              <a:t>Fifth Outline Level</a:t>
+            </a:r>
+            <a:endParaRPr b="0" lang="en-US" sz="1800" spc="-1" strike="noStrike">
+              <a:solidFill>
+                <a:srgbClr val="000000"/>
+              </a:solidFill>
+              <a:latin typeface="Arial"/>
+            </a:endParaRPr>
+          </a:p>
+          <a:p>
+            <a:pPr lvl="5" marL="2592000" indent="-216000">
+              <a:spcBef>
+                <a:spcPts val="283"/>
+              </a:spcBef>
+              <a:buClr>
+                <a:srgbClr val="000000"/>
+              </a:buClr>
+              <a:buSzPct val="45000"/>
+              <a:buFont typeface="Wingdings" charset="2"/>
+              <a:buChar char=""/>
+            </a:pPr>
+            <a:r>
+              <a:rPr b="0" lang="en-US" sz="1800" spc="-1" strike="noStrike">
+                <a:solidFill>
+                  <a:srgbClr val="000000"/>
+                </a:solidFill>
+                <a:latin typeface="Arial"/>
+              </a:rPr>
+              <a:t>Sixth Outline Level</a:t>
+            </a:r>
+            <a:endParaRPr b="0" lang="en-US" sz="1800" spc="-1" strike="noStrike">
+              <a:solidFill>
+                <a:srgbClr val="000000"/>
+              </a:solidFill>
+              <a:latin typeface="Arial"/>
+            </a:endParaRPr>
+          </a:p>
+          <a:p>
+            <a:pPr lvl="6" marL="3024000" indent="-216000">
+              <a:spcBef>
+                <a:spcPts val="283"/>
+              </a:spcBef>
+              <a:buClr>
+                <a:srgbClr val="000000"/>
+              </a:buClr>
+              <a:buSzPct val="45000"/>
+              <a:buFont typeface="Wingdings" charset="2"/>
+              <a:buChar char=""/>
+            </a:pPr>
+            <a:r>
+              <a:rPr b="0" lang="en-US" sz="1800" spc="-1" strike="noStrike">
+                <a:solidFill>
+                  <a:srgbClr val="000000"/>
+                </a:solidFill>
+                <a:latin typeface="Arial"/>
+              </a:rPr>
+              <a:t>Seventh Outline Level</a:t>
+            </a:r>
+            <a:endParaRPr b="0" lang="en-US" sz="1800" spc="-1" strike="noStrike">
+              <a:solidFill>
+                <a:srgbClr val="000000"/>
+              </a:solidFill>
+              <a:latin typeface="Arial"/>
+            </a:endParaRPr>
+          </a:p>
+        </p:txBody>
+      </p:sp>
+      <p:sp>
+        <p:nvSpPr>
+          <p:cNvPr id="2" name="PlaceHolder 3"/>
           <p:cNvSpPr>
             <a:spLocks noGrp="1"/>
           </p:cNvSpPr>
@@ -422,7 +648,7 @@
         <p:spPr>
           <a:xfrm>
             <a:off x="3447360" y="5165280"/>
-            <a:ext cx="3194640" cy="390240"/>
+            <a:ext cx="3194280" cy="389880"/>
           </a:xfrm>
           <a:prstGeom prst="rect">
             <a:avLst/>
@@ -483,7 +709,7 @@
       </p:sp>
       <p:sp>
         <p:nvSpPr>
-          <p:cNvPr id="2" name="PlaceHolder 3"/>
+          <p:cNvPr id="3" name="PlaceHolder 4"/>
           <p:cNvSpPr>
             <a:spLocks noGrp="1"/>
           </p:cNvSpPr>
@@ -494,7 +720,7 @@
         <p:spPr>
           <a:xfrm>
             <a:off x="7227360" y="5165280"/>
-            <a:ext cx="2347920" cy="390240"/>
+            <a:ext cx="2347560" cy="389880"/>
           </a:xfrm>
           <a:prstGeom prst="rect">
             <a:avLst/>
@@ -535,7 +761,7 @@
                 <a:tab algn="l" pos="0"/>
               </a:tabLst>
             </a:pPr>
-            <a:fld id="{BB9B203E-606B-4C6A-BB37-4857BBE2EA92}" type="slidenum">
+            <a:fld id="{7B34BA5A-05C0-4FB0-AD67-9C72D30C1386}" type="slidenum">
               <a:rPr b="0" lang="en-US" sz="1400" spc="-1" strike="noStrike">
                 <a:solidFill>
                   <a:srgbClr val="000000"/>
@@ -555,7 +781,7 @@
       </p:sp>
       <p:sp>
         <p:nvSpPr>
-          <p:cNvPr id="3" name="PlaceHolder 4"/>
+          <p:cNvPr id="4" name="PlaceHolder 5"/>
           <p:cNvSpPr>
             <a:spLocks noGrp="1"/>
           </p:cNvSpPr>
@@ -566,7 +792,7 @@
         <p:spPr>
           <a:xfrm>
             <a:off x="504000" y="5165280"/>
-            <a:ext cx="2347920" cy="390240"/>
+            <a:ext cx="2347560" cy="389880"/>
           </a:xfrm>
           <a:prstGeom prst="rect">
             <a:avLst/>
@@ -613,9 +839,297 @@
           </a:p>
         </p:txBody>
       </p:sp>
-      <p:sp>
-        <p:nvSpPr>
-          <p:cNvPr id="4" name="PlaceHolder 5"/>
+    </p:spTree>
+  </p:cSld>
+  <p:clrMap bg1="lt1" bg2="lt2" tx1="dk1" tx2="dk2" accent1="accent1" accent2="accent2" accent3="accent3" accent4="accent4" accent5="accent5" accent6="accent6" hlink="hlink" folHlink="folHlink"/>
+  <p:sldLayoutIdLst>
+    <p:sldLayoutId id="2147483649" r:id="rId2"/>
+  </p:sldLayoutIdLst>
+</p:sldMaster>
+</file>
+
+<file path=ppt/slideMasters/slideMaster2.xml><?xml version="1.0" encoding="utf-8"?>
+<p:sldMaster xmlns:a="http://schemas.openxmlformats.org/drawingml/2006/main" xmlns:p="http://schemas.openxmlformats.org/presentationml/2006/main" xmlns:r="http://schemas.openxmlformats.org/officeDocument/2006/relationships" xmlns:p14="http://schemas.microsoft.com/office/powerpoint/2010/main" xmlns:p15="http://schemas.microsoft.com/office/powerpoint/2012/main" xmlns:mc="http://schemas.openxmlformats.org/markup-compatibility/2006">
+  <p:cSld>
+    <p:spTree>
+      <p:nvGrpSpPr>
+        <p:cNvPr id="1" name=""/>
+        <p:cNvGrpSpPr/>
+        <p:nvPr/>
+      </p:nvGrpSpPr>
+      <p:grpSpPr>
+        <a:xfrm>
+          <a:off x="0" y="0"/>
+          <a:ext cx="0" cy="0"/>
+          <a:chOff x="0" y="0"/>
+          <a:chExt cx="0" cy="0"/>
+        </a:xfrm>
+      </p:grpSpPr>
+      <p:sp>
+        <p:nvSpPr>
+          <p:cNvPr id="7" name="PlaceHolder 1"/>
+          <p:cNvSpPr>
+            <a:spLocks noGrp="1"/>
+          </p:cNvSpPr>
+          <p:nvPr>
+            <p:ph type="title"/>
+          </p:nvPr>
+        </p:nvSpPr>
+        <p:spPr>
+          <a:xfrm>
+            <a:off x="504000" y="226080"/>
+            <a:ext cx="9070920" cy="945720"/>
+          </a:xfrm>
+          <a:prstGeom prst="rect">
+            <a:avLst/>
+          </a:prstGeom>
+          <a:noFill/>
+          <a:ln w="0">
+            <a:noFill/>
+          </a:ln>
+        </p:spPr>
+        <p:txBody>
+          <a:bodyPr lIns="0" rIns="0" tIns="0" bIns="0" anchor="ctr">
+            <a:noAutofit/>
+          </a:bodyPr>
+          <a:p>
+            <a:pPr indent="0">
+              <a:buNone/>
+            </a:pPr>
+            <a:r>
+              <a:rPr b="0" lang="en-US" sz="1800" spc="-1" strike="noStrike">
+                <a:solidFill>
+                  <a:srgbClr val="000000"/>
+                </a:solidFill>
+                <a:latin typeface="Arial"/>
+              </a:rPr>
+              <a:t>Click to edit the </a:t>
+            </a:r>
+            <a:r>
+              <a:rPr b="0" lang="en-US" sz="1800" spc="-1" strike="noStrike">
+                <a:solidFill>
+                  <a:srgbClr val="000000"/>
+                </a:solidFill>
+                <a:latin typeface="Arial"/>
+              </a:rPr>
+              <a:t>title text format</a:t>
+            </a:r>
+            <a:endParaRPr b="0" lang="en-US" sz="1800" spc="-1" strike="noStrike">
+              <a:solidFill>
+                <a:srgbClr val="000000"/>
+              </a:solidFill>
+              <a:latin typeface="Arial"/>
+            </a:endParaRPr>
+          </a:p>
+        </p:txBody>
+      </p:sp>
+      <p:sp>
+        <p:nvSpPr>
+          <p:cNvPr id="8" name="PlaceHolder 2"/>
+          <p:cNvSpPr>
+            <a:spLocks noGrp="1"/>
+          </p:cNvSpPr>
+          <p:nvPr>
+            <p:ph type="ftr" idx="4"/>
+          </p:nvPr>
+        </p:nvSpPr>
+        <p:spPr>
+          <a:xfrm>
+            <a:off x="3447360" y="5165280"/>
+            <a:ext cx="3194280" cy="389880"/>
+          </a:xfrm>
+          <a:prstGeom prst="rect">
+            <a:avLst/>
+          </a:prstGeom>
+          <a:noFill/>
+          <a:ln w="0">
+            <a:noFill/>
+          </a:ln>
+        </p:spPr>
+        <p:txBody>
+          <a:bodyPr lIns="0" rIns="0" tIns="0" bIns="0" anchor="t">
+            <a:noAutofit/>
+          </a:bodyPr>
+          <a:lstStyle>
+            <a:lvl1pPr indent="0" algn="ctr">
+              <a:lnSpc>
+                <a:spcPct val="100000"/>
+              </a:lnSpc>
+              <a:buNone/>
+              <a:tabLst>
+                <a:tab algn="l" pos="0"/>
+              </a:tabLst>
+              <a:defRPr b="0" lang="en-US" sz="1400" spc="-1" strike="noStrike">
+                <a:solidFill>
+                  <a:srgbClr val="000000"/>
+                </a:solidFill>
+                <a:latin typeface="Times New Roman"/>
+              </a:defRPr>
+            </a:lvl1pPr>
+          </a:lstStyle>
+          <a:p>
+            <a:pPr indent="0" algn="ctr">
+              <a:lnSpc>
+                <a:spcPct val="100000"/>
+              </a:lnSpc>
+              <a:buNone/>
+              <a:tabLst>
+                <a:tab algn="l" pos="0"/>
+              </a:tabLst>
+            </a:pPr>
+            <a:r>
+              <a:rPr b="0" lang="en-US" sz="1400" spc="-1" strike="noStrike">
+                <a:solidFill>
+                  <a:srgbClr val="000000"/>
+                </a:solidFill>
+                <a:latin typeface="Times New Roman"/>
+              </a:rPr>
+              <a:t>&lt;footer&gt;</a:t>
+            </a:r>
+            <a:endParaRPr b="0" lang="en-US" sz="1400" spc="-1" strike="noStrike">
+              <a:solidFill>
+                <a:srgbClr val="000000"/>
+              </a:solidFill>
+              <a:latin typeface="Times New Roman"/>
+            </a:endParaRPr>
+          </a:p>
+        </p:txBody>
+      </p:sp>
+      <p:sp>
+        <p:nvSpPr>
+          <p:cNvPr id="9" name="PlaceHolder 3"/>
+          <p:cNvSpPr>
+            <a:spLocks noGrp="1"/>
+          </p:cNvSpPr>
+          <p:nvPr>
+            <p:ph type="sldNum" idx="5"/>
+          </p:nvPr>
+        </p:nvSpPr>
+        <p:spPr>
+          <a:xfrm>
+            <a:off x="7227360" y="5165280"/>
+            <a:ext cx="2347560" cy="389880"/>
+          </a:xfrm>
+          <a:prstGeom prst="rect">
+            <a:avLst/>
+          </a:prstGeom>
+          <a:noFill/>
+          <a:ln w="0">
+            <a:noFill/>
+          </a:ln>
+        </p:spPr>
+        <p:txBody>
+          <a:bodyPr lIns="0" rIns="0" tIns="0" bIns="0" anchor="t">
+            <a:noAutofit/>
+          </a:bodyPr>
+          <a:lstStyle>
+            <a:lvl1pPr indent="0" algn="r">
+              <a:lnSpc>
+                <a:spcPct val="100000"/>
+              </a:lnSpc>
+              <a:buNone/>
+              <a:tabLst>
+                <a:tab algn="l" pos="0"/>
+              </a:tabLst>
+              <a:defRPr b="0" lang="en-US" sz="1400" spc="-1" strike="noStrike">
+                <a:solidFill>
+                  <a:srgbClr val="000000"/>
+                </a:solidFill>
+                <a:latin typeface="Times New Roman"/>
+              </a:defRPr>
+            </a:lvl1pPr>
+          </a:lstStyle>
+          <a:p>
+            <a:pPr indent="0" algn="r">
+              <a:lnSpc>
+                <a:spcPct val="100000"/>
+              </a:lnSpc>
+              <a:buNone/>
+              <a:tabLst>
+                <a:tab algn="l" pos="0"/>
+              </a:tabLst>
+            </a:pPr>
+            <a:fld id="{7CC32A0D-7994-499D-B7B1-BF6907ED703B}" type="slidenum">
+              <a:rPr b="0" lang="en-US" sz="1400" spc="-1" strike="noStrike">
+                <a:solidFill>
+                  <a:srgbClr val="000000"/>
+                </a:solidFill>
+                <a:latin typeface="Times New Roman"/>
+              </a:rPr>
+              <a:t>&lt;number&gt;</a:t>
+            </a:fld>
+            <a:endParaRPr b="0" lang="en-US" sz="1400" spc="-1" strike="noStrike">
+              <a:solidFill>
+                <a:srgbClr val="000000"/>
+              </a:solidFill>
+              <a:latin typeface="Times New Roman"/>
+            </a:endParaRPr>
+          </a:p>
+        </p:txBody>
+      </p:sp>
+      <p:sp>
+        <p:nvSpPr>
+          <p:cNvPr id="10" name="PlaceHolder 4"/>
+          <p:cNvSpPr>
+            <a:spLocks noGrp="1"/>
+          </p:cNvSpPr>
+          <p:nvPr>
+            <p:ph type="dt" idx="6"/>
+          </p:nvPr>
+        </p:nvSpPr>
+        <p:spPr>
+          <a:xfrm>
+            <a:off x="504000" y="5165280"/>
+            <a:ext cx="2347560" cy="389880"/>
+          </a:xfrm>
+          <a:prstGeom prst="rect">
+            <a:avLst/>
+          </a:prstGeom>
+          <a:noFill/>
+          <a:ln w="0">
+            <a:noFill/>
+          </a:ln>
+        </p:spPr>
+        <p:txBody>
+          <a:bodyPr lIns="0" rIns="0" tIns="0" bIns="0" anchor="t">
+            <a:noAutofit/>
+          </a:bodyPr>
+          <a:lstStyle>
+            <a:lvl1pPr indent="0">
+              <a:buNone/>
+              <a:defRPr b="0" lang="en-US" sz="1400" spc="-1" strike="noStrike">
+                <a:solidFill>
+                  <a:srgbClr val="000000"/>
+                </a:solidFill>
+                <a:latin typeface="Times New Roman"/>
+              </a:defRPr>
+            </a:lvl1pPr>
+          </a:lstStyle>
+          <a:p>
+            <a:pPr indent="0">
+              <a:buNone/>
+            </a:pPr>
+            <a:r>
+              <a:rPr b="0" lang="en-US" sz="1400" spc="-1" strike="noStrike">
+                <a:solidFill>
+                  <a:srgbClr val="000000"/>
+                </a:solidFill>
+                <a:latin typeface="Times New Roman"/>
+              </a:rPr>
+              <a:t>&lt;date/time&gt;</a:t>
+            </a:r>
+            <a:endParaRPr b="0" lang="en-US" sz="1400" spc="-1" strike="noStrike">
+              <a:solidFill>
+                <a:srgbClr val="000000"/>
+              </a:solidFill>
+              <a:latin typeface="Times New Roman"/>
+            </a:endParaRPr>
+          </a:p>
+        </p:txBody>
+      </p:sp>
+      <p:sp>
+        <p:nvSpPr>
+          <p:cNvPr id="11" name="PlaceHolder 5"/>
           <p:cNvSpPr>
             <a:spLocks noGrp="1"/>
           </p:cNvSpPr>
@@ -842,8 +1356,7 @@
   </p:cSld>
   <p:clrMap bg1="lt1" bg2="lt2" tx1="dk1" tx2="dk2" accent1="accent1" accent2="accent2" accent3="accent3" accent4="accent4" accent5="accent5" accent6="accent6" hlink="hlink" folHlink="folHlink"/>
   <p:sldLayoutIdLst>
-    <p:sldLayoutId id="2147483649" r:id="rId2"/>
-    <p:sldLayoutId id="2147483650" r:id="rId3"/>
+    <p:sldLayoutId id="2147483651" r:id="rId2"/>
   </p:sldLayoutIdLst>
 </p:sldMaster>
 </file>
@@ -867,7 +1380,7 @@
       </p:grpSpPr>
       <p:pic>
         <p:nvPicPr>
-          <p:cNvPr id="9" name="" descr=""/>
+          <p:cNvPr id="14" name="" descr=""/>
           <p:cNvPicPr/>
           <p:nvPr/>
         </p:nvPicPr>
@@ -878,7 +1391,7 @@
         <p:spPr>
           <a:xfrm>
             <a:off x="3648600" y="1162440"/>
-            <a:ext cx="2523240" cy="3637800"/>
+            <a:ext cx="2522880" cy="3637440"/>
           </a:xfrm>
           <a:prstGeom prst="rect">
             <a:avLst/>
@@ -890,7 +1403,7 @@
       </p:pic>
       <p:sp>
         <p:nvSpPr>
-          <p:cNvPr id="10" name=""/>
+          <p:cNvPr id="15" name=""/>
           <p:cNvSpPr/>
           <p:nvPr/>
         </p:nvSpPr>
@@ -933,14 +1446,14 @@
       </p:sp>
       <p:sp>
         <p:nvSpPr>
-          <p:cNvPr id="11" name=""/>
+          <p:cNvPr id="16" name=""/>
           <p:cNvSpPr/>
           <p:nvPr/>
         </p:nvSpPr>
         <p:spPr>
           <a:xfrm>
             <a:off x="6955200" y="3742200"/>
-            <a:ext cx="1777680" cy="345960"/>
+            <a:ext cx="1777320" cy="345600"/>
           </a:xfrm>
           <a:prstGeom prst="rect">
             <a:avLst/>
@@ -972,6 +1485,7 @@
                   <a:srgbClr val="000000"/>
                 </a:solidFill>
                 <a:latin typeface="Arial"/>
+                <a:ea typeface="DejaVu Sans"/>
               </a:rPr>
               <a:t>Monomer name</a:t>
             </a:r>
@@ -986,7 +1500,7 @@
       </p:sp>
       <p:sp>
         <p:nvSpPr>
-          <p:cNvPr id="12" name=""/>
+          <p:cNvPr id="17" name=""/>
           <p:cNvSpPr/>
           <p:nvPr/>
         </p:nvSpPr>
@@ -1029,14 +1543,14 @@
       </p:sp>
       <p:sp>
         <p:nvSpPr>
-          <p:cNvPr id="13" name=""/>
+          <p:cNvPr id="18" name=""/>
           <p:cNvSpPr/>
           <p:nvPr/>
         </p:nvSpPr>
         <p:spPr>
           <a:xfrm>
             <a:off x="6955560" y="4066200"/>
-            <a:ext cx="1321920" cy="345960"/>
+            <a:ext cx="1321560" cy="345600"/>
           </a:xfrm>
           <a:prstGeom prst="rect">
             <a:avLst/>
@@ -1068,6 +1582,7 @@
                   <a:srgbClr val="000000"/>
                 </a:solidFill>
                 <a:latin typeface="Arial"/>
+                <a:ea typeface="DejaVu Sans"/>
               </a:rPr>
               <a:t>BILN name</a:t>
             </a:r>
@@ -1082,7 +1597,7 @@
       </p:sp>
       <p:sp>
         <p:nvSpPr>
-          <p:cNvPr id="14" name=""/>
+          <p:cNvPr id="19" name=""/>
           <p:cNvSpPr/>
           <p:nvPr/>
         </p:nvSpPr>
@@ -1125,14 +1640,14 @@
       </p:sp>
       <p:sp>
         <p:nvSpPr>
-          <p:cNvPr id="15" name=""/>
+          <p:cNvPr id="20" name=""/>
           <p:cNvSpPr/>
           <p:nvPr/>
         </p:nvSpPr>
         <p:spPr>
           <a:xfrm>
             <a:off x="6955920" y="4354200"/>
-            <a:ext cx="2198160" cy="345960"/>
+            <a:ext cx="2197800" cy="345600"/>
           </a:xfrm>
           <a:prstGeom prst="rect">
             <a:avLst/>
@@ -1164,6 +1679,7 @@
                   <a:srgbClr val="000000"/>
                 </a:solidFill>
                 <a:latin typeface="Arial"/>
+                <a:ea typeface="DejaVu Sans"/>
               </a:rPr>
               <a:t>3 letter name (PDB)</a:t>
             </a:r>
@@ -1178,14 +1694,14 @@
       </p:sp>
       <p:sp>
         <p:nvSpPr>
-          <p:cNvPr id="16" name=""/>
+          <p:cNvPr id="21" name=""/>
           <p:cNvSpPr/>
           <p:nvPr/>
         </p:nvSpPr>
         <p:spPr>
           <a:xfrm>
             <a:off x="5871600" y="1143000"/>
-            <a:ext cx="456840" cy="2514240"/>
+            <a:ext cx="456480" cy="2513880"/>
           </a:xfrm>
           <a:prstGeom prst="rect">
             <a:avLst/>
@@ -1255,7 +1771,7 @@
       </p:grpSpPr>
       <p:pic>
         <p:nvPicPr>
-          <p:cNvPr id="17" name="" descr=""/>
+          <p:cNvPr id="22" name="" descr=""/>
           <p:cNvPicPr/>
           <p:nvPr/>
         </p:nvPicPr>
@@ -1266,7 +1782,7 @@
         <p:spPr>
           <a:xfrm>
             <a:off x="1371600" y="228600"/>
-            <a:ext cx="5757840" cy="5067000"/>
+            <a:ext cx="5757480" cy="5066640"/>
           </a:xfrm>
           <a:prstGeom prst="rect">
             <a:avLst/>
@@ -1278,14 +1794,14 @@
       </p:pic>
       <p:sp>
         <p:nvSpPr>
-          <p:cNvPr id="18" name=""/>
-          <p:cNvSpPr txBox="1"/>
+          <p:cNvPr id="23" name=""/>
+          <p:cNvSpPr/>
           <p:nvPr/>
         </p:nvSpPr>
         <p:spPr>
           <a:xfrm>
             <a:off x="7795800" y="685800"/>
-            <a:ext cx="1348200" cy="346320"/>
+            <a:ext cx="1347840" cy="345960"/>
           </a:xfrm>
           <a:prstGeom prst="rect">
             <a:avLst/>
@@ -1295,13 +1811,24 @@
             <a:noFill/>
           </a:ln>
         </p:spPr>
+        <p:style>
+          <a:lnRef idx="0"/>
+          <a:fillRef idx="0"/>
+          <a:effectRef idx="0"/>
+          <a:fontRef idx="minor"/>
+        </p:style>
         <p:txBody>
           <a:bodyPr lIns="90000" rIns="90000" tIns="45000" bIns="45000" anchor="t">
             <a:noAutofit/>
           </a:bodyPr>
           <a:p>
-            <a:r>
-              <a:rPr b="0" lang="en-US" sz="1800" spc="-1" strike="noStrike">
+            <a:pPr>
+              <a:lnSpc>
+                <a:spcPct val="100000"/>
+              </a:lnSpc>
+            </a:pPr>
+            <a:r>
+              <a:rPr b="1" lang="en-US" sz="1600" spc="-1" strike="noStrike">
                 <a:solidFill>
                   <a:srgbClr val="000000"/>
                 </a:solidFill>
@@ -1309,25 +1836,25 @@
               </a:rPr>
               <a:t>Text search</a:t>
             </a:r>
-            <a:endParaRPr b="0" lang="en-US" sz="1800" spc="-1" strike="noStrike">
-              <a:solidFill>
-                <a:srgbClr val="000000"/>
-              </a:solidFill>
-              <a:latin typeface="Arial"/>
-            </a:endParaRPr>
-          </a:p>
-        </p:txBody>
-      </p:sp>
-      <p:sp>
-        <p:nvSpPr>
-          <p:cNvPr id="19" name=""/>
-          <p:cNvSpPr txBox="1"/>
+            <a:endParaRPr b="1" lang="en-US" sz="1600" spc="-1" strike="noStrike">
+              <a:solidFill>
+                <a:srgbClr val="000000"/>
+              </a:solidFill>
+              <a:latin typeface="Arial"/>
+            </a:endParaRPr>
+          </a:p>
+        </p:txBody>
+      </p:sp>
+      <p:sp>
+        <p:nvSpPr>
+          <p:cNvPr id="24" name=""/>
+          <p:cNvSpPr/>
           <p:nvPr/>
         </p:nvSpPr>
         <p:spPr>
           <a:xfrm>
             <a:off x="7796160" y="1297800"/>
-            <a:ext cx="1727640" cy="346320"/>
+            <a:ext cx="1727280" cy="345960"/>
           </a:xfrm>
           <a:prstGeom prst="rect">
             <a:avLst/>
@@ -1337,13 +1864,24 @@
             <a:noFill/>
           </a:ln>
         </p:spPr>
+        <p:style>
+          <a:lnRef idx="0"/>
+          <a:fillRef idx="0"/>
+          <a:effectRef idx="0"/>
+          <a:fontRef idx="minor"/>
+        </p:style>
         <p:txBody>
           <a:bodyPr lIns="90000" rIns="90000" tIns="45000" bIns="45000" anchor="t">
             <a:noAutofit/>
           </a:bodyPr>
           <a:p>
-            <a:r>
-              <a:rPr b="0" lang="en-US" sz="1800" spc="-1" strike="noStrike">
+            <a:pPr>
+              <a:lnSpc>
+                <a:spcPct val="100000"/>
+              </a:lnSpc>
+            </a:pPr>
+            <a:r>
+              <a:rPr b="1" lang="en-US" sz="1600" spc="-1" strike="noStrike">
                 <a:solidFill>
                   <a:srgbClr val="000000"/>
                 </a:solidFill>
@@ -1351,25 +1889,25 @@
               </a:rPr>
               <a:t>Monomer class</a:t>
             </a:r>
-            <a:endParaRPr b="0" lang="en-US" sz="1800" spc="-1" strike="noStrike">
-              <a:solidFill>
-                <a:srgbClr val="000000"/>
-              </a:solidFill>
-              <a:latin typeface="Arial"/>
-            </a:endParaRPr>
-          </a:p>
-        </p:txBody>
-      </p:sp>
-      <p:sp>
-        <p:nvSpPr>
-          <p:cNvPr id="20" name=""/>
-          <p:cNvSpPr txBox="1"/>
+            <a:endParaRPr b="1" lang="en-US" sz="1600" spc="-1" strike="noStrike">
+              <a:solidFill>
+                <a:srgbClr val="000000"/>
+              </a:solidFill>
+              <a:latin typeface="Arial"/>
+            </a:endParaRPr>
+          </a:p>
+        </p:txBody>
+      </p:sp>
+      <p:sp>
+        <p:nvSpPr>
+          <p:cNvPr id="25" name=""/>
+          <p:cNvSpPr/>
           <p:nvPr/>
         </p:nvSpPr>
         <p:spPr>
           <a:xfrm>
             <a:off x="7796520" y="4177800"/>
-            <a:ext cx="2209320" cy="346320"/>
+            <a:ext cx="2284200" cy="345960"/>
           </a:xfrm>
           <a:prstGeom prst="rect">
             <a:avLst/>
@@ -1379,39 +1917,50 @@
             <a:noFill/>
           </a:ln>
         </p:spPr>
+        <p:style>
+          <a:lnRef idx="0"/>
+          <a:fillRef idx="0"/>
+          <a:effectRef idx="0"/>
+          <a:fontRef idx="minor"/>
+        </p:style>
         <p:txBody>
           <a:bodyPr lIns="90000" rIns="90000" tIns="45000" bIns="45000" anchor="t">
             <a:noAutofit/>
           </a:bodyPr>
           <a:p>
-            <a:r>
-              <a:rPr b="0" lang="en-US" sz="1800" spc="-1" strike="noStrike">
+            <a:pPr>
+              <a:lnSpc>
+                <a:spcPct val="100000"/>
+              </a:lnSpc>
+            </a:pPr>
+            <a:r>
+              <a:rPr b="1" lang="en-US" sz="1600" spc="-1" strike="noStrike">
                 <a:solidFill>
                   <a:srgbClr val="000000"/>
                 </a:solidFill>
                 <a:latin typeface="Arial"/>
               </a:rPr>
-              <a:t>Selected Monomers</a:t>
-            </a:r>
-            <a:endParaRPr b="0" lang="en-US" sz="1800" spc="-1" strike="noStrike">
-              <a:solidFill>
-                <a:srgbClr val="000000"/>
-              </a:solidFill>
-              <a:latin typeface="Arial"/>
-            </a:endParaRPr>
-          </a:p>
-        </p:txBody>
-      </p:sp>
-      <p:sp>
-        <p:nvSpPr>
-          <p:cNvPr id="21" name=""/>
+              <a:t>Proposed Monomers</a:t>
+            </a:r>
+            <a:endParaRPr b="1" lang="en-US" sz="1600" spc="-1" strike="noStrike">
+              <a:solidFill>
+                <a:srgbClr val="000000"/>
+              </a:solidFill>
+              <a:latin typeface="Arial"/>
+            </a:endParaRPr>
+          </a:p>
+        </p:txBody>
+      </p:sp>
+      <p:sp>
+        <p:nvSpPr>
+          <p:cNvPr id="26" name=""/>
           <p:cNvSpPr/>
           <p:nvPr/>
         </p:nvSpPr>
         <p:spPr>
           <a:xfrm flipH="1">
             <a:off x="6629400" y="914400"/>
-            <a:ext cx="1143000" cy="0"/>
+            <a:ext cx="1143000" cy="360"/>
           </a:xfrm>
           <a:prstGeom prst="line">
             <a:avLst/>
@@ -1440,20 +1989,21 @@
                 <a:srgbClr val="000000"/>
               </a:solidFill>
               <a:latin typeface="Arial"/>
-            </a:endParaRPr>
-          </a:p>
-        </p:txBody>
-      </p:sp>
-      <p:sp>
-        <p:nvSpPr>
-          <p:cNvPr id="22" name=""/>
+              <a:ea typeface="DejaVu Sans"/>
+            </a:endParaRPr>
+          </a:p>
+        </p:txBody>
+      </p:sp>
+      <p:sp>
+        <p:nvSpPr>
+          <p:cNvPr id="27" name=""/>
           <p:cNvSpPr/>
           <p:nvPr/>
         </p:nvSpPr>
         <p:spPr>
           <a:xfrm flipH="1">
             <a:off x="6638760" y="1454400"/>
-            <a:ext cx="1143000" cy="0"/>
+            <a:ext cx="1143000" cy="360"/>
           </a:xfrm>
           <a:prstGeom prst="line">
             <a:avLst/>
@@ -1482,20 +2032,21 @@
                 <a:srgbClr val="000000"/>
               </a:solidFill>
               <a:latin typeface="Arial"/>
-            </a:endParaRPr>
-          </a:p>
-        </p:txBody>
-      </p:sp>
-      <p:sp>
-        <p:nvSpPr>
-          <p:cNvPr id="23" name=""/>
+              <a:ea typeface="DejaVu Sans"/>
+            </a:endParaRPr>
+          </a:p>
+        </p:txBody>
+      </p:sp>
+      <p:sp>
+        <p:nvSpPr>
+          <p:cNvPr id="28" name=""/>
           <p:cNvSpPr/>
           <p:nvPr/>
         </p:nvSpPr>
         <p:spPr>
           <a:xfrm flipH="1">
             <a:off x="6648120" y="4370400"/>
-            <a:ext cx="1143000" cy="0"/>
+            <a:ext cx="1143000" cy="360"/>
           </a:xfrm>
           <a:prstGeom prst="line">
             <a:avLst/>
@@ -1524,6 +2075,191 @@
                 <a:srgbClr val="000000"/>
               </a:solidFill>
               <a:latin typeface="Arial"/>
+              <a:ea typeface="DejaVu Sans"/>
+            </a:endParaRPr>
+          </a:p>
+        </p:txBody>
+      </p:sp>
+      <p:sp>
+        <p:nvSpPr>
+          <p:cNvPr id="29" name=""/>
+          <p:cNvSpPr/>
+          <p:nvPr/>
+        </p:nvSpPr>
+        <p:spPr>
+          <a:xfrm flipH="1">
+            <a:off x="5715000" y="3429000"/>
+            <a:ext cx="2057400" cy="360"/>
+          </a:xfrm>
+          <a:prstGeom prst="line">
+            <a:avLst/>
+          </a:prstGeom>
+          <a:ln w="36720">
+            <a:solidFill>
+              <a:srgbClr val="ff0000"/>
+            </a:solidFill>
+            <a:round/>
+            <a:tailEnd len="med" type="triangle" w="med"/>
+          </a:ln>
+        </p:spPr>
+        <p:style>
+          <a:lnRef idx="0"/>
+          <a:fillRef idx="0"/>
+          <a:effectRef idx="0"/>
+          <a:fontRef idx="minor"/>
+        </p:style>
+        <p:txBody>
+          <a:bodyPr lIns="108360" rIns="108360" tIns="-63360" bIns="-63360" anchor="ctr">
+            <a:noAutofit/>
+          </a:bodyPr>
+          <a:p>
+            <a:endParaRPr b="0" lang="en-US" sz="1800" spc="-1" strike="noStrike">
+              <a:solidFill>
+                <a:srgbClr val="000000"/>
+              </a:solidFill>
+              <a:latin typeface="Arial"/>
+              <a:ea typeface="DejaVu Sans"/>
+            </a:endParaRPr>
+          </a:p>
+        </p:txBody>
+      </p:sp>
+      <p:sp>
+        <p:nvSpPr>
+          <p:cNvPr id="30" name=""/>
+          <p:cNvSpPr/>
+          <p:nvPr/>
+        </p:nvSpPr>
+        <p:spPr>
+          <a:xfrm>
+            <a:off x="7796520" y="2881800"/>
+            <a:ext cx="2033280" cy="1233000"/>
+          </a:xfrm>
+          <a:prstGeom prst="rect">
+            <a:avLst/>
+          </a:prstGeom>
+          <a:noFill/>
+          <a:ln w="0">
+            <a:noFill/>
+          </a:ln>
+        </p:spPr>
+        <p:style>
+          <a:lnRef idx="0"/>
+          <a:fillRef idx="0"/>
+          <a:effectRef idx="0"/>
+          <a:fontRef idx="minor"/>
+        </p:style>
+        <p:txBody>
+          <a:bodyPr lIns="90000" rIns="90000" tIns="45000" bIns="45000" anchor="t">
+            <a:noAutofit/>
+          </a:bodyPr>
+          <a:p>
+            <a:pPr>
+              <a:lnSpc>
+                <a:spcPct val="100000"/>
+              </a:lnSpc>
+            </a:pPr>
+            <a:r>
+              <a:rPr b="1" lang="en-US" sz="1600" spc="-1" strike="noStrike">
+                <a:solidFill>
+                  <a:srgbClr val="000000"/>
+                </a:solidFill>
+                <a:latin typeface="Arial"/>
+              </a:rPr>
+              <a:t>Append/prepend/ monomer to BILN sequence of given Chain</a:t>
+            </a:r>
+            <a:endParaRPr b="1" lang="en-US" sz="1600" spc="-1" strike="noStrike">
+              <a:solidFill>
+                <a:srgbClr val="000000"/>
+              </a:solidFill>
+              <a:latin typeface="Arial"/>
+            </a:endParaRPr>
+          </a:p>
+        </p:txBody>
+      </p:sp>
+      <p:sp>
+        <p:nvSpPr>
+          <p:cNvPr id="31" name=""/>
+          <p:cNvSpPr/>
+          <p:nvPr/>
+        </p:nvSpPr>
+        <p:spPr>
+          <a:xfrm flipH="1" flipV="1">
+            <a:off x="2743200" y="2743200"/>
+            <a:ext cx="5029200" cy="685800"/>
+          </a:xfrm>
+          <a:prstGeom prst="line">
+            <a:avLst/>
+          </a:prstGeom>
+          <a:ln w="36720">
+            <a:solidFill>
+              <a:srgbClr val="ff0000"/>
+            </a:solidFill>
+            <a:prstDash val="dash"/>
+            <a:round/>
+            <a:tailEnd len="med" type="triangle" w="med"/>
+          </a:ln>
+        </p:spPr>
+        <p:style>
+          <a:lnRef idx="0"/>
+          <a:fillRef idx="0"/>
+          <a:effectRef idx="0"/>
+          <a:fontRef idx="minor"/>
+        </p:style>
+        <p:txBody>
+          <a:bodyPr lIns="108360" rIns="108360" tIns="-63360" bIns="-63360" anchor="ctr">
+            <a:noAutofit/>
+          </a:bodyPr>
+          <a:p>
+            <a:endParaRPr b="0" lang="en-US" sz="1800" spc="-1" strike="noStrike">
+              <a:solidFill>
+                <a:srgbClr val="000000"/>
+              </a:solidFill>
+              <a:latin typeface="Arial"/>
+              <a:ea typeface="DejaVu Sans"/>
+            </a:endParaRPr>
+          </a:p>
+        </p:txBody>
+      </p:sp>
+      <p:sp>
+        <p:nvSpPr>
+          <p:cNvPr id="32" name=""/>
+          <p:cNvSpPr/>
+          <p:nvPr/>
+        </p:nvSpPr>
+        <p:spPr>
+          <a:xfrm flipH="1" flipV="1">
+            <a:off x="3657600" y="2743200"/>
+            <a:ext cx="4138920" cy="685800"/>
+          </a:xfrm>
+          <a:prstGeom prst="line">
+            <a:avLst/>
+          </a:prstGeom>
+          <a:ln w="36720">
+            <a:solidFill>
+              <a:srgbClr val="ff0000"/>
+            </a:solidFill>
+            <a:prstDash val="dash"/>
+            <a:round/>
+            <a:tailEnd len="med" type="triangle" w="med"/>
+          </a:ln>
+        </p:spPr>
+        <p:style>
+          <a:lnRef idx="0"/>
+          <a:fillRef idx="0"/>
+          <a:effectRef idx="0"/>
+          <a:fontRef idx="minor"/>
+        </p:style>
+        <p:txBody>
+          <a:bodyPr lIns="108360" rIns="108360" tIns="-63360" bIns="-63360" anchor="ctr">
+            <a:noAutofit/>
+          </a:bodyPr>
+          <a:p>
+            <a:endParaRPr b="0" lang="en-US" sz="1800" spc="-1" strike="noStrike">
+              <a:solidFill>
+                <a:srgbClr val="000000"/>
+              </a:solidFill>
+              <a:latin typeface="Arial"/>
+              <a:ea typeface="DejaVu Sans"/>
             </a:endParaRPr>
           </a:p>
         </p:txBody>
@@ -1560,7 +2296,7 @@
       </p:grpSpPr>
       <p:pic>
         <p:nvPicPr>
-          <p:cNvPr id="24" name="" descr=""/>
+          <p:cNvPr id="33" name="" descr=""/>
           <p:cNvPicPr/>
           <p:nvPr/>
         </p:nvPicPr>
@@ -1571,7 +2307,7 @@
         <p:spPr>
           <a:xfrm>
             <a:off x="565200" y="819000"/>
-            <a:ext cx="6942240" cy="3839400"/>
+            <a:ext cx="6941880" cy="3839040"/>
           </a:xfrm>
           <a:prstGeom prst="rect">
             <a:avLst/>
@@ -1583,14 +2319,14 @@
       </p:pic>
       <p:sp>
         <p:nvSpPr>
-          <p:cNvPr id="25" name=""/>
+          <p:cNvPr id="34" name=""/>
           <p:cNvSpPr/>
           <p:nvPr/>
         </p:nvSpPr>
         <p:spPr>
           <a:xfrm flipH="1">
             <a:off x="7250760" y="2462400"/>
-            <a:ext cx="750240" cy="0"/>
+            <a:ext cx="750240" cy="360"/>
           </a:xfrm>
           <a:prstGeom prst="line">
             <a:avLst/>
@@ -1619,20 +2355,21 @@
                 <a:srgbClr val="000000"/>
               </a:solidFill>
               <a:latin typeface="Arial"/>
-            </a:endParaRPr>
-          </a:p>
-        </p:txBody>
-      </p:sp>
-      <p:sp>
-        <p:nvSpPr>
-          <p:cNvPr id="26" name=""/>
+              <a:ea typeface="DejaVu Sans"/>
+            </a:endParaRPr>
+          </a:p>
+        </p:txBody>
+      </p:sp>
+      <p:sp>
+        <p:nvSpPr>
+          <p:cNvPr id="35" name=""/>
           <p:cNvSpPr/>
           <p:nvPr/>
         </p:nvSpPr>
         <p:spPr>
           <a:xfrm>
             <a:off x="5257800" y="685800"/>
-            <a:ext cx="2286000" cy="4114800"/>
+            <a:ext cx="2285640" cy="4114440"/>
           </a:xfrm>
           <a:prstGeom prst="rect">
             <a:avLst/>
@@ -1656,25 +2393,31 @@
             <a:noAutofit/>
           </a:bodyPr>
           <a:p>
-            <a:endParaRPr b="0" lang="en-US" sz="1800" spc="-1" strike="noStrike">
-              <a:solidFill>
-                <a:srgbClr val="000000"/>
-              </a:solidFill>
-              <a:latin typeface="Arial"/>
-            </a:endParaRPr>
-          </a:p>
-        </p:txBody>
-      </p:sp>
-      <p:sp>
-        <p:nvSpPr>
-          <p:cNvPr id="27" name=""/>
-          <p:cNvSpPr txBox="1"/>
+            <a:pPr>
+              <a:lnSpc>
+                <a:spcPct val="100000"/>
+              </a:lnSpc>
+            </a:pPr>
+            <a:endParaRPr b="0" lang="en-US" sz="1800" spc="-1" strike="noStrike">
+              <a:solidFill>
+                <a:srgbClr val="000000"/>
+              </a:solidFill>
+              <a:latin typeface="Arial"/>
+              <a:ea typeface="DejaVu Sans"/>
+            </a:endParaRPr>
+          </a:p>
+        </p:txBody>
+      </p:sp>
+      <p:sp>
+        <p:nvSpPr>
+          <p:cNvPr id="36" name=""/>
+          <p:cNvSpPr/>
           <p:nvPr/>
         </p:nvSpPr>
         <p:spPr>
           <a:xfrm>
             <a:off x="8012520" y="2269800"/>
-            <a:ext cx="1207800" cy="602280"/>
+            <a:ext cx="1207440" cy="601920"/>
           </a:xfrm>
           <a:prstGeom prst="rect">
             <a:avLst/>
@@ -1684,11 +2427,22 @@
             <a:noFill/>
           </a:ln>
         </p:spPr>
+        <p:style>
+          <a:lnRef idx="0"/>
+          <a:fillRef idx="0"/>
+          <a:effectRef idx="0"/>
+          <a:fontRef idx="minor"/>
+        </p:style>
         <p:txBody>
           <a:bodyPr lIns="90000" rIns="90000" tIns="45000" bIns="45000" anchor="t">
             <a:noAutofit/>
           </a:bodyPr>
           <a:p>
+            <a:pPr>
+              <a:lnSpc>
+                <a:spcPct val="100000"/>
+              </a:lnSpc>
+            </a:pPr>
             <a:r>
               <a:rPr b="0" lang="en-US" sz="1800" spc="-1" strike="noStrike">
                 <a:solidFill>
@@ -1706,6 +2460,11 @@
             </a:endParaRPr>
           </a:p>
           <a:p>
+            <a:pPr>
+              <a:lnSpc>
+                <a:spcPct val="100000"/>
+              </a:lnSpc>
+            </a:pPr>
             <a:r>
               <a:rPr b="0" lang="en-US" sz="1800" spc="-1" strike="noStrike">
                 <a:solidFill>
@@ -1726,7 +2485,7 @@
       </p:sp>
       <p:sp>
         <p:nvSpPr>
-          <p:cNvPr id="28" name=""/>
+          <p:cNvPr id="37" name=""/>
           <p:cNvSpPr/>
           <p:nvPr/>
         </p:nvSpPr>
@@ -1762,20 +2521,21 @@
                 <a:srgbClr val="000000"/>
               </a:solidFill>
               <a:latin typeface="Arial"/>
-            </a:endParaRPr>
-          </a:p>
-        </p:txBody>
-      </p:sp>
-      <p:sp>
-        <p:nvSpPr>
-          <p:cNvPr id="29" name=""/>
-          <p:cNvSpPr txBox="1"/>
+              <a:ea typeface="DejaVu Sans"/>
+            </a:endParaRPr>
+          </a:p>
+        </p:txBody>
+      </p:sp>
+      <p:sp>
+        <p:nvSpPr>
+          <p:cNvPr id="38" name=""/>
+          <p:cNvSpPr/>
           <p:nvPr/>
         </p:nvSpPr>
         <p:spPr>
           <a:xfrm>
             <a:off x="560880" y="361800"/>
-            <a:ext cx="1739880" cy="346320"/>
+            <a:ext cx="1739520" cy="345960"/>
           </a:xfrm>
           <a:prstGeom prst="rect">
             <a:avLst/>
@@ -1785,11 +2545,22 @@
             <a:noFill/>
           </a:ln>
         </p:spPr>
+        <p:style>
+          <a:lnRef idx="0"/>
+          <a:fillRef idx="0"/>
+          <a:effectRef idx="0"/>
+          <a:fontRef idx="minor"/>
+        </p:style>
         <p:txBody>
           <a:bodyPr lIns="90000" rIns="90000" tIns="45000" bIns="45000" anchor="t">
             <a:noAutofit/>
           </a:bodyPr>
           <a:p>
+            <a:pPr>
+              <a:lnSpc>
+                <a:spcPct val="100000"/>
+              </a:lnSpc>
+            </a:pPr>
             <a:r>
               <a:rPr b="0" lang="en-US" sz="1800" spc="-1" strike="noStrike">
                 <a:solidFill>
@@ -1810,7 +2581,7 @@
       </p:sp>
       <p:sp>
         <p:nvSpPr>
-          <p:cNvPr id="30" name=""/>
+          <p:cNvPr id="39" name=""/>
           <p:cNvSpPr/>
           <p:nvPr/>
         </p:nvSpPr>
@@ -1846,20 +2617,21 @@
                 <a:srgbClr val="000000"/>
               </a:solidFill>
               <a:latin typeface="Arial"/>
-            </a:endParaRPr>
-          </a:p>
-        </p:txBody>
-      </p:sp>
-      <p:sp>
-        <p:nvSpPr>
-          <p:cNvPr id="31" name=""/>
-          <p:cNvSpPr txBox="1"/>
+              <a:ea typeface="DejaVu Sans"/>
+            </a:endParaRPr>
+          </a:p>
+        </p:txBody>
+      </p:sp>
+      <p:sp>
+        <p:nvSpPr>
+          <p:cNvPr id="40" name=""/>
+          <p:cNvSpPr/>
           <p:nvPr/>
         </p:nvSpPr>
         <p:spPr>
           <a:xfrm>
             <a:off x="2721240" y="361800"/>
-            <a:ext cx="1639080" cy="346320"/>
+            <a:ext cx="1638720" cy="345960"/>
           </a:xfrm>
           <a:prstGeom prst="rect">
             <a:avLst/>
@@ -1869,11 +2641,22 @@
             <a:noFill/>
           </a:ln>
         </p:spPr>
+        <p:style>
+          <a:lnRef idx="0"/>
+          <a:fillRef idx="0"/>
+          <a:effectRef idx="0"/>
+          <a:fontRef idx="minor"/>
+        </p:style>
         <p:txBody>
           <a:bodyPr lIns="90000" rIns="90000" tIns="45000" bIns="45000" anchor="t">
             <a:noAutofit/>
           </a:bodyPr>
           <a:p>
+            <a:pPr>
+              <a:lnSpc>
+                <a:spcPct val="100000"/>
+              </a:lnSpc>
+            </a:pPr>
             <a:r>
               <a:rPr b="0" lang="en-US" sz="1800" spc="-1" strike="noStrike">
                 <a:solidFill>
@@ -1894,14 +2677,14 @@
       </p:sp>
       <p:sp>
         <p:nvSpPr>
-          <p:cNvPr id="32" name=""/>
-          <p:cNvSpPr txBox="1"/>
+          <p:cNvPr id="41" name=""/>
+          <p:cNvSpPr/>
           <p:nvPr/>
         </p:nvSpPr>
         <p:spPr>
           <a:xfrm>
             <a:off x="885600" y="4789800"/>
-            <a:ext cx="1447200" cy="346320"/>
+            <a:ext cx="1446840" cy="345960"/>
           </a:xfrm>
           <a:prstGeom prst="rect">
             <a:avLst/>
@@ -1911,11 +2694,22 @@
             <a:noFill/>
           </a:ln>
         </p:spPr>
+        <p:style>
+          <a:lnRef idx="0"/>
+          <a:fillRef idx="0"/>
+          <a:effectRef idx="0"/>
+          <a:fontRef idx="minor"/>
+        </p:style>
         <p:txBody>
           <a:bodyPr lIns="90000" rIns="90000" tIns="45000" bIns="45000" anchor="t">
             <a:noAutofit/>
           </a:bodyPr>
           <a:p>
+            <a:pPr>
+              <a:lnSpc>
+                <a:spcPct val="100000"/>
+              </a:lnSpc>
+            </a:pPr>
             <a:r>
               <a:rPr b="0" lang="en-US" sz="1800" spc="-1" strike="noStrike">
                 <a:solidFill>
@@ -1936,14 +2730,14 @@
       </p:sp>
       <p:sp>
         <p:nvSpPr>
-          <p:cNvPr id="33" name=""/>
-          <p:cNvSpPr txBox="1"/>
+          <p:cNvPr id="42" name=""/>
+          <p:cNvSpPr/>
           <p:nvPr/>
         </p:nvSpPr>
         <p:spPr>
           <a:xfrm>
             <a:off x="3225600" y="4789800"/>
-            <a:ext cx="1447200" cy="346320"/>
+            <a:ext cx="1446840" cy="345960"/>
           </a:xfrm>
           <a:prstGeom prst="rect">
             <a:avLst/>
@@ -1953,11 +2747,22 @@
             <a:noFill/>
           </a:ln>
         </p:spPr>
+        <p:style>
+          <a:lnRef idx="0"/>
+          <a:fillRef idx="0"/>
+          <a:effectRef idx="0"/>
+          <a:fontRef idx="minor"/>
+        </p:style>
         <p:txBody>
           <a:bodyPr lIns="90000" rIns="90000" tIns="45000" bIns="45000" anchor="t">
             <a:noAutofit/>
           </a:bodyPr>
           <a:p>
+            <a:pPr>
+              <a:lnSpc>
+                <a:spcPct val="100000"/>
+              </a:lnSpc>
+            </a:pPr>
             <a:r>
               <a:rPr b="0" lang="en-US" sz="1800" spc="-1" strike="noStrike">
                 <a:solidFill>
@@ -1978,14 +2783,14 @@
       </p:sp>
       <p:sp>
         <p:nvSpPr>
-          <p:cNvPr id="34" name=""/>
+          <p:cNvPr id="43" name=""/>
           <p:cNvSpPr/>
           <p:nvPr/>
         </p:nvSpPr>
         <p:spPr>
           <a:xfrm>
             <a:off x="613800" y="937800"/>
-            <a:ext cx="4487400" cy="1035000"/>
+            <a:ext cx="4487040" cy="1034640"/>
           </a:xfrm>
           <a:prstGeom prst="rect">
             <a:avLst/>
@@ -2009,25 +2814,31 @@
             <a:noAutofit/>
           </a:bodyPr>
           <a:p>
-            <a:endParaRPr b="0" lang="en-US" sz="1800" spc="-1" strike="noStrike">
-              <a:solidFill>
-                <a:srgbClr val="000000"/>
-              </a:solidFill>
-              <a:latin typeface="Arial"/>
-            </a:endParaRPr>
-          </a:p>
-        </p:txBody>
-      </p:sp>
-      <p:sp>
-        <p:nvSpPr>
-          <p:cNvPr id="35" name=""/>
+            <a:pPr>
+              <a:lnSpc>
+                <a:spcPct val="100000"/>
+              </a:lnSpc>
+            </a:pPr>
+            <a:endParaRPr b="0" lang="en-US" sz="1800" spc="-1" strike="noStrike">
+              <a:solidFill>
+                <a:srgbClr val="000000"/>
+              </a:solidFill>
+              <a:latin typeface="Arial"/>
+              <a:ea typeface="DejaVu Sans"/>
+            </a:endParaRPr>
+          </a:p>
+        </p:txBody>
+      </p:sp>
+      <p:sp>
+        <p:nvSpPr>
+          <p:cNvPr id="44" name=""/>
           <p:cNvSpPr/>
           <p:nvPr/>
         </p:nvSpPr>
         <p:spPr>
           <a:xfrm>
             <a:off x="613800" y="2017800"/>
-            <a:ext cx="4487400" cy="725400"/>
+            <a:ext cx="4487040" cy="725040"/>
           </a:xfrm>
           <a:prstGeom prst="rect">
             <a:avLst/>
@@ -2051,25 +2862,31 @@
             <a:noAutofit/>
           </a:bodyPr>
           <a:p>
-            <a:endParaRPr b="0" lang="en-US" sz="1800" spc="-1" strike="noStrike">
-              <a:solidFill>
-                <a:srgbClr val="000000"/>
-              </a:solidFill>
-              <a:latin typeface="Arial"/>
-            </a:endParaRPr>
-          </a:p>
-        </p:txBody>
-      </p:sp>
-      <p:sp>
-        <p:nvSpPr>
-          <p:cNvPr id="36" name=""/>
+            <a:pPr>
+              <a:lnSpc>
+                <a:spcPct val="100000"/>
+              </a:lnSpc>
+            </a:pPr>
+            <a:endParaRPr b="0" lang="en-US" sz="1800" spc="-1" strike="noStrike">
+              <a:solidFill>
+                <a:srgbClr val="000000"/>
+              </a:solidFill>
+              <a:latin typeface="Arial"/>
+              <a:ea typeface="DejaVu Sans"/>
+            </a:endParaRPr>
+          </a:p>
+        </p:txBody>
+      </p:sp>
+      <p:sp>
+        <p:nvSpPr>
+          <p:cNvPr id="45" name=""/>
           <p:cNvSpPr/>
           <p:nvPr/>
         </p:nvSpPr>
         <p:spPr>
           <a:xfrm>
             <a:off x="649800" y="2815200"/>
-            <a:ext cx="2129400" cy="1843200"/>
+            <a:ext cx="2129040" cy="1842840"/>
           </a:xfrm>
           <a:prstGeom prst="rect">
             <a:avLst/>
@@ -2093,25 +2910,31 @@
             <a:noAutofit/>
           </a:bodyPr>
           <a:p>
-            <a:endParaRPr b="0" lang="en-US" sz="1800" spc="-1" strike="noStrike">
-              <a:solidFill>
-                <a:srgbClr val="000000"/>
-              </a:solidFill>
-              <a:latin typeface="Arial"/>
-            </a:endParaRPr>
-          </a:p>
-        </p:txBody>
-      </p:sp>
-      <p:sp>
-        <p:nvSpPr>
-          <p:cNvPr id="37" name=""/>
+            <a:pPr>
+              <a:lnSpc>
+                <a:spcPct val="100000"/>
+              </a:lnSpc>
+            </a:pPr>
+            <a:endParaRPr b="0" lang="en-US" sz="1800" spc="-1" strike="noStrike">
+              <a:solidFill>
+                <a:srgbClr val="000000"/>
+              </a:solidFill>
+              <a:latin typeface="Arial"/>
+              <a:ea typeface="DejaVu Sans"/>
+            </a:endParaRPr>
+          </a:p>
+        </p:txBody>
+      </p:sp>
+      <p:sp>
+        <p:nvSpPr>
+          <p:cNvPr id="46" name=""/>
           <p:cNvSpPr/>
           <p:nvPr/>
         </p:nvSpPr>
         <p:spPr>
           <a:xfrm>
             <a:off x="2863800" y="2815200"/>
-            <a:ext cx="2232000" cy="1843200"/>
+            <a:ext cx="2231640" cy="1842840"/>
           </a:xfrm>
           <a:prstGeom prst="rect">
             <a:avLst/>
@@ -2135,25 +2958,31 @@
             <a:noAutofit/>
           </a:bodyPr>
           <a:p>
-            <a:endParaRPr b="0" lang="en-US" sz="1800" spc="-1" strike="noStrike">
-              <a:solidFill>
-                <a:srgbClr val="000000"/>
-              </a:solidFill>
-              <a:latin typeface="Arial"/>
-            </a:endParaRPr>
-          </a:p>
-        </p:txBody>
-      </p:sp>
-      <p:sp>
-        <p:nvSpPr>
-          <p:cNvPr id="38" name=""/>
+            <a:pPr>
+              <a:lnSpc>
+                <a:spcPct val="100000"/>
+              </a:lnSpc>
+            </a:pPr>
+            <a:endParaRPr b="0" lang="en-US" sz="1800" spc="-1" strike="noStrike">
+              <a:solidFill>
+                <a:srgbClr val="000000"/>
+              </a:solidFill>
+              <a:latin typeface="Arial"/>
+              <a:ea typeface="DejaVu Sans"/>
+            </a:endParaRPr>
+          </a:p>
+        </p:txBody>
+      </p:sp>
+      <p:sp>
+        <p:nvSpPr>
+          <p:cNvPr id="47" name=""/>
           <p:cNvSpPr/>
           <p:nvPr/>
         </p:nvSpPr>
         <p:spPr>
           <a:xfrm flipV="1">
             <a:off x="1708200" y="4379400"/>
-            <a:ext cx="0" cy="473400"/>
+            <a:ext cx="360" cy="473400"/>
           </a:xfrm>
           <a:prstGeom prst="line">
             <a:avLst/>
@@ -2182,20 +3011,21 @@
                 <a:srgbClr val="000000"/>
               </a:solidFill>
               <a:latin typeface="Arial"/>
-            </a:endParaRPr>
-          </a:p>
-        </p:txBody>
-      </p:sp>
-      <p:sp>
-        <p:nvSpPr>
-          <p:cNvPr id="39" name=""/>
+              <a:ea typeface="DejaVu Sans"/>
+            </a:endParaRPr>
+          </a:p>
+        </p:txBody>
+      </p:sp>
+      <p:sp>
+        <p:nvSpPr>
+          <p:cNvPr id="48" name=""/>
           <p:cNvSpPr/>
           <p:nvPr/>
         </p:nvSpPr>
         <p:spPr>
           <a:xfrm flipV="1">
             <a:off x="3796200" y="4388760"/>
-            <a:ext cx="0" cy="473400"/>
+            <a:ext cx="360" cy="473400"/>
           </a:xfrm>
           <a:prstGeom prst="line">
             <a:avLst/>
@@ -2224,6 +3054,7 @@
                 <a:srgbClr val="000000"/>
               </a:solidFill>
               <a:latin typeface="Arial"/>
+              <a:ea typeface="DejaVu Sans"/>
             </a:endParaRPr>
           </a:p>
         </p:txBody>
@@ -2345,4 +3176,110 @@
     </a:fmtScheme>
   </a:themeElements>
 </a:theme>
+</file>
+
+<file path=ppt/theme/theme2.xml><?xml version="1.0" encoding="utf-8"?>
+<a:theme xmlns:a="http://schemas.openxmlformats.org/drawingml/2006/main" xmlns:r="http://schemas.openxmlformats.org/officeDocument/2006/relationships" name="Office Theme">
+  <a:themeElements>
+    <a:clrScheme name="LibreOffice">
+      <a:dk1>
+        <a:srgbClr val="000000"/>
+      </a:dk1>
+      <a:lt1>
+        <a:srgbClr val="ffffff"/>
+      </a:lt1>
+      <a:dk2>
+        <a:srgbClr val="000000"/>
+      </a:dk2>
+      <a:lt2>
+        <a:srgbClr val="ffffff"/>
+      </a:lt2>
+      <a:accent1>
+        <a:srgbClr val="18a303"/>
+      </a:accent1>
+      <a:accent2>
+        <a:srgbClr val="0369a3"/>
+      </a:accent2>
+      <a:accent3>
+        <a:srgbClr val="a33e03"/>
+      </a:accent3>
+      <a:accent4>
+        <a:srgbClr val="8e03a3"/>
+      </a:accent4>
+      <a:accent5>
+        <a:srgbClr val="c99c00"/>
+      </a:accent5>
+      <a:accent6>
+        <a:srgbClr val="c9211e"/>
+      </a:accent6>
+      <a:hlink>
+        <a:srgbClr val="0000ee"/>
+      </a:hlink>
+      <a:folHlink>
+        <a:srgbClr val="551a8b"/>
+      </a:folHlink>
+    </a:clrScheme>
+    <a:fontScheme name="Office">
+      <a:majorFont>
+        <a:latin typeface="Arial" pitchFamily="0" charset="1"/>
+        <a:ea typeface="DejaVu Sans" pitchFamily="0" charset="1"/>
+        <a:cs typeface="DejaVu Sans" pitchFamily="0" charset="1"/>
+      </a:majorFont>
+      <a:minorFont>
+        <a:latin typeface="Arial" pitchFamily="0" charset="1"/>
+        <a:ea typeface="DejaVu Sans" pitchFamily="0" charset="1"/>
+        <a:cs typeface="DejaVu Sans" pitchFamily="0" charset="1"/>
+      </a:minorFont>
+    </a:fontScheme>
+    <a:fmtScheme>
+      <a:fillStyleLst>
+        <a:solidFill>
+          <a:schemeClr val="phClr"/>
+        </a:solidFill>
+        <a:solidFill>
+          <a:schemeClr val="phClr"/>
+        </a:solidFill>
+        <a:solidFill>
+          <a:schemeClr val="phClr"/>
+        </a:solidFill>
+      </a:fillStyleLst>
+      <a:lnStyleLst>
+        <a:ln w="6350" cap="flat" cmpd="sng" algn="ctr">
+          <a:prstDash val="solid"/>
+          <a:miter/>
+        </a:ln>
+        <a:ln w="6350" cap="flat" cmpd="sng" algn="ctr">
+          <a:prstDash val="solid"/>
+          <a:miter/>
+        </a:ln>
+        <a:ln w="6350" cap="flat" cmpd="sng" algn="ctr">
+          <a:prstDash val="solid"/>
+          <a:miter/>
+        </a:ln>
+      </a:lnStyleLst>
+      <a:effectStyleLst>
+        <a:effectStyle>
+          <a:effectLst/>
+        </a:effectStyle>
+        <a:effectStyle>
+          <a:effectLst/>
+        </a:effectStyle>
+        <a:effectStyle>
+          <a:effectLst/>
+        </a:effectStyle>
+      </a:effectStyleLst>
+      <a:bgFillStyleLst>
+        <a:solidFill>
+          <a:schemeClr val="phClr"/>
+        </a:solidFill>
+        <a:solidFill>
+          <a:schemeClr val="phClr"/>
+        </a:solidFill>
+        <a:solidFill>
+          <a:schemeClr val="phClr"/>
+        </a:solidFill>
+      </a:bgFillStyleLst>
+    </a:fmtScheme>
+  </a:themeElements>
+</a:theme>
 </file>
</xml_diff>

<commit_message>
some use cases in doc
</commit_message>
<xml_diff>
--- a/doc/images/Monomer.pptx
+++ b/doc/images/Monomer.pptx
@@ -9,6 +9,10 @@
     <p:sldId id="256" r:id="rId4"/>
     <p:sldId id="257" r:id="rId5"/>
     <p:sldId id="258" r:id="rId6"/>
+    <p:sldId id="259" r:id="rId7"/>
+    <p:sldId id="260" r:id="rId8"/>
+    <p:sldId id="261" r:id="rId9"/>
+    <p:sldId id="262" r:id="rId10"/>
   </p:sldIdLst>
   <p:sldSz cx="10080625" cy="5670550"/>
   <p:notesSz cx="7772400" cy="10058400"/>
@@ -45,7 +49,7 @@
         <p:spPr>
           <a:xfrm>
             <a:off x="504000" y="226080"/>
-            <a:ext cx="9070920" cy="945720"/>
+            <a:ext cx="9070560" cy="945360"/>
           </a:xfrm>
           <a:prstGeom prst="rect">
             <a:avLst/>
@@ -85,7 +89,7 @@
         <p:spPr>
           <a:xfrm>
             <a:off x="504000" y="1326600"/>
-            <a:ext cx="9071640" cy="3288240"/>
+            <a:ext cx="9071280" cy="3287880"/>
           </a:xfrm>
           <a:prstGeom prst="rect">
             <a:avLst/>
@@ -149,7 +153,7 @@
         <p:txBody>
           <a:bodyPr/>
           <a:p>
-            <a:fld id="{72BC6089-C6A6-47A9-9EFD-A3D76CE093A7}" type="slidenum">
+            <a:fld id="{DF716571-327F-48C2-B95D-1D326D660D04}" type="slidenum">
               <a:t>&lt;#&gt;</a:t>
             </a:fld>
           </a:p>
@@ -211,7 +215,7 @@
         <p:spPr>
           <a:xfrm>
             <a:off x="504000" y="226080"/>
-            <a:ext cx="9070920" cy="945720"/>
+            <a:ext cx="9070560" cy="945360"/>
           </a:xfrm>
           <a:prstGeom prst="rect">
             <a:avLst/>
@@ -251,7 +255,7 @@
         <p:spPr>
           <a:xfrm>
             <a:off x="504000" y="1326600"/>
-            <a:ext cx="9071640" cy="3288240"/>
+            <a:ext cx="9071280" cy="3287880"/>
           </a:xfrm>
           <a:prstGeom prst="rect">
             <a:avLst/>
@@ -312,7 +316,7 @@
         <p:txBody>
           <a:bodyPr/>
           <a:p>
-            <a:fld id="{20670438-1563-46AE-8A13-A8A306ADB9DC}" type="slidenum">
+            <a:fld id="{1183F159-E470-42C5-9ACF-1A9B3C3AEC07}" type="slidenum">
               <a:t>&lt;#&gt;</a:t>
             </a:fld>
           </a:p>
@@ -374,7 +378,7 @@
         <p:spPr>
           <a:xfrm>
             <a:off x="504000" y="226080"/>
-            <a:ext cx="9070920" cy="945720"/>
+            <a:ext cx="9070560" cy="945360"/>
           </a:xfrm>
           <a:prstGeom prst="rect">
             <a:avLst/>
@@ -399,7 +403,34 @@
                 </a:solidFill>
                 <a:latin typeface="Arial"/>
               </a:rPr>
-              <a:t>Click to edit the title text format</a:t>
+              <a:t>Click to </a:t>
+            </a:r>
+            <a:r>
+              <a:rPr b="0" lang="en-US" sz="1800" spc="-1" strike="noStrike">
+                <a:solidFill>
+                  <a:srgbClr val="000000"/>
+                </a:solidFill>
+                <a:latin typeface="Arial"/>
+              </a:rPr>
+              <a:t>edit the </a:t>
+            </a:r>
+            <a:r>
+              <a:rPr b="0" lang="en-US" sz="1800" spc="-1" strike="noStrike">
+                <a:solidFill>
+                  <a:srgbClr val="000000"/>
+                </a:solidFill>
+                <a:latin typeface="Arial"/>
+              </a:rPr>
+              <a:t>title text </a:t>
+            </a:r>
+            <a:r>
+              <a:rPr b="0" lang="en-US" sz="1800" spc="-1" strike="noStrike">
+                <a:solidFill>
+                  <a:srgbClr val="000000"/>
+                </a:solidFill>
+                <a:latin typeface="Arial"/>
+              </a:rPr>
+              <a:t>format</a:t>
             </a:r>
             <a:endParaRPr b="0" lang="en-US" sz="1800" spc="-1" strike="noStrike">
               <a:solidFill>
@@ -423,7 +454,7 @@
         <p:spPr>
           <a:xfrm>
             <a:off x="504000" y="1326600"/>
-            <a:ext cx="9071640" cy="3288240"/>
+            <a:ext cx="9071280" cy="3287880"/>
           </a:xfrm>
           <a:prstGeom prst="rect">
             <a:avLst/>
@@ -648,7 +679,7 @@
         <p:spPr>
           <a:xfrm>
             <a:off x="3447360" y="5165280"/>
-            <a:ext cx="3194280" cy="389880"/>
+            <a:ext cx="3193920" cy="389520"/>
           </a:xfrm>
           <a:prstGeom prst="rect">
             <a:avLst/>
@@ -720,7 +751,7 @@
         <p:spPr>
           <a:xfrm>
             <a:off x="7227360" y="5165280"/>
-            <a:ext cx="2347560" cy="389880"/>
+            <a:ext cx="2347200" cy="389520"/>
           </a:xfrm>
           <a:prstGeom prst="rect">
             <a:avLst/>
@@ -761,7 +792,7 @@
                 <a:tab algn="l" pos="0"/>
               </a:tabLst>
             </a:pPr>
-            <a:fld id="{7B34BA5A-05C0-4FB0-AD67-9C72D30C1386}" type="slidenum">
+            <a:fld id="{5E5E2983-AAA3-4197-808E-39DCCFA6CC5E}" type="slidenum">
               <a:rPr b="0" lang="en-US" sz="1400" spc="-1" strike="noStrike">
                 <a:solidFill>
                   <a:srgbClr val="000000"/>
@@ -792,7 +823,7 @@
         <p:spPr>
           <a:xfrm>
             <a:off x="504000" y="5165280"/>
-            <a:ext cx="2347560" cy="389880"/>
+            <a:ext cx="2347200" cy="389520"/>
           </a:xfrm>
           <a:prstGeom prst="rect">
             <a:avLst/>
@@ -878,7 +909,7 @@
         <p:spPr>
           <a:xfrm>
             <a:off x="504000" y="226080"/>
-            <a:ext cx="9070920" cy="945720"/>
+            <a:ext cx="9070560" cy="945360"/>
           </a:xfrm>
           <a:prstGeom prst="rect">
             <a:avLst/>
@@ -903,16 +934,7 @@
                 </a:solidFill>
                 <a:latin typeface="Arial"/>
               </a:rPr>
-              <a:t>Click to edit the </a:t>
-            </a:r>
-            <a:r>
-              <a:rPr b="0" lang="en-US" sz="1800" spc="-1" strike="noStrike">
-                <a:solidFill>
-                  <a:srgbClr val="000000"/>
-                </a:solidFill>
-                <a:latin typeface="Arial"/>
-              </a:rPr>
-              <a:t>title text format</a:t>
+              <a:t>Click to edit the title text format</a:t>
             </a:r>
             <a:endParaRPr b="0" lang="en-US" sz="1800" spc="-1" strike="noStrike">
               <a:solidFill>
@@ -936,7 +958,7 @@
         <p:spPr>
           <a:xfrm>
             <a:off x="3447360" y="5165280"/>
-            <a:ext cx="3194280" cy="389880"/>
+            <a:ext cx="3193920" cy="389520"/>
           </a:xfrm>
           <a:prstGeom prst="rect">
             <a:avLst/>
@@ -1008,7 +1030,7 @@
         <p:spPr>
           <a:xfrm>
             <a:off x="7227360" y="5165280"/>
-            <a:ext cx="2347560" cy="389880"/>
+            <a:ext cx="2347200" cy="389520"/>
           </a:xfrm>
           <a:prstGeom prst="rect">
             <a:avLst/>
@@ -1049,7 +1071,7 @@
                 <a:tab algn="l" pos="0"/>
               </a:tabLst>
             </a:pPr>
-            <a:fld id="{7CC32A0D-7994-499D-B7B1-BF6907ED703B}" type="slidenum">
+            <a:fld id="{83E5976B-2EF1-4195-A6E1-87C39EEEF9CC}" type="slidenum">
               <a:rPr b="0" lang="en-US" sz="1400" spc="-1" strike="noStrike">
                 <a:solidFill>
                   <a:srgbClr val="000000"/>
@@ -1080,7 +1102,7 @@
         <p:spPr>
           <a:xfrm>
             <a:off x="504000" y="5165280"/>
-            <a:ext cx="2347560" cy="389880"/>
+            <a:ext cx="2347200" cy="389520"/>
           </a:xfrm>
           <a:prstGeom prst="rect">
             <a:avLst/>
@@ -1391,7 +1413,7 @@
         <p:spPr>
           <a:xfrm>
             <a:off x="3648600" y="1162440"/>
-            <a:ext cx="2522880" cy="3637440"/>
+            <a:ext cx="2522520" cy="3637080"/>
           </a:xfrm>
           <a:prstGeom prst="rect">
             <a:avLst/>
@@ -1453,7 +1475,7 @@
         <p:spPr>
           <a:xfrm>
             <a:off x="6955200" y="3742200"/>
-            <a:ext cx="1777320" cy="345600"/>
+            <a:ext cx="1776960" cy="345240"/>
           </a:xfrm>
           <a:prstGeom prst="rect">
             <a:avLst/>
@@ -1550,7 +1572,7 @@
         <p:spPr>
           <a:xfrm>
             <a:off x="6955560" y="4066200"/>
-            <a:ext cx="1321560" cy="345600"/>
+            <a:ext cx="1321200" cy="345240"/>
           </a:xfrm>
           <a:prstGeom prst="rect">
             <a:avLst/>
@@ -1647,7 +1669,7 @@
         <p:spPr>
           <a:xfrm>
             <a:off x="6955920" y="4354200"/>
-            <a:ext cx="2197800" cy="345600"/>
+            <a:ext cx="2197440" cy="345240"/>
           </a:xfrm>
           <a:prstGeom prst="rect">
             <a:avLst/>
@@ -1701,7 +1723,7 @@
         <p:spPr>
           <a:xfrm>
             <a:off x="5871600" y="1143000"/>
-            <a:ext cx="456480" cy="2513880"/>
+            <a:ext cx="456120" cy="2513520"/>
           </a:xfrm>
           <a:prstGeom prst="rect">
             <a:avLst/>
@@ -1782,7 +1804,7 @@
         <p:spPr>
           <a:xfrm>
             <a:off x="1371600" y="228600"/>
-            <a:ext cx="5757480" cy="5066640"/>
+            <a:ext cx="5757120" cy="5066280"/>
           </a:xfrm>
           <a:prstGeom prst="rect">
             <a:avLst/>
@@ -1801,7 +1823,7 @@
         <p:spPr>
           <a:xfrm>
             <a:off x="7795800" y="685800"/>
-            <a:ext cx="1347840" cy="345960"/>
+            <a:ext cx="1347480" cy="345600"/>
           </a:xfrm>
           <a:prstGeom prst="rect">
             <a:avLst/>
@@ -1833,10 +1855,11 @@
                   <a:srgbClr val="000000"/>
                 </a:solidFill>
                 <a:latin typeface="Arial"/>
+                <a:ea typeface="DejaVu Sans"/>
               </a:rPr>
               <a:t>Text search</a:t>
             </a:r>
-            <a:endParaRPr b="1" lang="en-US" sz="1600" spc="-1" strike="noStrike">
+            <a:endParaRPr b="0" lang="en-US" sz="1600" spc="-1" strike="noStrike">
               <a:solidFill>
                 <a:srgbClr val="000000"/>
               </a:solidFill>
@@ -1854,7 +1877,7 @@
         <p:spPr>
           <a:xfrm>
             <a:off x="7796160" y="1297800"/>
-            <a:ext cx="1727280" cy="345960"/>
+            <a:ext cx="1726920" cy="345600"/>
           </a:xfrm>
           <a:prstGeom prst="rect">
             <a:avLst/>
@@ -1886,10 +1909,11 @@
                   <a:srgbClr val="000000"/>
                 </a:solidFill>
                 <a:latin typeface="Arial"/>
+                <a:ea typeface="DejaVu Sans"/>
               </a:rPr>
               <a:t>Monomer class</a:t>
             </a:r>
-            <a:endParaRPr b="1" lang="en-US" sz="1600" spc="-1" strike="noStrike">
+            <a:endParaRPr b="0" lang="en-US" sz="1600" spc="-1" strike="noStrike">
               <a:solidFill>
                 <a:srgbClr val="000000"/>
               </a:solidFill>
@@ -1907,7 +1931,7 @@
         <p:spPr>
           <a:xfrm>
             <a:off x="7796520" y="4177800"/>
-            <a:ext cx="2284200" cy="345960"/>
+            <a:ext cx="2283840" cy="345600"/>
           </a:xfrm>
           <a:prstGeom prst="rect">
             <a:avLst/>
@@ -1939,10 +1963,11 @@
                   <a:srgbClr val="000000"/>
                 </a:solidFill>
                 <a:latin typeface="Arial"/>
+                <a:ea typeface="DejaVu Sans"/>
               </a:rPr>
               <a:t>Proposed Monomers</a:t>
             </a:r>
-            <a:endParaRPr b="1" lang="en-US" sz="1600" spc="-1" strike="noStrike">
+            <a:endParaRPr b="0" lang="en-US" sz="1600" spc="-1" strike="noStrike">
               <a:solidFill>
                 <a:srgbClr val="000000"/>
               </a:solidFill>
@@ -2132,7 +2157,7 @@
         <p:spPr>
           <a:xfrm>
             <a:off x="7796520" y="2881800"/>
-            <a:ext cx="2033280" cy="1233000"/>
+            <a:ext cx="2032920" cy="1232640"/>
           </a:xfrm>
           <a:prstGeom prst="rect">
             <a:avLst/>
@@ -2164,10 +2189,11 @@
                   <a:srgbClr val="000000"/>
                 </a:solidFill>
                 <a:latin typeface="Arial"/>
+                <a:ea typeface="DejaVu Sans"/>
               </a:rPr>
               <a:t>Append/prepend/ monomer to BILN sequence of given Chain</a:t>
             </a:r>
-            <a:endParaRPr b="1" lang="en-US" sz="1600" spc="-1" strike="noStrike">
+            <a:endParaRPr b="0" lang="en-US" sz="1600" spc="-1" strike="noStrike">
               <a:solidFill>
                 <a:srgbClr val="000000"/>
               </a:solidFill>
@@ -2307,7 +2333,7 @@
         <p:spPr>
           <a:xfrm>
             <a:off x="565200" y="819000"/>
-            <a:ext cx="6941880" cy="3839040"/>
+            <a:ext cx="6941520" cy="3838680"/>
           </a:xfrm>
           <a:prstGeom prst="rect">
             <a:avLst/>
@@ -2369,7 +2395,7 @@
         <p:spPr>
           <a:xfrm>
             <a:off x="5257800" y="685800"/>
-            <a:ext cx="2285640" cy="4114440"/>
+            <a:ext cx="2285280" cy="4114080"/>
           </a:xfrm>
           <a:prstGeom prst="rect">
             <a:avLst/>
@@ -2417,7 +2443,7 @@
         <p:spPr>
           <a:xfrm>
             <a:off x="8012520" y="2269800"/>
-            <a:ext cx="1207440" cy="601920"/>
+            <a:ext cx="1207080" cy="601560"/>
           </a:xfrm>
           <a:prstGeom prst="rect">
             <a:avLst/>
@@ -2449,6 +2475,7 @@
                   <a:srgbClr val="000000"/>
                 </a:solidFill>
                 <a:latin typeface="Arial"/>
+                <a:ea typeface="DejaVu Sans"/>
               </a:rPr>
               <a:t>Monomer </a:t>
             </a:r>
@@ -2471,6 +2498,7 @@
                   <a:srgbClr val="000000"/>
                 </a:solidFill>
                 <a:latin typeface="Arial"/>
+                <a:ea typeface="DejaVu Sans"/>
               </a:rPr>
               <a:t>library</a:t>
             </a:r>
@@ -2535,7 +2563,7 @@
         <p:spPr>
           <a:xfrm>
             <a:off x="560880" y="361800"/>
-            <a:ext cx="1739520" cy="345960"/>
+            <a:ext cx="1739160" cy="345600"/>
           </a:xfrm>
           <a:prstGeom prst="rect">
             <a:avLst/>
@@ -2567,6 +2595,7 @@
                   <a:srgbClr val="000000"/>
                 </a:solidFill>
                 <a:latin typeface="Arial"/>
+                <a:ea typeface="DejaVu Sans"/>
               </a:rPr>
               <a:t>BILN sequence</a:t>
             </a:r>
@@ -2631,7 +2660,7 @@
         <p:spPr>
           <a:xfrm>
             <a:off x="2721240" y="361800"/>
-            <a:ext cx="1638720" cy="345960"/>
+            <a:ext cx="1638360" cy="345600"/>
           </a:xfrm>
           <a:prstGeom prst="rect">
             <a:avLst/>
@@ -2663,6 +2692,7 @@
                   <a:srgbClr val="000000"/>
                 </a:solidFill>
                 <a:latin typeface="Arial"/>
+                <a:ea typeface="DejaVu Sans"/>
               </a:rPr>
               <a:t>3D constraints</a:t>
             </a:r>
@@ -2684,7 +2714,7 @@
         <p:spPr>
           <a:xfrm>
             <a:off x="885600" y="4789800"/>
-            <a:ext cx="1446840" cy="345960"/>
+            <a:ext cx="1446480" cy="345600"/>
           </a:xfrm>
           <a:prstGeom prst="rect">
             <a:avLst/>
@@ -2716,6 +2746,7 @@
                   <a:srgbClr val="000000"/>
                 </a:solidFill>
                 <a:latin typeface="Arial"/>
+                <a:ea typeface="DejaVu Sans"/>
               </a:rPr>
               <a:t>2D depiction</a:t>
             </a:r>
@@ -2737,7 +2768,7 @@
         <p:spPr>
           <a:xfrm>
             <a:off x="3225600" y="4789800"/>
-            <a:ext cx="1446840" cy="345960"/>
+            <a:ext cx="1446480" cy="345600"/>
           </a:xfrm>
           <a:prstGeom prst="rect">
             <a:avLst/>
@@ -2769,6 +2800,7 @@
                   <a:srgbClr val="000000"/>
                 </a:solidFill>
                 <a:latin typeface="Arial"/>
+                <a:ea typeface="DejaVu Sans"/>
               </a:rPr>
               <a:t>3D depiction</a:t>
             </a:r>
@@ -2790,7 +2822,7 @@
         <p:spPr>
           <a:xfrm>
             <a:off x="613800" y="937800"/>
-            <a:ext cx="4487040" cy="1034640"/>
+            <a:ext cx="4486680" cy="1034280"/>
           </a:xfrm>
           <a:prstGeom prst="rect">
             <a:avLst/>
@@ -2838,7 +2870,7 @@
         <p:spPr>
           <a:xfrm>
             <a:off x="613800" y="2017800"/>
-            <a:ext cx="4487040" cy="725040"/>
+            <a:ext cx="4486680" cy="724680"/>
           </a:xfrm>
           <a:prstGeom prst="rect">
             <a:avLst/>
@@ -2886,7 +2918,7 @@
         <p:spPr>
           <a:xfrm>
             <a:off x="649800" y="2815200"/>
-            <a:ext cx="2129040" cy="1842840"/>
+            <a:ext cx="2128680" cy="1842480"/>
           </a:xfrm>
           <a:prstGeom prst="rect">
             <a:avLst/>
@@ -2934,7 +2966,7 @@
         <p:spPr>
           <a:xfrm>
             <a:off x="2863800" y="2815200"/>
-            <a:ext cx="2231640" cy="1842840"/>
+            <a:ext cx="2231280" cy="1842480"/>
           </a:xfrm>
           <a:prstGeom prst="rect">
             <a:avLst/>
@@ -3046,6 +3078,833 @@
         </p:style>
         <p:txBody>
           <a:bodyPr lIns="108360" rIns="108360" tIns="63360" bIns="63360" anchor="ctr">
+            <a:noAutofit/>
+          </a:bodyPr>
+          <a:p>
+            <a:endParaRPr b="0" lang="en-US" sz="1800" spc="-1" strike="noStrike">
+              <a:solidFill>
+                <a:srgbClr val="000000"/>
+              </a:solidFill>
+              <a:latin typeface="Arial"/>
+              <a:ea typeface="DejaVu Sans"/>
+            </a:endParaRPr>
+          </a:p>
+        </p:txBody>
+      </p:sp>
+    </p:spTree>
+  </p:cSld>
+  <mc:AlternateContent>
+    <mc:Choice Requires="p14">
+      <p:transition spd="slow" p14:dur="2000"/>
+    </mc:Choice>
+    <mc:Fallback>
+      <p:transition spd="slow"/>
+    </mc:Fallback>
+  </mc:AlternateContent>
+</p:sld>
+</file>
+
+<file path=ppt/slides/slide4.xml><?xml version="1.0" encoding="utf-8"?>
+<p:sld xmlns:a="http://schemas.openxmlformats.org/drawingml/2006/main" xmlns:p="http://schemas.openxmlformats.org/presentationml/2006/main" xmlns:r="http://schemas.openxmlformats.org/officeDocument/2006/relationships" xmlns:p14="http://schemas.microsoft.com/office/powerpoint/2010/main" xmlns:p15="http://schemas.microsoft.com/office/powerpoint/2012/main" xmlns:mc="http://schemas.openxmlformats.org/markup-compatibility/2006">
+  <p:cSld>
+    <p:spTree>
+      <p:nvGrpSpPr>
+        <p:cNvPr id="1" name=""/>
+        <p:cNvGrpSpPr/>
+        <p:nvPr/>
+      </p:nvGrpSpPr>
+      <p:grpSpPr>
+        <a:xfrm>
+          <a:off x="0" y="0"/>
+          <a:ext cx="0" cy="0"/>
+          <a:chOff x="0" y="0"/>
+          <a:chExt cx="0" cy="0"/>
+        </a:xfrm>
+      </p:grpSpPr>
+      <p:pic>
+        <p:nvPicPr>
+          <p:cNvPr id="49" name="" descr=""/>
+          <p:cNvPicPr/>
+          <p:nvPr/>
+        </p:nvPicPr>
+        <p:blipFill>
+          <a:blip r:embed="rId1"/>
+          <a:stretch/>
+        </p:blipFill>
+        <p:spPr>
+          <a:xfrm>
+            <a:off x="4572000" y="133200"/>
+            <a:ext cx="2834280" cy="2742840"/>
+          </a:xfrm>
+          <a:prstGeom prst="rect">
+            <a:avLst/>
+          </a:prstGeom>
+          <a:ln w="0">
+            <a:noFill/>
+          </a:ln>
+        </p:spPr>
+      </p:pic>
+      <p:pic>
+        <p:nvPicPr>
+          <p:cNvPr id="50" name="" descr=""/>
+          <p:cNvPicPr/>
+          <p:nvPr/>
+        </p:nvPicPr>
+        <p:blipFill>
+          <a:blip r:embed="rId2"/>
+          <a:stretch/>
+        </p:blipFill>
+        <p:spPr>
+          <a:xfrm>
+            <a:off x="685800" y="139680"/>
+            <a:ext cx="2660400" cy="2574000"/>
+          </a:xfrm>
+          <a:prstGeom prst="rect">
+            <a:avLst/>
+          </a:prstGeom>
+          <a:ln w="0">
+            <a:noFill/>
+          </a:ln>
+        </p:spPr>
+      </p:pic>
+      <p:sp>
+        <p:nvSpPr>
+          <p:cNvPr id="51" name=""/>
+          <p:cNvSpPr/>
+          <p:nvPr/>
+        </p:nvSpPr>
+        <p:spPr>
+          <a:xfrm flipV="1">
+            <a:off x="1758600" y="1837800"/>
+            <a:ext cx="429120" cy="214560"/>
+          </a:xfrm>
+          <a:prstGeom prst="line">
+            <a:avLst/>
+          </a:prstGeom>
+          <a:ln w="36720">
+            <a:solidFill>
+              <a:srgbClr val="ff0000"/>
+            </a:solidFill>
+            <a:round/>
+            <a:tailEnd len="med" type="triangle" w="med"/>
+          </a:ln>
+        </p:spPr>
+        <p:style>
+          <a:lnRef idx="0"/>
+          <a:fillRef idx="0"/>
+          <a:effectRef idx="0"/>
+          <a:fontRef idx="minor"/>
+        </p:style>
+        <p:txBody>
+          <a:bodyPr lIns="108360" rIns="108360" tIns="63360" bIns="63360" anchor="ctr">
+            <a:noAutofit/>
+          </a:bodyPr>
+          <a:p>
+            <a:endParaRPr b="0" lang="en-US" sz="1800" spc="-1" strike="noStrike">
+              <a:solidFill>
+                <a:srgbClr val="000000"/>
+              </a:solidFill>
+              <a:latin typeface="Arial"/>
+              <a:ea typeface="DejaVu Sans"/>
+            </a:endParaRPr>
+          </a:p>
+        </p:txBody>
+      </p:sp>
+      <p:sp>
+        <p:nvSpPr>
+          <p:cNvPr id="52" name=""/>
+          <p:cNvSpPr/>
+          <p:nvPr/>
+        </p:nvSpPr>
+        <p:spPr>
+          <a:xfrm flipV="1">
+            <a:off x="1750320" y="2556360"/>
+            <a:ext cx="429120" cy="214200"/>
+          </a:xfrm>
+          <a:prstGeom prst="line">
+            <a:avLst/>
+          </a:prstGeom>
+          <a:ln w="36720">
+            <a:solidFill>
+              <a:srgbClr val="ff0000"/>
+            </a:solidFill>
+            <a:round/>
+            <a:tailEnd len="med" type="triangle" w="med"/>
+          </a:ln>
+        </p:spPr>
+        <p:style>
+          <a:lnRef idx="0"/>
+          <a:fillRef idx="0"/>
+          <a:effectRef idx="0"/>
+          <a:fontRef idx="minor"/>
+        </p:style>
+        <p:txBody>
+          <a:bodyPr lIns="108360" rIns="108360" tIns="63360" bIns="63360" anchor="ctr">
+            <a:noAutofit/>
+          </a:bodyPr>
+          <a:p>
+            <a:endParaRPr b="0" lang="en-US" sz="1400" spc="-1" strike="noStrike">
+              <a:solidFill>
+                <a:srgbClr val="000000"/>
+              </a:solidFill>
+              <a:latin typeface="Arial"/>
+              <a:ea typeface="DejaVu Sans"/>
+            </a:endParaRPr>
+          </a:p>
+        </p:txBody>
+      </p:sp>
+      <p:sp>
+        <p:nvSpPr>
+          <p:cNvPr id="53" name=""/>
+          <p:cNvSpPr/>
+          <p:nvPr/>
+        </p:nvSpPr>
+        <p:spPr>
+          <a:xfrm>
+            <a:off x="1092960" y="2610720"/>
+            <a:ext cx="964080" cy="489600"/>
+          </a:xfrm>
+          <a:prstGeom prst="rect">
+            <a:avLst/>
+          </a:prstGeom>
+          <a:noFill/>
+          <a:ln w="0">
+            <a:noFill/>
+          </a:ln>
+        </p:spPr>
+        <p:style>
+          <a:lnRef idx="0"/>
+          <a:fillRef idx="0"/>
+          <a:effectRef idx="0"/>
+          <a:fontRef idx="minor"/>
+        </p:style>
+        <p:txBody>
+          <a:bodyPr lIns="90000" rIns="90000" tIns="45000" bIns="45000" anchor="t">
+            <a:noAutofit/>
+          </a:bodyPr>
+          <a:p>
+            <a:pPr>
+              <a:lnSpc>
+                <a:spcPct val="100000"/>
+              </a:lnSpc>
+            </a:pPr>
+            <a:r>
+              <a:rPr b="1" lang="en-US" sz="1400" spc="-1" strike="noStrike">
+                <a:solidFill>
+                  <a:srgbClr val="000000"/>
+                </a:solidFill>
+                <a:latin typeface="Arial"/>
+              </a:rPr>
+              <a:t>Click 2</a:t>
+            </a:r>
+            <a:endParaRPr b="0" lang="en-US" sz="1400" spc="-1" strike="noStrike">
+              <a:solidFill>
+                <a:srgbClr val="000000"/>
+              </a:solidFill>
+              <a:latin typeface="Arial"/>
+            </a:endParaRPr>
+          </a:p>
+        </p:txBody>
+      </p:sp>
+      <p:sp>
+        <p:nvSpPr>
+          <p:cNvPr id="54" name=""/>
+          <p:cNvSpPr/>
+          <p:nvPr/>
+        </p:nvSpPr>
+        <p:spPr>
+          <a:xfrm>
+            <a:off x="1092960" y="1833480"/>
+            <a:ext cx="964080" cy="489600"/>
+          </a:xfrm>
+          <a:prstGeom prst="rect">
+            <a:avLst/>
+          </a:prstGeom>
+          <a:noFill/>
+          <a:ln w="0">
+            <a:noFill/>
+          </a:ln>
+        </p:spPr>
+        <p:style>
+          <a:lnRef idx="0"/>
+          <a:fillRef idx="0"/>
+          <a:effectRef idx="0"/>
+          <a:fontRef idx="minor"/>
+        </p:style>
+        <p:txBody>
+          <a:bodyPr lIns="90000" rIns="90000" tIns="45000" bIns="45000" anchor="t">
+            <a:noAutofit/>
+          </a:bodyPr>
+          <a:p>
+            <a:pPr>
+              <a:lnSpc>
+                <a:spcPct val="100000"/>
+              </a:lnSpc>
+            </a:pPr>
+            <a:r>
+              <a:rPr b="1" lang="en-US" sz="1400" spc="-1" strike="noStrike">
+                <a:solidFill>
+                  <a:srgbClr val="000000"/>
+                </a:solidFill>
+                <a:latin typeface="Arial"/>
+              </a:rPr>
+              <a:t>Click 1</a:t>
+            </a:r>
+            <a:endParaRPr b="0" lang="en-US" sz="1400" spc="-1" strike="noStrike">
+              <a:solidFill>
+                <a:srgbClr val="000000"/>
+              </a:solidFill>
+              <a:latin typeface="Arial"/>
+            </a:endParaRPr>
+          </a:p>
+        </p:txBody>
+      </p:sp>
+      <p:sp>
+        <p:nvSpPr>
+          <p:cNvPr id="55" name=""/>
+          <p:cNvSpPr/>
+          <p:nvPr/>
+        </p:nvSpPr>
+        <p:spPr>
+          <a:xfrm flipV="1">
+            <a:off x="3691800" y="1818000"/>
+            <a:ext cx="700200" cy="9360"/>
+          </a:xfrm>
+          <a:prstGeom prst="line">
+            <a:avLst/>
+          </a:prstGeom>
+          <a:ln w="36720">
+            <a:solidFill>
+              <a:srgbClr val="ff0000"/>
+            </a:solidFill>
+            <a:round/>
+            <a:tailEnd len="med" type="triangle" w="med"/>
+          </a:ln>
+        </p:spPr>
+        <p:style>
+          <a:lnRef idx="0"/>
+          <a:fillRef idx="0"/>
+          <a:effectRef idx="0"/>
+          <a:fontRef idx="minor"/>
+        </p:style>
+        <p:txBody>
+          <a:bodyPr lIns="108360" rIns="108360" tIns="-54000" bIns="-54000" anchor="ctr">
+            <a:noAutofit/>
+          </a:bodyPr>
+          <a:p>
+            <a:endParaRPr b="0" lang="en-US" sz="1800" spc="-1" strike="noStrike">
+              <a:solidFill>
+                <a:srgbClr val="000000"/>
+              </a:solidFill>
+              <a:latin typeface="Arial"/>
+              <a:ea typeface="DejaVu Sans"/>
+            </a:endParaRPr>
+          </a:p>
+        </p:txBody>
+      </p:sp>
+      <p:pic>
+        <p:nvPicPr>
+          <p:cNvPr id="56" name="" descr=""/>
+          <p:cNvPicPr/>
+          <p:nvPr/>
+        </p:nvPicPr>
+        <p:blipFill>
+          <a:blip r:embed="rId3"/>
+          <a:stretch/>
+        </p:blipFill>
+        <p:spPr>
+          <a:xfrm>
+            <a:off x="4572000" y="2876400"/>
+            <a:ext cx="2834280" cy="2742840"/>
+          </a:xfrm>
+          <a:prstGeom prst="rect">
+            <a:avLst/>
+          </a:prstGeom>
+          <a:ln w="0">
+            <a:noFill/>
+          </a:ln>
+        </p:spPr>
+      </p:pic>
+      <p:pic>
+        <p:nvPicPr>
+          <p:cNvPr id="57" name="" descr=""/>
+          <p:cNvPicPr/>
+          <p:nvPr/>
+        </p:nvPicPr>
+        <p:blipFill>
+          <a:blip r:embed="rId4"/>
+          <a:stretch/>
+        </p:blipFill>
+        <p:spPr>
+          <a:xfrm>
+            <a:off x="545760" y="2927520"/>
+            <a:ext cx="2834280" cy="2742840"/>
+          </a:xfrm>
+          <a:prstGeom prst="rect">
+            <a:avLst/>
+          </a:prstGeom>
+          <a:ln w="0">
+            <a:noFill/>
+          </a:ln>
+        </p:spPr>
+      </p:pic>
+      <p:sp>
+        <p:nvSpPr>
+          <p:cNvPr id="58" name=""/>
+          <p:cNvSpPr/>
+          <p:nvPr/>
+        </p:nvSpPr>
+        <p:spPr>
+          <a:xfrm flipH="1" flipV="1">
+            <a:off x="3682440" y="4515480"/>
+            <a:ext cx="700200" cy="9360"/>
+          </a:xfrm>
+          <a:prstGeom prst="line">
+            <a:avLst/>
+          </a:prstGeom>
+          <a:ln w="36720">
+            <a:solidFill>
+              <a:srgbClr val="ff0000"/>
+            </a:solidFill>
+            <a:round/>
+            <a:tailEnd len="med" type="triangle" w="med"/>
+          </a:ln>
+        </p:spPr>
+        <p:style>
+          <a:lnRef idx="0"/>
+          <a:fillRef idx="0"/>
+          <a:effectRef idx="0"/>
+          <a:fontRef idx="minor"/>
+        </p:style>
+        <p:txBody>
+          <a:bodyPr lIns="108360" rIns="108360" tIns="-54000" bIns="-54000" anchor="ctr">
+            <a:noAutofit/>
+          </a:bodyPr>
+          <a:p>
+            <a:endParaRPr b="0" lang="en-US" sz="1800" spc="-1" strike="noStrike">
+              <a:solidFill>
+                <a:srgbClr val="000000"/>
+              </a:solidFill>
+              <a:latin typeface="Arial"/>
+              <a:ea typeface="DejaVu Sans"/>
+            </a:endParaRPr>
+          </a:p>
+        </p:txBody>
+      </p:sp>
+      <p:sp>
+        <p:nvSpPr>
+          <p:cNvPr id="59" name=""/>
+          <p:cNvSpPr/>
+          <p:nvPr/>
+        </p:nvSpPr>
+        <p:spPr>
+          <a:xfrm flipV="1">
+            <a:off x="5484960" y="4977720"/>
+            <a:ext cx="429120" cy="214200"/>
+          </a:xfrm>
+          <a:prstGeom prst="line">
+            <a:avLst/>
+          </a:prstGeom>
+          <a:ln w="36720">
+            <a:solidFill>
+              <a:srgbClr val="ff0000"/>
+            </a:solidFill>
+            <a:round/>
+            <a:tailEnd len="med" type="triangle" w="med"/>
+          </a:ln>
+        </p:spPr>
+        <p:style>
+          <a:lnRef idx="0"/>
+          <a:fillRef idx="0"/>
+          <a:effectRef idx="0"/>
+          <a:fontRef idx="minor"/>
+        </p:style>
+        <p:txBody>
+          <a:bodyPr lIns="108360" rIns="108360" tIns="63360" bIns="63360" anchor="ctr">
+            <a:noAutofit/>
+          </a:bodyPr>
+          <a:p>
+            <a:endParaRPr b="0" lang="en-US" sz="1400" spc="-1" strike="noStrike">
+              <a:solidFill>
+                <a:srgbClr val="000000"/>
+              </a:solidFill>
+              <a:latin typeface="Arial"/>
+              <a:ea typeface="DejaVu Sans"/>
+            </a:endParaRPr>
+          </a:p>
+        </p:txBody>
+      </p:sp>
+      <p:sp>
+        <p:nvSpPr>
+          <p:cNvPr id="60" name=""/>
+          <p:cNvSpPr/>
+          <p:nvPr/>
+        </p:nvSpPr>
+        <p:spPr>
+          <a:xfrm>
+            <a:off x="4765320" y="5023080"/>
+            <a:ext cx="964080" cy="489600"/>
+          </a:xfrm>
+          <a:prstGeom prst="rect">
+            <a:avLst/>
+          </a:prstGeom>
+          <a:noFill/>
+          <a:ln w="0">
+            <a:noFill/>
+          </a:ln>
+        </p:spPr>
+        <p:style>
+          <a:lnRef idx="0"/>
+          <a:fillRef idx="0"/>
+          <a:effectRef idx="0"/>
+          <a:fontRef idx="minor"/>
+        </p:style>
+        <p:txBody>
+          <a:bodyPr lIns="90000" rIns="90000" tIns="45000" bIns="45000" anchor="t">
+            <a:noAutofit/>
+          </a:bodyPr>
+          <a:p>
+            <a:pPr>
+              <a:lnSpc>
+                <a:spcPct val="100000"/>
+              </a:lnSpc>
+            </a:pPr>
+            <a:r>
+              <a:rPr b="1" lang="en-US" sz="1400" spc="-1" strike="noStrike">
+                <a:solidFill>
+                  <a:srgbClr val="000000"/>
+                </a:solidFill>
+                <a:latin typeface="Arial"/>
+              </a:rPr>
+              <a:t>Double click</a:t>
+            </a:r>
+            <a:endParaRPr b="0" lang="en-US" sz="1400" spc="-1" strike="noStrike">
+              <a:solidFill>
+                <a:srgbClr val="000000"/>
+              </a:solidFill>
+              <a:latin typeface="Arial"/>
+            </a:endParaRPr>
+          </a:p>
+        </p:txBody>
+      </p:sp>
+      <p:sp>
+        <p:nvSpPr>
+          <p:cNvPr id="61" name=""/>
+          <p:cNvSpPr/>
+          <p:nvPr/>
+        </p:nvSpPr>
+        <p:spPr>
+          <a:xfrm>
+            <a:off x="3577680" y="4159440"/>
+            <a:ext cx="1150560" cy="489600"/>
+          </a:xfrm>
+          <a:prstGeom prst="rect">
+            <a:avLst/>
+          </a:prstGeom>
+          <a:noFill/>
+          <a:ln w="0">
+            <a:noFill/>
+          </a:ln>
+        </p:spPr>
+        <p:style>
+          <a:lnRef idx="0"/>
+          <a:fillRef idx="0"/>
+          <a:effectRef idx="0"/>
+          <a:fontRef idx="minor"/>
+        </p:style>
+        <p:txBody>
+          <a:bodyPr lIns="90000" rIns="90000" tIns="45000" bIns="45000" anchor="t">
+            <a:noAutofit/>
+          </a:bodyPr>
+          <a:p>
+            <a:pPr>
+              <a:lnSpc>
+                <a:spcPct val="100000"/>
+              </a:lnSpc>
+            </a:pPr>
+            <a:r>
+              <a:rPr b="1" lang="en-US" sz="1400" spc="-1" strike="noStrike">
+                <a:solidFill>
+                  <a:srgbClr val="000000"/>
+                </a:solidFill>
+                <a:latin typeface="Arial"/>
+              </a:rPr>
+              <a:t>Unlinking</a:t>
+            </a:r>
+            <a:endParaRPr b="0" lang="en-US" sz="1400" spc="-1" strike="noStrike">
+              <a:solidFill>
+                <a:srgbClr val="000000"/>
+              </a:solidFill>
+              <a:latin typeface="Arial"/>
+            </a:endParaRPr>
+          </a:p>
+        </p:txBody>
+      </p:sp>
+      <p:sp>
+        <p:nvSpPr>
+          <p:cNvPr id="62" name=""/>
+          <p:cNvSpPr/>
+          <p:nvPr/>
+        </p:nvSpPr>
+        <p:spPr>
+          <a:xfrm>
+            <a:off x="3614040" y="1459800"/>
+            <a:ext cx="1150560" cy="489600"/>
+          </a:xfrm>
+          <a:prstGeom prst="rect">
+            <a:avLst/>
+          </a:prstGeom>
+          <a:noFill/>
+          <a:ln w="0">
+            <a:noFill/>
+          </a:ln>
+        </p:spPr>
+        <p:style>
+          <a:lnRef idx="0"/>
+          <a:fillRef idx="0"/>
+          <a:effectRef idx="0"/>
+          <a:fontRef idx="minor"/>
+        </p:style>
+        <p:txBody>
+          <a:bodyPr lIns="90000" rIns="90000" tIns="45000" bIns="45000" anchor="t">
+            <a:noAutofit/>
+          </a:bodyPr>
+          <a:p>
+            <a:pPr>
+              <a:lnSpc>
+                <a:spcPct val="100000"/>
+              </a:lnSpc>
+            </a:pPr>
+            <a:r>
+              <a:rPr b="1" lang="en-US" sz="1400" spc="-1" strike="noStrike">
+                <a:solidFill>
+                  <a:srgbClr val="000000"/>
+                </a:solidFill>
+                <a:latin typeface="Arial"/>
+              </a:rPr>
+              <a:t>Linking</a:t>
+            </a:r>
+            <a:endParaRPr b="0" lang="en-US" sz="1400" spc="-1" strike="noStrike">
+              <a:solidFill>
+                <a:srgbClr val="000000"/>
+              </a:solidFill>
+              <a:latin typeface="Arial"/>
+            </a:endParaRPr>
+          </a:p>
+        </p:txBody>
+      </p:sp>
+    </p:spTree>
+  </p:cSld>
+  <mc:AlternateContent>
+    <mc:Choice Requires="p14">
+      <p:transition spd="slow" p14:dur="2000"/>
+    </mc:Choice>
+    <mc:Fallback>
+      <p:transition spd="slow"/>
+    </mc:Fallback>
+  </mc:AlternateContent>
+</p:sld>
+</file>
+
+<file path=ppt/slides/slide5.xml><?xml version="1.0" encoding="utf-8"?>
+<p:sld xmlns:a="http://schemas.openxmlformats.org/drawingml/2006/main" xmlns:p="http://schemas.openxmlformats.org/presentationml/2006/main" xmlns:r="http://schemas.openxmlformats.org/officeDocument/2006/relationships" xmlns:p14="http://schemas.microsoft.com/office/powerpoint/2010/main" xmlns:p15="http://schemas.microsoft.com/office/powerpoint/2012/main" xmlns:mc="http://schemas.openxmlformats.org/markup-compatibility/2006">
+  <p:cSld>
+    <p:spTree>
+      <p:nvGrpSpPr>
+        <p:cNvPr id="1" name=""/>
+        <p:cNvGrpSpPr/>
+        <p:nvPr/>
+      </p:nvGrpSpPr>
+      <p:grpSpPr>
+        <a:xfrm>
+          <a:off x="0" y="0"/>
+          <a:ext cx="0" cy="0"/>
+          <a:chOff x="0" y="0"/>
+          <a:chExt cx="0" cy="0"/>
+        </a:xfrm>
+      </p:grpSpPr>
+      <p:pic>
+        <p:nvPicPr>
+          <p:cNvPr id="63" name="" descr=""/>
+          <p:cNvPicPr/>
+          <p:nvPr/>
+        </p:nvPicPr>
+        <p:blipFill>
+          <a:blip r:embed="rId1"/>
+          <a:stretch/>
+        </p:blipFill>
+        <p:spPr>
+          <a:xfrm>
+            <a:off x="1826640" y="1700280"/>
+            <a:ext cx="6495480" cy="2313720"/>
+          </a:xfrm>
+          <a:prstGeom prst="rect">
+            <a:avLst/>
+          </a:prstGeom>
+          <a:ln w="0">
+            <a:noFill/>
+          </a:ln>
+        </p:spPr>
+      </p:pic>
+    </p:spTree>
+  </p:cSld>
+  <mc:AlternateContent>
+    <mc:Choice Requires="p14">
+      <p:transition spd="slow" p14:dur="2000"/>
+    </mc:Choice>
+    <mc:Fallback>
+      <p:transition spd="slow"/>
+    </mc:Fallback>
+  </mc:AlternateContent>
+</p:sld>
+</file>
+
+<file path=ppt/slides/slide6.xml><?xml version="1.0" encoding="utf-8"?>
+<p:sld xmlns:a="http://schemas.openxmlformats.org/drawingml/2006/main" xmlns:p="http://schemas.openxmlformats.org/presentationml/2006/main" xmlns:r="http://schemas.openxmlformats.org/officeDocument/2006/relationships" xmlns:p14="http://schemas.microsoft.com/office/powerpoint/2010/main" xmlns:p15="http://schemas.microsoft.com/office/powerpoint/2012/main" xmlns:mc="http://schemas.openxmlformats.org/markup-compatibility/2006">
+  <p:cSld>
+    <p:spTree>
+      <p:nvGrpSpPr>
+        <p:cNvPr id="1" name=""/>
+        <p:cNvGrpSpPr/>
+        <p:nvPr/>
+      </p:nvGrpSpPr>
+      <p:grpSpPr>
+        <a:xfrm>
+          <a:off x="0" y="0"/>
+          <a:ext cx="0" cy="0"/>
+          <a:chOff x="0" y="0"/>
+          <a:chExt cx="0" cy="0"/>
+        </a:xfrm>
+      </p:grpSpPr>
+      <p:pic>
+        <p:nvPicPr>
+          <p:cNvPr id="64" name="" descr=""/>
+          <p:cNvPicPr/>
+          <p:nvPr/>
+        </p:nvPicPr>
+        <p:blipFill>
+          <a:blip r:embed="rId1"/>
+          <a:stretch/>
+        </p:blipFill>
+        <p:spPr>
+          <a:xfrm>
+            <a:off x="694800" y="1417320"/>
+            <a:ext cx="3420000" cy="2926080"/>
+          </a:xfrm>
+          <a:prstGeom prst="rect">
+            <a:avLst/>
+          </a:prstGeom>
+          <a:ln w="0">
+            <a:noFill/>
+          </a:ln>
+        </p:spPr>
+      </p:pic>
+    </p:spTree>
+  </p:cSld>
+  <mc:AlternateContent>
+    <mc:Choice Requires="p14">
+      <p:transition spd="slow" p14:dur="2000"/>
+    </mc:Choice>
+    <mc:Fallback>
+      <p:transition spd="slow"/>
+    </mc:Fallback>
+  </mc:AlternateContent>
+</p:sld>
+</file>
+
+<file path=ppt/slides/slide7.xml><?xml version="1.0" encoding="utf-8"?>
+<p:sld xmlns:a="http://schemas.openxmlformats.org/drawingml/2006/main" xmlns:p="http://schemas.openxmlformats.org/presentationml/2006/main" xmlns:r="http://schemas.openxmlformats.org/officeDocument/2006/relationships" xmlns:p14="http://schemas.microsoft.com/office/powerpoint/2010/main" xmlns:p15="http://schemas.microsoft.com/office/powerpoint/2012/main" xmlns:mc="http://schemas.openxmlformats.org/markup-compatibility/2006">
+  <p:cSld>
+    <p:spTree>
+      <p:nvGrpSpPr>
+        <p:cNvPr id="1" name=""/>
+        <p:cNvGrpSpPr/>
+        <p:nvPr/>
+      </p:nvGrpSpPr>
+      <p:grpSpPr>
+        <a:xfrm>
+          <a:off x="0" y="0"/>
+          <a:ext cx="0" cy="0"/>
+          <a:chOff x="0" y="0"/>
+          <a:chExt cx="0" cy="0"/>
+        </a:xfrm>
+      </p:grpSpPr>
+      <p:pic>
+        <p:nvPicPr>
+          <p:cNvPr id="65" name="" descr=""/>
+          <p:cNvPicPr/>
+          <p:nvPr/>
+        </p:nvPicPr>
+        <p:blipFill>
+          <a:blip r:embed="rId1"/>
+          <a:stretch/>
+        </p:blipFill>
+        <p:spPr>
+          <a:xfrm>
+            <a:off x="1143000" y="1107000"/>
+            <a:ext cx="3639240" cy="2926080"/>
+          </a:xfrm>
+          <a:prstGeom prst="rect">
+            <a:avLst/>
+          </a:prstGeom>
+          <a:ln w="0">
+            <a:noFill/>
+          </a:ln>
+        </p:spPr>
+      </p:pic>
+      <p:pic>
+        <p:nvPicPr>
+          <p:cNvPr id="66" name="" descr=""/>
+          <p:cNvPicPr/>
+          <p:nvPr/>
+        </p:nvPicPr>
+        <p:blipFill>
+          <a:blip r:embed="rId2"/>
+          <a:stretch/>
+        </p:blipFill>
+        <p:spPr>
+          <a:xfrm>
+            <a:off x="5257800" y="1104120"/>
+            <a:ext cx="3639240" cy="2926080"/>
+          </a:xfrm>
+          <a:prstGeom prst="rect">
+            <a:avLst/>
+          </a:prstGeom>
+          <a:ln w="0">
+            <a:noFill/>
+          </a:ln>
+        </p:spPr>
+      </p:pic>
+      <p:sp>
+        <p:nvSpPr>
+          <p:cNvPr id="67" name=""/>
+          <p:cNvSpPr/>
+          <p:nvPr/>
+        </p:nvSpPr>
+        <p:spPr>
+          <a:xfrm flipV="1">
+            <a:off x="4690800" y="2211120"/>
+            <a:ext cx="700200" cy="9360"/>
+          </a:xfrm>
+          <a:prstGeom prst="line">
+            <a:avLst/>
+          </a:prstGeom>
+          <a:ln w="36720">
+            <a:solidFill>
+              <a:srgbClr val="ff0000"/>
+            </a:solidFill>
+            <a:round/>
+            <a:tailEnd len="med" type="triangle" w="med"/>
+          </a:ln>
+        </p:spPr>
+        <p:style>
+          <a:lnRef idx="0"/>
+          <a:fillRef idx="0"/>
+          <a:effectRef idx="0"/>
+          <a:fontRef idx="minor"/>
+        </p:style>
+        <p:txBody>
+          <a:bodyPr lIns="108360" rIns="108360" tIns="-54000" bIns="-54000" anchor="ctr">
             <a:noAutofit/>
           </a:bodyPr>
           <a:p>

</xml_diff>

<commit_message>
better doc, still not complete
</commit_message>
<xml_diff>
--- a/doc/images/Monomer.pptx
+++ b/doc/images/Monomer.pptx
@@ -70,7 +70,7 @@
         <p:txBody>
           <a:bodyPr/>
           <a:p>
-            <a:fld id="{1601BD10-D068-4A7C-A013-3278BC4DFADD}" type="slidenum">
+            <a:fld id="{ECBBE316-F421-47FE-A091-BD48A1691B12}" type="slidenum">
               <a:t>&lt;#&gt;</a:t>
             </a:fld>
           </a:p>
@@ -132,7 +132,7 @@
         <p:spPr>
           <a:xfrm>
             <a:off x="504000" y="226080"/>
-            <a:ext cx="9070200" cy="945000"/>
+            <a:ext cx="9069840" cy="944640"/>
           </a:xfrm>
           <a:prstGeom prst="rect">
             <a:avLst/>
@@ -169,7 +169,7 @@
         <p:spPr>
           <a:xfrm>
             <a:off x="504000" y="1326600"/>
-            <a:ext cx="9070920" cy="1567800"/>
+            <a:ext cx="9070560" cy="1567800"/>
           </a:xfrm>
           <a:prstGeom prst="rect">
             <a:avLst/>
@@ -203,7 +203,7 @@
         <p:spPr>
           <a:xfrm>
             <a:off x="504000" y="3043800"/>
-            <a:ext cx="9070920" cy="1567800"/>
+            <a:ext cx="9070560" cy="1567800"/>
           </a:xfrm>
           <a:prstGeom prst="rect">
             <a:avLst/>
@@ -258,7 +258,7 @@
         <p:txBody>
           <a:bodyPr/>
           <a:p>
-            <a:fld id="{1D17CAB1-BF71-4B25-8B91-64AA5809182F}" type="slidenum">
+            <a:fld id="{B7C43451-52FF-43B5-95B2-162BE61CF853}" type="slidenum">
               <a:t>&lt;#&gt;</a:t>
             </a:fld>
           </a:p>
@@ -320,7 +320,7 @@
         <p:spPr>
           <a:xfrm>
             <a:off x="504000" y="226080"/>
-            <a:ext cx="9070200" cy="945000"/>
+            <a:ext cx="9069840" cy="944640"/>
           </a:xfrm>
           <a:prstGeom prst="rect">
             <a:avLst/>
@@ -357,7 +357,7 @@
         <p:spPr>
           <a:xfrm>
             <a:off x="504000" y="1326600"/>
-            <a:ext cx="4426560" cy="1567800"/>
+            <a:ext cx="4426200" cy="1567800"/>
           </a:xfrm>
           <a:prstGeom prst="rect">
             <a:avLst/>
@@ -390,8 +390,8 @@
         </p:nvSpPr>
         <p:spPr>
           <a:xfrm>
-            <a:off x="5152320" y="1326600"/>
-            <a:ext cx="4426560" cy="1567800"/>
+            <a:off x="5151960" y="1326600"/>
+            <a:ext cx="4426200" cy="1567800"/>
           </a:xfrm>
           <a:prstGeom prst="rect">
             <a:avLst/>
@@ -425,7 +425,7 @@
         <p:spPr>
           <a:xfrm>
             <a:off x="504000" y="3043800"/>
-            <a:ext cx="4426560" cy="1567800"/>
+            <a:ext cx="4426200" cy="1567800"/>
           </a:xfrm>
           <a:prstGeom prst="rect">
             <a:avLst/>
@@ -458,8 +458,8 @@
         </p:nvSpPr>
         <p:spPr>
           <a:xfrm>
-            <a:off x="5152320" y="3043800"/>
-            <a:ext cx="4426560" cy="1567800"/>
+            <a:off x="5151960" y="3043800"/>
+            <a:ext cx="4426200" cy="1567800"/>
           </a:xfrm>
           <a:prstGeom prst="rect">
             <a:avLst/>
@@ -514,7 +514,7 @@
         <p:txBody>
           <a:bodyPr/>
           <a:p>
-            <a:fld id="{9D6C32B6-930A-41A0-9550-C5AA688C8B29}" type="slidenum">
+            <a:fld id="{521129D0-8FC8-4A12-A887-6304D213A348}" type="slidenum">
               <a:t>&lt;#&gt;</a:t>
             </a:fld>
           </a:p>
@@ -576,7 +576,7 @@
         <p:spPr>
           <a:xfrm>
             <a:off x="504000" y="226080"/>
-            <a:ext cx="9070200" cy="945000"/>
+            <a:ext cx="9069840" cy="944640"/>
           </a:xfrm>
           <a:prstGeom prst="rect">
             <a:avLst/>
@@ -613,7 +613,7 @@
         <p:spPr>
           <a:xfrm>
             <a:off x="504000" y="1326600"/>
-            <a:ext cx="2920680" cy="1567800"/>
+            <a:ext cx="2920320" cy="1567800"/>
           </a:xfrm>
           <a:prstGeom prst="rect">
             <a:avLst/>
@@ -646,8 +646,8 @@
         </p:nvSpPr>
         <p:spPr>
           <a:xfrm>
-            <a:off x="3571200" y="1326600"/>
-            <a:ext cx="2920680" cy="1567800"/>
+            <a:off x="3570840" y="1326600"/>
+            <a:ext cx="2920320" cy="1567800"/>
           </a:xfrm>
           <a:prstGeom prst="rect">
             <a:avLst/>
@@ -680,8 +680,8 @@
         </p:nvSpPr>
         <p:spPr>
           <a:xfrm>
-            <a:off x="6638040" y="1326600"/>
-            <a:ext cx="2920680" cy="1567800"/>
+            <a:off x="6637320" y="1326600"/>
+            <a:ext cx="2920320" cy="1567800"/>
           </a:xfrm>
           <a:prstGeom prst="rect">
             <a:avLst/>
@@ -715,7 +715,7 @@
         <p:spPr>
           <a:xfrm>
             <a:off x="504000" y="3043800"/>
-            <a:ext cx="2920680" cy="1567800"/>
+            <a:ext cx="2920320" cy="1567800"/>
           </a:xfrm>
           <a:prstGeom prst="rect">
             <a:avLst/>
@@ -748,8 +748,8 @@
         </p:nvSpPr>
         <p:spPr>
           <a:xfrm>
-            <a:off x="3571200" y="3043800"/>
-            <a:ext cx="2920680" cy="1567800"/>
+            <a:off x="3570840" y="3043800"/>
+            <a:ext cx="2920320" cy="1567800"/>
           </a:xfrm>
           <a:prstGeom prst="rect">
             <a:avLst/>
@@ -782,8 +782,8 @@
         </p:nvSpPr>
         <p:spPr>
           <a:xfrm>
-            <a:off x="6638040" y="3043800"/>
-            <a:ext cx="2920680" cy="1567800"/>
+            <a:off x="6637320" y="3043800"/>
+            <a:ext cx="2920320" cy="1567800"/>
           </a:xfrm>
           <a:prstGeom prst="rect">
             <a:avLst/>
@@ -838,7 +838,7 @@
         <p:txBody>
           <a:bodyPr/>
           <a:p>
-            <a:fld id="{EBB43ADA-4C08-4645-A3C8-FA0AED5BC52C}" type="slidenum">
+            <a:fld id="{B860AB85-CC67-41D7-9AF4-60E51DF61502}" type="slidenum">
               <a:t>&lt;#&gt;</a:t>
             </a:fld>
           </a:p>
@@ -921,7 +921,7 @@
         <p:txBody>
           <a:bodyPr/>
           <a:p>
-            <a:fld id="{1DD2DB82-DD64-4A22-A25C-3AAF235E0496}" type="slidenum">
+            <a:fld id="{29424E1C-F408-44E5-A5A7-B4DF975DA444}" type="slidenum">
               <a:t>&lt;#&gt;</a:t>
             </a:fld>
           </a:p>
@@ -983,7 +983,7 @@
         <p:spPr>
           <a:xfrm>
             <a:off x="504000" y="226080"/>
-            <a:ext cx="9070200" cy="945000"/>
+            <a:ext cx="9069840" cy="944640"/>
           </a:xfrm>
           <a:prstGeom prst="rect">
             <a:avLst/>
@@ -1020,7 +1020,7 @@
         <p:spPr>
           <a:xfrm>
             <a:off x="504000" y="1326600"/>
-            <a:ext cx="9070920" cy="3287520"/>
+            <a:ext cx="9070560" cy="3287160"/>
           </a:xfrm>
           <a:prstGeom prst="rect">
             <a:avLst/>
@@ -1078,7 +1078,7 @@
         <p:txBody>
           <a:bodyPr/>
           <a:p>
-            <a:fld id="{0239A562-0392-475B-9BAB-1202569A967C}" type="slidenum">
+            <a:fld id="{392189D8-EAD9-4E86-ACC6-2D7F81CFA935}" type="slidenum">
               <a:t>&lt;#&gt;</a:t>
             </a:fld>
           </a:p>
@@ -1140,7 +1140,7 @@
         <p:spPr>
           <a:xfrm>
             <a:off x="504000" y="226080"/>
-            <a:ext cx="9070200" cy="945000"/>
+            <a:ext cx="9069840" cy="944640"/>
           </a:xfrm>
           <a:prstGeom prst="rect">
             <a:avLst/>
@@ -1177,7 +1177,7 @@
         <p:spPr>
           <a:xfrm>
             <a:off x="504000" y="1326600"/>
-            <a:ext cx="9070920" cy="3287520"/>
+            <a:ext cx="9070560" cy="3287160"/>
           </a:xfrm>
           <a:prstGeom prst="rect">
             <a:avLst/>
@@ -1232,7 +1232,7 @@
         <p:txBody>
           <a:bodyPr/>
           <a:p>
-            <a:fld id="{142DD63F-BE4E-4B91-98E8-AFF26D4A91ED}" type="slidenum">
+            <a:fld id="{3B29609F-92F2-463F-92EB-DC6627D7DD69}" type="slidenum">
               <a:t>&lt;#&gt;</a:t>
             </a:fld>
           </a:p>
@@ -1294,7 +1294,7 @@
         <p:spPr>
           <a:xfrm>
             <a:off x="504000" y="226080"/>
-            <a:ext cx="9070200" cy="945000"/>
+            <a:ext cx="9069840" cy="944640"/>
           </a:xfrm>
           <a:prstGeom prst="rect">
             <a:avLst/>
@@ -1331,7 +1331,7 @@
         <p:spPr>
           <a:xfrm>
             <a:off x="504000" y="1326600"/>
-            <a:ext cx="4426560" cy="3287520"/>
+            <a:ext cx="4426200" cy="3287160"/>
           </a:xfrm>
           <a:prstGeom prst="rect">
             <a:avLst/>
@@ -1364,8 +1364,8 @@
         </p:nvSpPr>
         <p:spPr>
           <a:xfrm>
-            <a:off x="5152320" y="1326600"/>
-            <a:ext cx="4426560" cy="3287520"/>
+            <a:off x="5151960" y="1326600"/>
+            <a:ext cx="4426200" cy="3287160"/>
           </a:xfrm>
           <a:prstGeom prst="rect">
             <a:avLst/>
@@ -1420,7 +1420,7 @@
         <p:txBody>
           <a:bodyPr/>
           <a:p>
-            <a:fld id="{192C140D-7739-4C0E-B896-596E1681D6B9}" type="slidenum">
+            <a:fld id="{6AEEEBA2-3070-407B-B76E-FCEF918BC89E}" type="slidenum">
               <a:t>&lt;#&gt;</a:t>
             </a:fld>
           </a:p>
@@ -1482,7 +1482,7 @@
         <p:spPr>
           <a:xfrm>
             <a:off x="504000" y="226080"/>
-            <a:ext cx="9070200" cy="945000"/>
+            <a:ext cx="9069840" cy="944640"/>
           </a:xfrm>
           <a:prstGeom prst="rect">
             <a:avLst/>
@@ -1540,7 +1540,7 @@
         <p:txBody>
           <a:bodyPr/>
           <a:p>
-            <a:fld id="{C20433C0-4BAC-4E1F-8780-6C897D3ED5DF}" type="slidenum">
+            <a:fld id="{BDF0EE9D-C9D6-4C56-A3FD-ED9AD6667776}" type="slidenum">
               <a:t>&lt;#&gt;</a:t>
             </a:fld>
           </a:p>
@@ -1602,7 +1602,7 @@
         <p:spPr>
           <a:xfrm>
             <a:off x="504000" y="226080"/>
-            <a:ext cx="9070200" cy="4381920"/>
+            <a:ext cx="9069840" cy="4380120"/>
           </a:xfrm>
           <a:prstGeom prst="rect">
             <a:avLst/>
@@ -1660,7 +1660,7 @@
         <p:txBody>
           <a:bodyPr/>
           <a:p>
-            <a:fld id="{9D42AE4C-1552-49DB-8D7F-B15CBF389D8A}" type="slidenum">
+            <a:fld id="{643729E3-D240-48C1-AC5F-04E09515C914}" type="slidenum">
               <a:t>&lt;#&gt;</a:t>
             </a:fld>
           </a:p>
@@ -1722,7 +1722,7 @@
         <p:spPr>
           <a:xfrm>
             <a:off x="504000" y="226080"/>
-            <a:ext cx="9070200" cy="945000"/>
+            <a:ext cx="9069840" cy="944640"/>
           </a:xfrm>
           <a:prstGeom prst="rect">
             <a:avLst/>
@@ -1759,7 +1759,7 @@
         <p:spPr>
           <a:xfrm>
             <a:off x="504000" y="1326600"/>
-            <a:ext cx="4426560" cy="1567800"/>
+            <a:ext cx="4426200" cy="1567800"/>
           </a:xfrm>
           <a:prstGeom prst="rect">
             <a:avLst/>
@@ -1792,8 +1792,8 @@
         </p:nvSpPr>
         <p:spPr>
           <a:xfrm>
-            <a:off x="5152320" y="1326600"/>
-            <a:ext cx="4426560" cy="3287520"/>
+            <a:off x="5151960" y="1326600"/>
+            <a:ext cx="4426200" cy="3287160"/>
           </a:xfrm>
           <a:prstGeom prst="rect">
             <a:avLst/>
@@ -1827,7 +1827,7 @@
         <p:spPr>
           <a:xfrm>
             <a:off x="504000" y="3043800"/>
-            <a:ext cx="4426560" cy="1567800"/>
+            <a:ext cx="4426200" cy="1567800"/>
           </a:xfrm>
           <a:prstGeom prst="rect">
             <a:avLst/>
@@ -1882,7 +1882,7 @@
         <p:txBody>
           <a:bodyPr/>
           <a:p>
-            <a:fld id="{44318039-6BCB-4911-9769-35D1FAEC19CB}" type="slidenum">
+            <a:fld id="{26AE03DC-6530-46A4-9FBD-49947EBFBEC2}" type="slidenum">
               <a:t>&lt;#&gt;</a:t>
             </a:fld>
           </a:p>
@@ -1944,7 +1944,7 @@
         <p:spPr>
           <a:xfrm>
             <a:off x="504000" y="226080"/>
-            <a:ext cx="9070200" cy="945000"/>
+            <a:ext cx="9069840" cy="944640"/>
           </a:xfrm>
           <a:prstGeom prst="rect">
             <a:avLst/>
@@ -1981,7 +1981,7 @@
         <p:spPr>
           <a:xfrm>
             <a:off x="504000" y="1326600"/>
-            <a:ext cx="9070920" cy="3287520"/>
+            <a:ext cx="9070560" cy="3287160"/>
           </a:xfrm>
           <a:prstGeom prst="rect">
             <a:avLst/>
@@ -2039,7 +2039,7 @@
         <p:txBody>
           <a:bodyPr/>
           <a:p>
-            <a:fld id="{CBF89B17-57A6-4916-9FD0-BB13085D06EB}" type="slidenum">
+            <a:fld id="{D8F22E80-5110-41A1-9288-A140E15E09B9}" type="slidenum">
               <a:t>&lt;#&gt;</a:t>
             </a:fld>
           </a:p>
@@ -2101,7 +2101,7 @@
         <p:spPr>
           <a:xfrm>
             <a:off x="504000" y="226080"/>
-            <a:ext cx="9070200" cy="945000"/>
+            <a:ext cx="9069840" cy="944640"/>
           </a:xfrm>
           <a:prstGeom prst="rect">
             <a:avLst/>
@@ -2138,7 +2138,7 @@
         <p:spPr>
           <a:xfrm>
             <a:off x="504000" y="1326600"/>
-            <a:ext cx="4426560" cy="3287520"/>
+            <a:ext cx="4426200" cy="3287160"/>
           </a:xfrm>
           <a:prstGeom prst="rect">
             <a:avLst/>
@@ -2171,8 +2171,8 @@
         </p:nvSpPr>
         <p:spPr>
           <a:xfrm>
-            <a:off x="5152320" y="1326600"/>
-            <a:ext cx="4426560" cy="1567800"/>
+            <a:off x="5151960" y="1326600"/>
+            <a:ext cx="4426200" cy="1567800"/>
           </a:xfrm>
           <a:prstGeom prst="rect">
             <a:avLst/>
@@ -2205,8 +2205,8 @@
         </p:nvSpPr>
         <p:spPr>
           <a:xfrm>
-            <a:off x="5152320" y="3043800"/>
-            <a:ext cx="4426560" cy="1567800"/>
+            <a:off x="5151960" y="3043800"/>
+            <a:ext cx="4426200" cy="1567800"/>
           </a:xfrm>
           <a:prstGeom prst="rect">
             <a:avLst/>
@@ -2261,7 +2261,7 @@
         <p:txBody>
           <a:bodyPr/>
           <a:p>
-            <a:fld id="{AE07F5E8-18EB-4060-8216-FD67302B4914}" type="slidenum">
+            <a:fld id="{3DFF3226-3551-495A-95FF-7448F89AD14E}" type="slidenum">
               <a:t>&lt;#&gt;</a:t>
             </a:fld>
           </a:p>
@@ -2323,7 +2323,7 @@
         <p:spPr>
           <a:xfrm>
             <a:off x="504000" y="226080"/>
-            <a:ext cx="9070200" cy="945000"/>
+            <a:ext cx="9069840" cy="944640"/>
           </a:xfrm>
           <a:prstGeom prst="rect">
             <a:avLst/>
@@ -2360,7 +2360,7 @@
         <p:spPr>
           <a:xfrm>
             <a:off x="504000" y="1326600"/>
-            <a:ext cx="4426560" cy="1567800"/>
+            <a:ext cx="4426200" cy="1567800"/>
           </a:xfrm>
           <a:prstGeom prst="rect">
             <a:avLst/>
@@ -2393,8 +2393,8 @@
         </p:nvSpPr>
         <p:spPr>
           <a:xfrm>
-            <a:off x="5152320" y="1326600"/>
-            <a:ext cx="4426560" cy="1567800"/>
+            <a:off x="5151960" y="1326600"/>
+            <a:ext cx="4426200" cy="1567800"/>
           </a:xfrm>
           <a:prstGeom prst="rect">
             <a:avLst/>
@@ -2428,7 +2428,7 @@
         <p:spPr>
           <a:xfrm>
             <a:off x="504000" y="3043800"/>
-            <a:ext cx="9070920" cy="1567800"/>
+            <a:ext cx="9070560" cy="1567800"/>
           </a:xfrm>
           <a:prstGeom prst="rect">
             <a:avLst/>
@@ -2483,7 +2483,7 @@
         <p:txBody>
           <a:bodyPr/>
           <a:p>
-            <a:fld id="{C93F5D9D-1B9C-4C11-8A60-2289CA734AF6}" type="slidenum">
+            <a:fld id="{8571C1C1-B98D-4541-BF1F-898B46AC0E11}" type="slidenum">
               <a:t>&lt;#&gt;</a:t>
             </a:fld>
           </a:p>
@@ -2545,7 +2545,7 @@
         <p:spPr>
           <a:xfrm>
             <a:off x="504000" y="226080"/>
-            <a:ext cx="9070200" cy="945000"/>
+            <a:ext cx="9069840" cy="944640"/>
           </a:xfrm>
           <a:prstGeom prst="rect">
             <a:avLst/>
@@ -2582,7 +2582,7 @@
         <p:spPr>
           <a:xfrm>
             <a:off x="504000" y="1326600"/>
-            <a:ext cx="9070920" cy="1567800"/>
+            <a:ext cx="9070560" cy="1567800"/>
           </a:xfrm>
           <a:prstGeom prst="rect">
             <a:avLst/>
@@ -2616,7 +2616,7 @@
         <p:spPr>
           <a:xfrm>
             <a:off x="504000" y="3043800"/>
-            <a:ext cx="9070920" cy="1567800"/>
+            <a:ext cx="9070560" cy="1567800"/>
           </a:xfrm>
           <a:prstGeom prst="rect">
             <a:avLst/>
@@ -2671,7 +2671,7 @@
         <p:txBody>
           <a:bodyPr/>
           <a:p>
-            <a:fld id="{6BFA7730-DC7D-420E-9863-A3AFA29F4B0E}" type="slidenum">
+            <a:fld id="{18633827-38AD-4C99-8513-CCDE762DA7EF}" type="slidenum">
               <a:t>&lt;#&gt;</a:t>
             </a:fld>
           </a:p>
@@ -2733,7 +2733,7 @@
         <p:spPr>
           <a:xfrm>
             <a:off x="504000" y="226080"/>
-            <a:ext cx="9070200" cy="945000"/>
+            <a:ext cx="9069840" cy="944640"/>
           </a:xfrm>
           <a:prstGeom prst="rect">
             <a:avLst/>
@@ -2770,7 +2770,7 @@
         <p:spPr>
           <a:xfrm>
             <a:off x="504000" y="1326600"/>
-            <a:ext cx="4426560" cy="1567800"/>
+            <a:ext cx="4426200" cy="1567800"/>
           </a:xfrm>
           <a:prstGeom prst="rect">
             <a:avLst/>
@@ -2803,8 +2803,8 @@
         </p:nvSpPr>
         <p:spPr>
           <a:xfrm>
-            <a:off x="5152320" y="1326600"/>
-            <a:ext cx="4426560" cy="1567800"/>
+            <a:off x="5151960" y="1326600"/>
+            <a:ext cx="4426200" cy="1567800"/>
           </a:xfrm>
           <a:prstGeom prst="rect">
             <a:avLst/>
@@ -2838,7 +2838,7 @@
         <p:spPr>
           <a:xfrm>
             <a:off x="504000" y="3043800"/>
-            <a:ext cx="4426560" cy="1567800"/>
+            <a:ext cx="4426200" cy="1567800"/>
           </a:xfrm>
           <a:prstGeom prst="rect">
             <a:avLst/>
@@ -2871,8 +2871,8 @@
         </p:nvSpPr>
         <p:spPr>
           <a:xfrm>
-            <a:off x="5152320" y="3043800"/>
-            <a:ext cx="4426560" cy="1567800"/>
+            <a:off x="5151960" y="3043800"/>
+            <a:ext cx="4426200" cy="1567800"/>
           </a:xfrm>
           <a:prstGeom prst="rect">
             <a:avLst/>
@@ -2927,7 +2927,7 @@
         <p:txBody>
           <a:bodyPr/>
           <a:p>
-            <a:fld id="{DABC5BC5-8CA9-46C6-941A-9DC7F69CAD7D}" type="slidenum">
+            <a:fld id="{693FED6A-5870-487C-9366-CEC72D8D3A16}" type="slidenum">
               <a:t>&lt;#&gt;</a:t>
             </a:fld>
           </a:p>
@@ -2989,7 +2989,7 @@
         <p:spPr>
           <a:xfrm>
             <a:off x="504000" y="226080"/>
-            <a:ext cx="9070200" cy="945000"/>
+            <a:ext cx="9069840" cy="944640"/>
           </a:xfrm>
           <a:prstGeom prst="rect">
             <a:avLst/>
@@ -3026,7 +3026,7 @@
         <p:spPr>
           <a:xfrm>
             <a:off x="504000" y="1326600"/>
-            <a:ext cx="2920680" cy="1567800"/>
+            <a:ext cx="2920320" cy="1567800"/>
           </a:xfrm>
           <a:prstGeom prst="rect">
             <a:avLst/>
@@ -3059,8 +3059,8 @@
         </p:nvSpPr>
         <p:spPr>
           <a:xfrm>
-            <a:off x="3571200" y="1326600"/>
-            <a:ext cx="2920680" cy="1567800"/>
+            <a:off x="3570840" y="1326600"/>
+            <a:ext cx="2920320" cy="1567800"/>
           </a:xfrm>
           <a:prstGeom prst="rect">
             <a:avLst/>
@@ -3093,8 +3093,8 @@
         </p:nvSpPr>
         <p:spPr>
           <a:xfrm>
-            <a:off x="6638040" y="1326600"/>
-            <a:ext cx="2920680" cy="1567800"/>
+            <a:off x="6637320" y="1326600"/>
+            <a:ext cx="2920320" cy="1567800"/>
           </a:xfrm>
           <a:prstGeom prst="rect">
             <a:avLst/>
@@ -3128,7 +3128,7 @@
         <p:spPr>
           <a:xfrm>
             <a:off x="504000" y="3043800"/>
-            <a:ext cx="2920680" cy="1567800"/>
+            <a:ext cx="2920320" cy="1567800"/>
           </a:xfrm>
           <a:prstGeom prst="rect">
             <a:avLst/>
@@ -3161,8 +3161,8 @@
         </p:nvSpPr>
         <p:spPr>
           <a:xfrm>
-            <a:off x="3571200" y="3043800"/>
-            <a:ext cx="2920680" cy="1567800"/>
+            <a:off x="3570840" y="3043800"/>
+            <a:ext cx="2920320" cy="1567800"/>
           </a:xfrm>
           <a:prstGeom prst="rect">
             <a:avLst/>
@@ -3195,8 +3195,8 @@
         </p:nvSpPr>
         <p:spPr>
           <a:xfrm>
-            <a:off x="6638040" y="3043800"/>
-            <a:ext cx="2920680" cy="1567800"/>
+            <a:off x="6637320" y="3043800"/>
+            <a:ext cx="2920320" cy="1567800"/>
           </a:xfrm>
           <a:prstGeom prst="rect">
             <a:avLst/>
@@ -3251,7 +3251,7 @@
         <p:txBody>
           <a:bodyPr/>
           <a:p>
-            <a:fld id="{4E9FFFC2-8B00-43E5-9BBB-EA310C042608}" type="slidenum">
+            <a:fld id="{17C08AA6-03FA-4553-9113-5D66B49FACA0}" type="slidenum">
               <a:t>&lt;#&gt;</a:t>
             </a:fld>
           </a:p>
@@ -3313,7 +3313,7 @@
         <p:spPr>
           <a:xfrm>
             <a:off x="504000" y="226080"/>
-            <a:ext cx="9070200" cy="945000"/>
+            <a:ext cx="9069840" cy="944640"/>
           </a:xfrm>
           <a:prstGeom prst="rect">
             <a:avLst/>
@@ -3350,7 +3350,7 @@
         <p:spPr>
           <a:xfrm>
             <a:off x="504000" y="1326600"/>
-            <a:ext cx="9070920" cy="3287520"/>
+            <a:ext cx="9070560" cy="3287160"/>
           </a:xfrm>
           <a:prstGeom prst="rect">
             <a:avLst/>
@@ -3405,7 +3405,7 @@
         <p:txBody>
           <a:bodyPr/>
           <a:p>
-            <a:fld id="{B427A34C-F292-475D-B44B-0D7201C03070}" type="slidenum">
+            <a:fld id="{EED061CD-08A0-4B4D-A418-FA9737B79947}" type="slidenum">
               <a:t>&lt;#&gt;</a:t>
             </a:fld>
           </a:p>
@@ -3467,7 +3467,7 @@
         <p:spPr>
           <a:xfrm>
             <a:off x="504000" y="226080"/>
-            <a:ext cx="9070200" cy="945000"/>
+            <a:ext cx="9069840" cy="944640"/>
           </a:xfrm>
           <a:prstGeom prst="rect">
             <a:avLst/>
@@ -3504,7 +3504,7 @@
         <p:spPr>
           <a:xfrm>
             <a:off x="504000" y="1326600"/>
-            <a:ext cx="4426560" cy="3287520"/>
+            <a:ext cx="4426200" cy="3287160"/>
           </a:xfrm>
           <a:prstGeom prst="rect">
             <a:avLst/>
@@ -3537,8 +3537,8 @@
         </p:nvSpPr>
         <p:spPr>
           <a:xfrm>
-            <a:off x="5152320" y="1326600"/>
-            <a:ext cx="4426560" cy="3287520"/>
+            <a:off x="5151960" y="1326600"/>
+            <a:ext cx="4426200" cy="3287160"/>
           </a:xfrm>
           <a:prstGeom prst="rect">
             <a:avLst/>
@@ -3593,7 +3593,7 @@
         <p:txBody>
           <a:bodyPr/>
           <a:p>
-            <a:fld id="{21D2472C-1F1A-4817-BB92-A01624595D2A}" type="slidenum">
+            <a:fld id="{9C3F1BA3-B44C-4E52-B7CD-3203B82B30B4}" type="slidenum">
               <a:t>&lt;#&gt;</a:t>
             </a:fld>
           </a:p>
@@ -3655,7 +3655,7 @@
         <p:spPr>
           <a:xfrm>
             <a:off x="504000" y="226080"/>
-            <a:ext cx="9070200" cy="945000"/>
+            <a:ext cx="9069840" cy="944640"/>
           </a:xfrm>
           <a:prstGeom prst="rect">
             <a:avLst/>
@@ -3713,7 +3713,7 @@
         <p:txBody>
           <a:bodyPr/>
           <a:p>
-            <a:fld id="{2BB34AC6-E0B5-4FD7-86CB-AF87E9DE0EAF}" type="slidenum">
+            <a:fld id="{A5FA5C6F-5C8D-467D-BC6F-CB139E94D195}" type="slidenum">
               <a:t>&lt;#&gt;</a:t>
             </a:fld>
           </a:p>
@@ -3775,7 +3775,7 @@
         <p:spPr>
           <a:xfrm>
             <a:off x="504000" y="226080"/>
-            <a:ext cx="9070200" cy="4381920"/>
+            <a:ext cx="9069840" cy="4380120"/>
           </a:xfrm>
           <a:prstGeom prst="rect">
             <a:avLst/>
@@ -3833,7 +3833,7 @@
         <p:txBody>
           <a:bodyPr/>
           <a:p>
-            <a:fld id="{E95095FB-AB5F-453E-A09E-50690D97443F}" type="slidenum">
+            <a:fld id="{7EDF8782-4A4E-4308-9528-E1CE3098AF79}" type="slidenum">
               <a:t>&lt;#&gt;</a:t>
             </a:fld>
           </a:p>
@@ -3895,7 +3895,7 @@
         <p:spPr>
           <a:xfrm>
             <a:off x="504000" y="226080"/>
-            <a:ext cx="9070200" cy="945000"/>
+            <a:ext cx="9069840" cy="944640"/>
           </a:xfrm>
           <a:prstGeom prst="rect">
             <a:avLst/>
@@ -3932,7 +3932,7 @@
         <p:spPr>
           <a:xfrm>
             <a:off x="504000" y="1326600"/>
-            <a:ext cx="4426560" cy="1567800"/>
+            <a:ext cx="4426200" cy="1567800"/>
           </a:xfrm>
           <a:prstGeom prst="rect">
             <a:avLst/>
@@ -3965,8 +3965,8 @@
         </p:nvSpPr>
         <p:spPr>
           <a:xfrm>
-            <a:off x="5152320" y="1326600"/>
-            <a:ext cx="4426560" cy="3287520"/>
+            <a:off x="5151960" y="1326600"/>
+            <a:ext cx="4426200" cy="3287160"/>
           </a:xfrm>
           <a:prstGeom prst="rect">
             <a:avLst/>
@@ -4000,7 +4000,7 @@
         <p:spPr>
           <a:xfrm>
             <a:off x="504000" y="3043800"/>
-            <a:ext cx="4426560" cy="1567800"/>
+            <a:ext cx="4426200" cy="1567800"/>
           </a:xfrm>
           <a:prstGeom prst="rect">
             <a:avLst/>
@@ -4055,7 +4055,7 @@
         <p:txBody>
           <a:bodyPr/>
           <a:p>
-            <a:fld id="{B01EA222-961E-4239-803A-23F3CD6CAC51}" type="slidenum">
+            <a:fld id="{AEE876ED-96F9-4D5A-8687-AA265553EA72}" type="slidenum">
               <a:t>&lt;#&gt;</a:t>
             </a:fld>
           </a:p>
@@ -4117,7 +4117,7 @@
         <p:spPr>
           <a:xfrm>
             <a:off x="504000" y="226080"/>
-            <a:ext cx="9070200" cy="945000"/>
+            <a:ext cx="9069840" cy="944640"/>
           </a:xfrm>
           <a:prstGeom prst="rect">
             <a:avLst/>
@@ -4154,7 +4154,7 @@
         <p:spPr>
           <a:xfrm>
             <a:off x="504000" y="1326600"/>
-            <a:ext cx="4426560" cy="3287520"/>
+            <a:ext cx="4426200" cy="3287160"/>
           </a:xfrm>
           <a:prstGeom prst="rect">
             <a:avLst/>
@@ -4187,8 +4187,8 @@
         </p:nvSpPr>
         <p:spPr>
           <a:xfrm>
-            <a:off x="5152320" y="1326600"/>
-            <a:ext cx="4426560" cy="1567800"/>
+            <a:off x="5151960" y="1326600"/>
+            <a:ext cx="4426200" cy="1567800"/>
           </a:xfrm>
           <a:prstGeom prst="rect">
             <a:avLst/>
@@ -4221,8 +4221,8 @@
         </p:nvSpPr>
         <p:spPr>
           <a:xfrm>
-            <a:off x="5152320" y="3043800"/>
-            <a:ext cx="4426560" cy="1567800"/>
+            <a:off x="5151960" y="3043800"/>
+            <a:ext cx="4426200" cy="1567800"/>
           </a:xfrm>
           <a:prstGeom prst="rect">
             <a:avLst/>
@@ -4277,7 +4277,7 @@
         <p:txBody>
           <a:bodyPr/>
           <a:p>
-            <a:fld id="{6284EDAB-8A5D-4292-BC9A-FB39F5C8CCE4}" type="slidenum">
+            <a:fld id="{4C6E4C08-B1F9-4B80-B743-F11F19A96C67}" type="slidenum">
               <a:t>&lt;#&gt;</a:t>
             </a:fld>
           </a:p>
@@ -4339,7 +4339,7 @@
         <p:spPr>
           <a:xfrm>
             <a:off x="504000" y="226080"/>
-            <a:ext cx="9070200" cy="945000"/>
+            <a:ext cx="9069840" cy="944640"/>
           </a:xfrm>
           <a:prstGeom prst="rect">
             <a:avLst/>
@@ -4376,7 +4376,7 @@
         <p:spPr>
           <a:xfrm>
             <a:off x="504000" y="1326600"/>
-            <a:ext cx="4426560" cy="1567800"/>
+            <a:ext cx="4426200" cy="1567800"/>
           </a:xfrm>
           <a:prstGeom prst="rect">
             <a:avLst/>
@@ -4409,8 +4409,8 @@
         </p:nvSpPr>
         <p:spPr>
           <a:xfrm>
-            <a:off x="5152320" y="1326600"/>
-            <a:ext cx="4426560" cy="1567800"/>
+            <a:off x="5151960" y="1326600"/>
+            <a:ext cx="4426200" cy="1567800"/>
           </a:xfrm>
           <a:prstGeom prst="rect">
             <a:avLst/>
@@ -4444,7 +4444,7 @@
         <p:spPr>
           <a:xfrm>
             <a:off x="504000" y="3043800"/>
-            <a:ext cx="9070920" cy="1567800"/>
+            <a:ext cx="9070560" cy="1567800"/>
           </a:xfrm>
           <a:prstGeom prst="rect">
             <a:avLst/>
@@ -4499,7 +4499,7 @@
         <p:txBody>
           <a:bodyPr/>
           <a:p>
-            <a:fld id="{725F6162-0748-4559-913C-70E3F92C97FA}" type="slidenum">
+            <a:fld id="{FACC9C2B-A0E5-45A7-8743-475D2723CF8B}" type="slidenum">
               <a:t>&lt;#&gt;</a:t>
             </a:fld>
           </a:p>
@@ -4561,7 +4561,7 @@
         <p:spPr>
           <a:xfrm>
             <a:off x="504000" y="226080"/>
-            <a:ext cx="9070200" cy="945000"/>
+            <a:ext cx="9069840" cy="944640"/>
           </a:xfrm>
           <a:prstGeom prst="rect">
             <a:avLst/>
@@ -4601,7 +4601,7 @@
         <p:spPr>
           <a:xfrm>
             <a:off x="3447360" y="5165280"/>
-            <a:ext cx="3193560" cy="389160"/>
+            <a:ext cx="3193200" cy="388800"/>
           </a:xfrm>
           <a:prstGeom prst="rect">
             <a:avLst/>
@@ -4670,7 +4670,7 @@
         <p:spPr>
           <a:xfrm>
             <a:off x="7227360" y="5165280"/>
-            <a:ext cx="2346840" cy="389160"/>
+            <a:ext cx="2346480" cy="388800"/>
           </a:xfrm>
           <a:prstGeom prst="rect">
             <a:avLst/>
@@ -4711,7 +4711,7 @@
                 <a:tab algn="l" pos="0"/>
               </a:tabLst>
             </a:pPr>
-            <a:fld id="{18584F4E-10C1-44D7-BA52-AD9143C62B29}" type="slidenum">
+            <a:fld id="{B6294A38-7487-4962-B9AE-5981B6151430}" type="slidenum">
               <a:rPr b="0" lang="en-US" sz="1400" spc="-1" strike="noStrike">
                 <a:solidFill>
                   <a:srgbClr val="000000"/>
@@ -4739,7 +4739,7 @@
         <p:spPr>
           <a:xfrm>
             <a:off x="504000" y="5165280"/>
-            <a:ext cx="2346840" cy="389160"/>
+            <a:ext cx="2346480" cy="388800"/>
           </a:xfrm>
           <a:prstGeom prst="rect">
             <a:avLst/>
@@ -5006,7 +5006,7 @@
         <p:spPr>
           <a:xfrm>
             <a:off x="504000" y="226080"/>
-            <a:ext cx="9070200" cy="945000"/>
+            <a:ext cx="9069840" cy="944640"/>
           </a:xfrm>
           <a:prstGeom prst="rect">
             <a:avLst/>
@@ -5025,211 +5025,7 @@
               <a:rPr b="0" lang="en-US" sz="1800" spc="-1" strike="noStrike">
                 <a:latin typeface="Arial"/>
               </a:rPr>
-              <a:t>C</a:t>
-            </a:r>
-            <a:r>
-              <a:rPr b="0" lang="en-US" sz="1800" spc="-1" strike="noStrike">
-                <a:latin typeface="Arial"/>
-              </a:rPr>
-              <a:t>l</a:t>
-            </a:r>
-            <a:r>
-              <a:rPr b="0" lang="en-US" sz="1800" spc="-1" strike="noStrike">
-                <a:latin typeface="Arial"/>
-              </a:rPr>
-              <a:t>i</a:t>
-            </a:r>
-            <a:r>
-              <a:rPr b="0" lang="en-US" sz="1800" spc="-1" strike="noStrike">
-                <a:latin typeface="Arial"/>
-              </a:rPr>
-              <a:t>c</a:t>
-            </a:r>
-            <a:r>
-              <a:rPr b="0" lang="en-US" sz="1800" spc="-1" strike="noStrike">
-                <a:latin typeface="Arial"/>
-              </a:rPr>
-              <a:t>k</a:t>
-            </a:r>
-            <a:r>
-              <a:rPr b="0" lang="en-US" sz="1800" spc="-1" strike="noStrike">
-                <a:latin typeface="Arial"/>
-              </a:rPr>
-              <a:t> </a:t>
-            </a:r>
-            <a:r>
-              <a:rPr b="0" lang="en-US" sz="1800" spc="-1" strike="noStrike">
-                <a:latin typeface="Arial"/>
-              </a:rPr>
-              <a:t>t</a:t>
-            </a:r>
-            <a:r>
-              <a:rPr b="0" lang="en-US" sz="1800" spc="-1" strike="noStrike">
-                <a:latin typeface="Arial"/>
-              </a:rPr>
-              <a:t>o</a:t>
-            </a:r>
-            <a:r>
-              <a:rPr b="0" lang="en-US" sz="1800" spc="-1" strike="noStrike">
-                <a:latin typeface="Arial"/>
-              </a:rPr>
-              <a:t> </a:t>
-            </a:r>
-            <a:r>
-              <a:rPr b="0" lang="en-US" sz="1800" spc="-1" strike="noStrike">
-                <a:latin typeface="Arial"/>
-              </a:rPr>
-              <a:t>e</a:t>
-            </a:r>
-            <a:r>
-              <a:rPr b="0" lang="en-US" sz="1800" spc="-1" strike="noStrike">
-                <a:latin typeface="Arial"/>
-              </a:rPr>
-              <a:t>d</a:t>
-            </a:r>
-            <a:r>
-              <a:rPr b="0" lang="en-US" sz="1800" spc="-1" strike="noStrike">
-                <a:latin typeface="Arial"/>
-              </a:rPr>
-              <a:t>i</a:t>
-            </a:r>
-            <a:r>
-              <a:rPr b="0" lang="en-US" sz="1800" spc="-1" strike="noStrike">
-                <a:latin typeface="Arial"/>
-              </a:rPr>
-              <a:t>t</a:t>
-            </a:r>
-            <a:r>
-              <a:rPr b="0" lang="en-US" sz="1800" spc="-1" strike="noStrike">
-                <a:latin typeface="Arial"/>
-              </a:rPr>
-              <a:t> </a:t>
-            </a:r>
-            <a:r>
-              <a:rPr b="0" lang="en-US" sz="1800" spc="-1" strike="noStrike">
-                <a:latin typeface="Arial"/>
-              </a:rPr>
-              <a:t>t</a:t>
-            </a:r>
-            <a:r>
-              <a:rPr b="0" lang="en-US" sz="1800" spc="-1" strike="noStrike">
-                <a:latin typeface="Arial"/>
-              </a:rPr>
-              <a:t>h</a:t>
-            </a:r>
-            <a:r>
-              <a:rPr b="0" lang="en-US" sz="1800" spc="-1" strike="noStrike">
-                <a:latin typeface="Arial"/>
-              </a:rPr>
-              <a:t>e</a:t>
-            </a:r>
-            <a:r>
-              <a:rPr b="0" lang="en-US" sz="1800" spc="-1" strike="noStrike">
-                <a:latin typeface="Arial"/>
-              </a:rPr>
-              <a:t> </a:t>
-            </a:r>
-            <a:r>
-              <a:rPr b="0" lang="en-US" sz="1800" spc="-1" strike="noStrike">
-                <a:latin typeface="Arial"/>
-              </a:rPr>
-              <a:t>t</a:t>
-            </a:r>
-            <a:r>
-              <a:rPr b="0" lang="en-US" sz="1800" spc="-1" strike="noStrike">
-                <a:latin typeface="Arial"/>
-              </a:rPr>
-              <a:t>i</a:t>
-            </a:r>
-            <a:r>
-              <a:rPr b="0" lang="en-US" sz="1800" spc="-1" strike="noStrike">
-                <a:latin typeface="Arial"/>
-              </a:rPr>
-              <a:t>t</a:t>
-            </a:r>
-            <a:r>
-              <a:rPr b="0" lang="en-US" sz="1800" spc="-1" strike="noStrike">
-                <a:latin typeface="Arial"/>
-              </a:rPr>
-              <a:t>l</a:t>
-            </a:r>
-            <a:r>
-              <a:rPr b="0" lang="en-US" sz="1800" spc="-1" strike="noStrike">
-                <a:latin typeface="Arial"/>
-              </a:rPr>
-              <a:t>e</a:t>
-            </a:r>
-            <a:r>
-              <a:rPr b="0" lang="en-US" sz="1800" spc="-1" strike="noStrike">
-                <a:latin typeface="Arial"/>
-              </a:rPr>
-              <a:t> </a:t>
-            </a:r>
-            <a:r>
-              <a:rPr b="0" lang="en-US" sz="1800" spc="-1" strike="noStrike">
-                <a:latin typeface="Arial"/>
-              </a:rPr>
-              <a:t>t</a:t>
-            </a:r>
-            <a:r>
-              <a:rPr b="0" lang="en-US" sz="1800" spc="-1" strike="noStrike">
-                <a:latin typeface="Arial"/>
-              </a:rPr>
-              <a:t>e</a:t>
-            </a:r>
-            <a:r>
-              <a:rPr b="0" lang="en-US" sz="1800" spc="-1" strike="noStrike">
-                <a:latin typeface="Arial"/>
-              </a:rPr>
-              <a:t>x</a:t>
-            </a:r>
-            <a:r>
-              <a:rPr b="0" lang="en-US" sz="1800" spc="-1" strike="noStrike">
-                <a:latin typeface="Arial"/>
-              </a:rPr>
-              <a:t>t</a:t>
-            </a:r>
-            <a:r>
-              <a:rPr b="0" lang="en-US" sz="1800" spc="-1" strike="noStrike">
-                <a:latin typeface="Arial"/>
-              </a:rPr>
-              <a:t> </a:t>
-            </a:r>
-            <a:r>
-              <a:rPr b="0" lang="en-US" sz="1800" spc="-1" strike="noStrike">
-                <a:latin typeface="Arial"/>
-              </a:rPr>
-              <a:t>f</a:t>
-            </a:r>
-            <a:r>
-              <a:rPr b="0" lang="en-US" sz="1800" spc="-1" strike="noStrike">
-                <a:latin typeface="Arial"/>
-              </a:rPr>
-              <a:t>o</a:t>
-            </a:r>
-            <a:r>
-              <a:rPr b="0" lang="en-US" sz="1800" spc="-1" strike="noStrike">
-                <a:latin typeface="Arial"/>
-              </a:rPr>
-              <a:t>r</a:t>
-            </a:r>
-            <a:r>
-              <a:rPr b="0" lang="en-US" sz="1800" spc="-1" strike="noStrike">
-                <a:latin typeface="Arial"/>
-              </a:rPr>
-              <a:t>m</a:t>
-            </a:r>
-            <a:r>
-              <a:rPr b="0" lang="en-US" sz="1800" spc="-1" strike="noStrike">
-                <a:latin typeface="Arial"/>
-              </a:rPr>
-              <a:t>a</a:t>
-            </a:r>
-            <a:r>
-              <a:rPr b="0" lang="en-US" sz="1800" spc="-1" strike="noStrike">
-                <a:latin typeface="Arial"/>
-              </a:rPr>
-              <a:t>t</a:t>
+              <a:t>Click to edit the title text format</a:t>
             </a:r>
             <a:endParaRPr b="0" lang="en-US" sz="1800" spc="-1" strike="noStrike">
               <a:latin typeface="Arial"/>
@@ -5250,7 +5046,7 @@
         <p:spPr>
           <a:xfrm>
             <a:off x="504000" y="1326600"/>
-            <a:ext cx="9070920" cy="3287520"/>
+            <a:ext cx="9070560" cy="3287160"/>
           </a:xfrm>
           <a:prstGeom prst="rect">
             <a:avLst/>
@@ -5433,7 +5229,7 @@
         <p:spPr>
           <a:xfrm>
             <a:off x="3447360" y="5165280"/>
-            <a:ext cx="3193560" cy="389160"/>
+            <a:ext cx="3193200" cy="388800"/>
           </a:xfrm>
           <a:prstGeom prst="rect">
             <a:avLst/>
@@ -5502,7 +5298,7 @@
         <p:spPr>
           <a:xfrm>
             <a:off x="7227360" y="5165280"/>
-            <a:ext cx="2346840" cy="389160"/>
+            <a:ext cx="2346480" cy="388800"/>
           </a:xfrm>
           <a:prstGeom prst="rect">
             <a:avLst/>
@@ -5543,7 +5339,7 @@
                 <a:tab algn="l" pos="0"/>
               </a:tabLst>
             </a:pPr>
-            <a:fld id="{F6860444-0E71-45C8-8178-EBBECD7F5620}" type="slidenum">
+            <a:fld id="{CA3159E3-D80A-44C2-8687-20BA6E8925F5}" type="slidenum">
               <a:rPr b="0" lang="en-US" sz="1400" spc="-1" strike="noStrike">
                 <a:solidFill>
                   <a:srgbClr val="000000"/>
@@ -5571,7 +5367,7 @@
         <p:spPr>
           <a:xfrm>
             <a:off x="504000" y="5165280"/>
-            <a:ext cx="2346840" cy="389160"/>
+            <a:ext cx="2346480" cy="388800"/>
           </a:xfrm>
           <a:prstGeom prst="rect">
             <a:avLst/>
@@ -5655,7 +5451,7 @@
         <p:spPr>
           <a:xfrm>
             <a:off x="3648600" y="1162440"/>
-            <a:ext cx="2522160" cy="3636720"/>
+            <a:ext cx="2521800" cy="3636360"/>
           </a:xfrm>
           <a:prstGeom prst="rect">
             <a:avLst/>
@@ -5703,7 +5499,7 @@
         <p:spPr>
           <a:xfrm>
             <a:off x="6955200" y="3742200"/>
-            <a:ext cx="1776600" cy="344880"/>
+            <a:ext cx="2188800" cy="344520"/>
           </a:xfrm>
           <a:prstGeom prst="rect">
             <a:avLst/>
@@ -5738,8 +5534,19 @@
                 <a:latin typeface="Arial"/>
                 <a:ea typeface="DejaVu Sans"/>
               </a:rPr>
-              <a:t>Monomer name</a:t>
-            </a:r>
+              <a:t>Monomer name </a:t>
+            </a:r>
+            <a:endParaRPr b="0" lang="en-US" sz="1800" spc="-1" strike="noStrike">
+              <a:latin typeface="Arial"/>
+            </a:endParaRPr>
+          </a:p>
+          <a:p>
+            <a:pPr>
+              <a:lnSpc>
+                <a:spcPct val="100000"/>
+              </a:lnSpc>
+              <a:buNone/>
+            </a:pPr>
             <a:endParaRPr b="0" lang="en-US" sz="1800" spc="-1" strike="noStrike">
               <a:latin typeface="Arial"/>
             </a:endParaRPr>
@@ -5782,16 +5589,19 @@
           <p:nvPr/>
         </p:nvSpPr>
         <p:spPr>
-          <a:xfrm>
-            <a:off x="6955560" y="4066200"/>
-            <a:ext cx="1320840" cy="344880"/>
-          </a:xfrm>
-          <a:prstGeom prst="rect">
-            <a:avLst/>
-          </a:prstGeom>
-          <a:noFill/>
-          <a:ln w="0">
-            <a:noFill/>
+          <a:xfrm flipH="1">
+            <a:off x="6142320" y="4534200"/>
+            <a:ext cx="685800" cy="360"/>
+          </a:xfrm>
+          <a:prstGeom prst="line">
+            <a:avLst/>
+          </a:prstGeom>
+          <a:ln w="36720">
+            <a:solidFill>
+              <a:srgbClr val="ff0000"/>
+            </a:solidFill>
+            <a:round/>
+            <a:tailEnd len="med" type="triangle" w="med"/>
           </a:ln>
         </p:spPr>
         <p:style>
@@ -5800,6 +5610,32 @@
           <a:effectRef idx="0"/>
           <a:fontRef idx="minor"/>
         </p:style>
+      </p:sp>
+      <p:sp>
+        <p:nvSpPr>
+          <p:cNvPr id="87" name=""/>
+          <p:cNvSpPr/>
+          <p:nvPr/>
+        </p:nvSpPr>
+        <p:spPr>
+          <a:xfrm>
+            <a:off x="6955200" y="4354200"/>
+            <a:ext cx="2196720" cy="344520"/>
+          </a:xfrm>
+          <a:prstGeom prst="rect">
+            <a:avLst/>
+          </a:prstGeom>
+          <a:noFill/>
+          <a:ln w="0">
+            <a:noFill/>
+          </a:ln>
+        </p:spPr>
+        <p:style>
+          <a:lnRef idx="0"/>
+          <a:fillRef idx="0"/>
+          <a:effectRef idx="0"/>
+          <a:fontRef idx="minor"/>
+        </p:style>
         <p:txBody>
           <a:bodyPr lIns="90000" rIns="90000" tIns="45000" bIns="45000" anchor="t">
             <a:noAutofit/>
@@ -5811,6 +5647,132 @@
               </a:lnSpc>
               <a:buNone/>
             </a:pPr>
+            <a:r>
+              <a:rPr b="0" lang="en-US" sz="1800" spc="-1" strike="noStrike">
+                <a:solidFill>
+                  <a:srgbClr val="000000"/>
+                </a:solidFill>
+                <a:latin typeface="Arial"/>
+                <a:ea typeface="DejaVu Sans"/>
+              </a:rPr>
+              <a:t>3 letter name (PDB)</a:t>
+            </a:r>
+            <a:endParaRPr b="0" lang="en-US" sz="1800" spc="-1" strike="noStrike">
+              <a:latin typeface="Arial"/>
+            </a:endParaRPr>
+          </a:p>
+        </p:txBody>
+      </p:sp>
+      <p:sp>
+        <p:nvSpPr>
+          <p:cNvPr id="88" name=""/>
+          <p:cNvSpPr/>
+          <p:nvPr/>
+        </p:nvSpPr>
+        <p:spPr>
+          <a:xfrm>
+            <a:off x="5871600" y="1143000"/>
+            <a:ext cx="455400" cy="2512800"/>
+          </a:xfrm>
+          <a:prstGeom prst="rect">
+            <a:avLst/>
+          </a:prstGeom>
+          <a:solidFill>
+            <a:srgbClr val="ffffff"/>
+          </a:solidFill>
+          <a:ln w="0">
+            <a:noFill/>
+          </a:ln>
+        </p:spPr>
+        <p:style>
+          <a:lnRef idx="0"/>
+          <a:fillRef idx="0"/>
+          <a:effectRef idx="0"/>
+          <a:fontRef idx="minor"/>
+        </p:style>
+      </p:sp>
+      <p:sp>
+        <p:nvSpPr>
+          <p:cNvPr id="89" name=""/>
+          <p:cNvSpPr/>
+          <p:nvPr/>
+        </p:nvSpPr>
+        <p:spPr>
+          <a:xfrm flipH="1">
+            <a:off x="5257800" y="2514600"/>
+            <a:ext cx="1600200" cy="228600"/>
+          </a:xfrm>
+          <a:prstGeom prst="line">
+            <a:avLst/>
+          </a:prstGeom>
+          <a:ln w="36720">
+            <a:solidFill>
+              <a:srgbClr val="ff0000"/>
+            </a:solidFill>
+            <a:round/>
+            <a:tailEnd len="med" type="triangle" w="med"/>
+          </a:ln>
+        </p:spPr>
+        <p:style>
+          <a:lnRef idx="0"/>
+          <a:fillRef idx="0"/>
+          <a:effectRef idx="0"/>
+          <a:fontRef idx="minor"/>
+        </p:style>
+      </p:sp>
+      <p:sp>
+        <p:nvSpPr>
+          <p:cNvPr id="90" name=""/>
+          <p:cNvSpPr/>
+          <p:nvPr/>
+        </p:nvSpPr>
+        <p:spPr>
+          <a:xfrm flipH="1" flipV="1">
+            <a:off x="5257800" y="2286000"/>
+            <a:ext cx="1609560" cy="239400"/>
+          </a:xfrm>
+          <a:prstGeom prst="line">
+            <a:avLst/>
+          </a:prstGeom>
+          <a:ln w="36720">
+            <a:solidFill>
+              <a:srgbClr val="ff0000"/>
+            </a:solidFill>
+            <a:round/>
+            <a:tailEnd len="med" type="triangle" w="med"/>
+          </a:ln>
+        </p:spPr>
+        <p:style>
+          <a:lnRef idx="0"/>
+          <a:fillRef idx="0"/>
+          <a:effectRef idx="0"/>
+          <a:fontRef idx="minor"/>
+        </p:style>
+      </p:sp>
+      <p:sp>
+        <p:nvSpPr>
+          <p:cNvPr id="91" name=""/>
+          <p:cNvSpPr txBox="1"/>
+          <p:nvPr/>
+        </p:nvSpPr>
+        <p:spPr>
+          <a:xfrm>
+            <a:off x="6955200" y="4101480"/>
+            <a:ext cx="1322280" cy="346680"/>
+          </a:xfrm>
+          <a:prstGeom prst="rect">
+            <a:avLst/>
+          </a:prstGeom>
+          <a:noFill/>
+          <a:ln w="0">
+            <a:noFill/>
+          </a:ln>
+        </p:spPr>
+        <p:txBody>
+          <a:bodyPr lIns="90000" rIns="90000" tIns="45000" bIns="45000" anchor="t">
+            <a:noAutofit/>
+          </a:bodyPr>
+          <a:p>
             <a:r>
               <a:rPr b="0" lang="en-US" sz="1800" spc="-1" strike="noStrike">
                 <a:solidFill>
@@ -5829,43 +5791,14 @@
       </p:sp>
       <p:sp>
         <p:nvSpPr>
-          <p:cNvPr id="87" name=""/>
+          <p:cNvPr id="92" name=""/>
           <p:cNvSpPr/>
           <p:nvPr/>
         </p:nvSpPr>
         <p:spPr>
-          <a:xfrm flipH="1">
-            <a:off x="6142320" y="4534200"/>
-            <a:ext cx="685800" cy="360"/>
-          </a:xfrm>
-          <a:prstGeom prst="line">
-            <a:avLst/>
-          </a:prstGeom>
-          <a:ln w="36720">
-            <a:solidFill>
-              <a:srgbClr val="ff0000"/>
-            </a:solidFill>
-            <a:round/>
-            <a:tailEnd len="med" type="triangle" w="med"/>
-          </a:ln>
-        </p:spPr>
-        <p:style>
-          <a:lnRef idx="0"/>
-          <a:fillRef idx="0"/>
-          <a:effectRef idx="0"/>
-          <a:fontRef idx="minor"/>
-        </p:style>
-      </p:sp>
-      <p:sp>
-        <p:nvSpPr>
-          <p:cNvPr id="88" name=""/>
-          <p:cNvSpPr/>
-          <p:nvPr/>
-        </p:nvSpPr>
-        <p:spPr>
-          <a:xfrm>
-            <a:off x="6955920" y="4354200"/>
-            <a:ext cx="2197080" cy="344880"/>
+          <a:xfrm>
+            <a:off x="6955200" y="2338200"/>
+            <a:ext cx="2188800" cy="344520"/>
           </a:xfrm>
           <a:prstGeom prst="rect">
             <a:avLst/>
@@ -5900,41 +5833,24 @@
                 <a:latin typeface="Arial"/>
                 <a:ea typeface="DejaVu Sans"/>
               </a:rPr>
-              <a:t>3 letter name (PDB)</a:t>
+              <a:t>R-groups</a:t>
             </a:r>
             <a:endParaRPr b="0" lang="en-US" sz="1800" spc="-1" strike="noStrike">
               <a:latin typeface="Arial"/>
             </a:endParaRPr>
           </a:p>
-        </p:txBody>
-      </p:sp>
-      <p:sp>
-        <p:nvSpPr>
-          <p:cNvPr id="89" name=""/>
-          <p:cNvSpPr/>
-          <p:nvPr/>
-        </p:nvSpPr>
-        <p:spPr>
-          <a:xfrm>
-            <a:off x="5871600" y="1143000"/>
-            <a:ext cx="455760" cy="2513160"/>
-          </a:xfrm>
-          <a:prstGeom prst="rect">
-            <a:avLst/>
-          </a:prstGeom>
-          <a:solidFill>
-            <a:srgbClr val="ffffff"/>
-          </a:solidFill>
-          <a:ln w="0">
-            <a:noFill/>
-          </a:ln>
-        </p:spPr>
-        <p:style>
-          <a:lnRef idx="0"/>
-          <a:fillRef idx="0"/>
-          <a:effectRef idx="0"/>
-          <a:fontRef idx="minor"/>
-        </p:style>
+          <a:p>
+            <a:pPr>
+              <a:lnSpc>
+                <a:spcPct val="100000"/>
+              </a:lnSpc>
+              <a:buNone/>
+            </a:pPr>
+            <a:endParaRPr b="0" lang="en-US" sz="1800" spc="-1" strike="noStrike">
+              <a:latin typeface="Arial"/>
+            </a:endParaRPr>
+          </a:p>
+        </p:txBody>
       </p:sp>
     </p:spTree>
   </p:cSld>
@@ -5968,7 +5884,7 @@
       </p:grpSpPr>
       <p:pic>
         <p:nvPicPr>
-          <p:cNvPr id="90" name="" descr=""/>
+          <p:cNvPr id="93" name="" descr=""/>
           <p:cNvPicPr/>
           <p:nvPr/>
         </p:nvPicPr>
@@ -5979,7 +5895,7 @@
         <p:spPr>
           <a:xfrm>
             <a:off x="1371600" y="228600"/>
-            <a:ext cx="5756760" cy="5065920"/>
+            <a:ext cx="5756400" cy="5065560"/>
           </a:xfrm>
           <a:prstGeom prst="rect">
             <a:avLst/>
@@ -5991,14 +5907,14 @@
       </p:pic>
       <p:sp>
         <p:nvSpPr>
-          <p:cNvPr id="91" name=""/>
+          <p:cNvPr id="94" name=""/>
           <p:cNvSpPr/>
           <p:nvPr/>
         </p:nvSpPr>
         <p:spPr>
           <a:xfrm>
             <a:off x="7795800" y="685800"/>
-            <a:ext cx="1347120" cy="345240"/>
+            <a:ext cx="1346760" cy="344880"/>
           </a:xfrm>
           <a:prstGeom prst="rect">
             <a:avLst/>
@@ -6043,14 +5959,14 @@
       </p:sp>
       <p:sp>
         <p:nvSpPr>
-          <p:cNvPr id="92" name=""/>
+          <p:cNvPr id="95" name=""/>
           <p:cNvSpPr/>
           <p:nvPr/>
         </p:nvSpPr>
         <p:spPr>
           <a:xfrm>
             <a:off x="7796160" y="1297800"/>
-            <a:ext cx="1726560" cy="345240"/>
+            <a:ext cx="1726200" cy="344880"/>
           </a:xfrm>
           <a:prstGeom prst="rect">
             <a:avLst/>
@@ -6095,14 +6011,14 @@
       </p:sp>
       <p:sp>
         <p:nvSpPr>
-          <p:cNvPr id="93" name=""/>
+          <p:cNvPr id="96" name=""/>
           <p:cNvSpPr/>
           <p:nvPr/>
         </p:nvSpPr>
         <p:spPr>
           <a:xfrm>
             <a:off x="7796520" y="4177800"/>
-            <a:ext cx="2283480" cy="345240"/>
+            <a:ext cx="2283120" cy="344880"/>
           </a:xfrm>
           <a:prstGeom prst="rect">
             <a:avLst/>
@@ -6147,7 +6063,7 @@
       </p:sp>
       <p:sp>
         <p:nvSpPr>
-          <p:cNvPr id="94" name=""/>
+          <p:cNvPr id="97" name=""/>
           <p:cNvSpPr/>
           <p:nvPr/>
         </p:nvSpPr>
@@ -6176,7 +6092,7 @@
       </p:sp>
       <p:sp>
         <p:nvSpPr>
-          <p:cNvPr id="95" name=""/>
+          <p:cNvPr id="98" name=""/>
           <p:cNvSpPr/>
           <p:nvPr/>
         </p:nvSpPr>
@@ -6205,7 +6121,7 @@
       </p:sp>
       <p:sp>
         <p:nvSpPr>
-          <p:cNvPr id="96" name=""/>
+          <p:cNvPr id="99" name=""/>
           <p:cNvSpPr/>
           <p:nvPr/>
         </p:nvSpPr>
@@ -6234,7 +6150,7 @@
       </p:sp>
       <p:sp>
         <p:nvSpPr>
-          <p:cNvPr id="97" name=""/>
+          <p:cNvPr id="100" name=""/>
           <p:cNvSpPr/>
           <p:nvPr/>
         </p:nvSpPr>
@@ -6263,14 +6179,14 @@
       </p:sp>
       <p:sp>
         <p:nvSpPr>
-          <p:cNvPr id="98" name=""/>
+          <p:cNvPr id="101" name=""/>
           <p:cNvSpPr/>
           <p:nvPr/>
         </p:nvSpPr>
         <p:spPr>
           <a:xfrm>
             <a:off x="7796520" y="2881800"/>
-            <a:ext cx="2032560" cy="1232280"/>
+            <a:ext cx="2032200" cy="1231920"/>
           </a:xfrm>
           <a:prstGeom prst="rect">
             <a:avLst/>
@@ -6315,7 +6231,7 @@
       </p:sp>
       <p:sp>
         <p:nvSpPr>
-          <p:cNvPr id="99" name=""/>
+          <p:cNvPr id="102" name=""/>
           <p:cNvSpPr/>
           <p:nvPr/>
         </p:nvSpPr>
@@ -6345,7 +6261,7 @@
       </p:sp>
       <p:sp>
         <p:nvSpPr>
-          <p:cNvPr id="100" name=""/>
+          <p:cNvPr id="103" name=""/>
           <p:cNvSpPr/>
           <p:nvPr/>
         </p:nvSpPr>
@@ -6405,7 +6321,7 @@
       </p:grpSpPr>
       <p:pic>
         <p:nvPicPr>
-          <p:cNvPr id="101" name="" descr=""/>
+          <p:cNvPr id="104" name="" descr=""/>
           <p:cNvPicPr/>
           <p:nvPr/>
         </p:nvPicPr>
@@ -6416,7 +6332,7 @@
         <p:spPr>
           <a:xfrm>
             <a:off x="565200" y="819000"/>
-            <a:ext cx="6941160" cy="3838320"/>
+            <a:ext cx="6940800" cy="3837960"/>
           </a:xfrm>
           <a:prstGeom prst="rect">
             <a:avLst/>
@@ -6428,7 +6344,7 @@
       </p:pic>
       <p:sp>
         <p:nvSpPr>
-          <p:cNvPr id="102" name=""/>
+          <p:cNvPr id="105" name=""/>
           <p:cNvSpPr/>
           <p:nvPr/>
         </p:nvSpPr>
@@ -6457,14 +6373,14 @@
       </p:sp>
       <p:sp>
         <p:nvSpPr>
-          <p:cNvPr id="103" name=""/>
+          <p:cNvPr id="106" name=""/>
           <p:cNvSpPr/>
           <p:nvPr/>
         </p:nvSpPr>
         <p:spPr>
           <a:xfrm>
             <a:off x="5257800" y="685800"/>
-            <a:ext cx="2284920" cy="4113720"/>
+            <a:ext cx="2284560" cy="4113360"/>
           </a:xfrm>
           <a:prstGeom prst="rect">
             <a:avLst/>
@@ -6486,14 +6402,14 @@
       </p:sp>
       <p:sp>
         <p:nvSpPr>
-          <p:cNvPr id="104" name=""/>
+          <p:cNvPr id="107" name=""/>
           <p:cNvSpPr/>
           <p:nvPr/>
         </p:nvSpPr>
         <p:spPr>
           <a:xfrm>
             <a:off x="8012520" y="2269800"/>
-            <a:ext cx="1206720" cy="601200"/>
+            <a:ext cx="1206360" cy="600840"/>
           </a:xfrm>
           <a:prstGeom prst="rect">
             <a:avLst/>
@@ -6559,7 +6475,7 @@
       </p:sp>
       <p:sp>
         <p:nvSpPr>
-          <p:cNvPr id="105" name=""/>
+          <p:cNvPr id="108" name=""/>
           <p:cNvSpPr/>
           <p:nvPr/>
         </p:nvSpPr>
@@ -6588,14 +6504,14 @@
       </p:sp>
       <p:sp>
         <p:nvSpPr>
-          <p:cNvPr id="106" name=""/>
+          <p:cNvPr id="109" name=""/>
           <p:cNvSpPr/>
           <p:nvPr/>
         </p:nvSpPr>
         <p:spPr>
           <a:xfrm>
             <a:off x="560880" y="361800"/>
-            <a:ext cx="1738800" cy="345240"/>
+            <a:ext cx="1953720" cy="344880"/>
           </a:xfrm>
           <a:prstGeom prst="rect">
             <a:avLst/>
@@ -6640,7 +6556,7 @@
       </p:sp>
       <p:sp>
         <p:nvSpPr>
-          <p:cNvPr id="107" name=""/>
+          <p:cNvPr id="110" name=""/>
           <p:cNvSpPr/>
           <p:nvPr/>
         </p:nvSpPr>
@@ -6669,14 +6585,14 @@
       </p:sp>
       <p:sp>
         <p:nvSpPr>
-          <p:cNvPr id="108" name=""/>
+          <p:cNvPr id="111" name=""/>
           <p:cNvSpPr/>
           <p:nvPr/>
         </p:nvSpPr>
         <p:spPr>
           <a:xfrm>
             <a:off x="2721240" y="361800"/>
-            <a:ext cx="1638000" cy="345240"/>
+            <a:ext cx="1850760" cy="344880"/>
           </a:xfrm>
           <a:prstGeom prst="rect">
             <a:avLst/>
@@ -6721,14 +6637,14 @@
       </p:sp>
       <p:sp>
         <p:nvSpPr>
-          <p:cNvPr id="109" name=""/>
+          <p:cNvPr id="112" name=""/>
           <p:cNvSpPr/>
           <p:nvPr/>
         </p:nvSpPr>
         <p:spPr>
           <a:xfrm>
             <a:off x="885600" y="4789800"/>
-            <a:ext cx="1446120" cy="345240"/>
+            <a:ext cx="1445760" cy="344880"/>
           </a:xfrm>
           <a:prstGeom prst="rect">
             <a:avLst/>
@@ -6773,14 +6689,14 @@
       </p:sp>
       <p:sp>
         <p:nvSpPr>
-          <p:cNvPr id="110" name=""/>
+          <p:cNvPr id="113" name=""/>
           <p:cNvSpPr/>
           <p:nvPr/>
         </p:nvSpPr>
         <p:spPr>
           <a:xfrm>
             <a:off x="3225600" y="4789800"/>
-            <a:ext cx="1446120" cy="345240"/>
+            <a:ext cx="1445760" cy="344880"/>
           </a:xfrm>
           <a:prstGeom prst="rect">
             <a:avLst/>
@@ -6825,14 +6741,14 @@
       </p:sp>
       <p:sp>
         <p:nvSpPr>
-          <p:cNvPr id="111" name=""/>
+          <p:cNvPr id="114" name=""/>
           <p:cNvSpPr/>
           <p:nvPr/>
         </p:nvSpPr>
         <p:spPr>
           <a:xfrm>
             <a:off x="613800" y="937800"/>
-            <a:ext cx="4486320" cy="1033920"/>
+            <a:ext cx="4485960" cy="1033560"/>
           </a:xfrm>
           <a:prstGeom prst="rect">
             <a:avLst/>
@@ -6854,14 +6770,14 @@
       </p:sp>
       <p:sp>
         <p:nvSpPr>
-          <p:cNvPr id="112" name=""/>
+          <p:cNvPr id="115" name=""/>
           <p:cNvSpPr/>
           <p:nvPr/>
         </p:nvSpPr>
         <p:spPr>
           <a:xfrm>
             <a:off x="613800" y="2017800"/>
-            <a:ext cx="4486320" cy="724320"/>
+            <a:ext cx="4485960" cy="723960"/>
           </a:xfrm>
           <a:prstGeom prst="rect">
             <a:avLst/>
@@ -6883,14 +6799,14 @@
       </p:sp>
       <p:sp>
         <p:nvSpPr>
-          <p:cNvPr id="113" name=""/>
+          <p:cNvPr id="116" name=""/>
           <p:cNvSpPr/>
           <p:nvPr/>
         </p:nvSpPr>
         <p:spPr>
           <a:xfrm>
             <a:off x="649800" y="2815200"/>
-            <a:ext cx="2128320" cy="1842120"/>
+            <a:ext cx="2127960" cy="1841760"/>
           </a:xfrm>
           <a:prstGeom prst="rect">
             <a:avLst/>
@@ -6912,14 +6828,14 @@
       </p:sp>
       <p:sp>
         <p:nvSpPr>
-          <p:cNvPr id="114" name=""/>
+          <p:cNvPr id="117" name=""/>
           <p:cNvSpPr/>
           <p:nvPr/>
         </p:nvSpPr>
         <p:spPr>
           <a:xfrm>
             <a:off x="2863800" y="2815200"/>
-            <a:ext cx="2230920" cy="1842120"/>
+            <a:ext cx="2230560" cy="1841760"/>
           </a:xfrm>
           <a:prstGeom prst="rect">
             <a:avLst/>
@@ -6941,7 +6857,7 @@
       </p:sp>
       <p:sp>
         <p:nvSpPr>
-          <p:cNvPr id="115" name=""/>
+          <p:cNvPr id="118" name=""/>
           <p:cNvSpPr/>
           <p:nvPr/>
         </p:nvSpPr>
@@ -6970,7 +6886,7 @@
       </p:sp>
       <p:sp>
         <p:nvSpPr>
-          <p:cNvPr id="116" name=""/>
+          <p:cNvPr id="119" name=""/>
           <p:cNvSpPr/>
           <p:nvPr/>
         </p:nvSpPr>
@@ -6996,6 +6912,87 @@
           <a:effectRef idx="0"/>
           <a:fontRef idx="minor"/>
         </p:style>
+      </p:sp>
+      <p:sp>
+        <p:nvSpPr>
+          <p:cNvPr id="120" name=""/>
+          <p:cNvSpPr/>
+          <p:nvPr/>
+        </p:nvSpPr>
+        <p:spPr>
+          <a:xfrm flipH="1">
+            <a:off x="7260120" y="1022760"/>
+            <a:ext cx="750240" cy="360"/>
+          </a:xfrm>
+          <a:prstGeom prst="line">
+            <a:avLst/>
+          </a:prstGeom>
+          <a:ln w="36720">
+            <a:solidFill>
+              <a:srgbClr val="ff0000"/>
+            </a:solidFill>
+            <a:round/>
+            <a:tailEnd len="med" type="triangle" w="med"/>
+          </a:ln>
+        </p:spPr>
+        <p:style>
+          <a:lnRef idx="0"/>
+          <a:fillRef idx="0"/>
+          <a:effectRef idx="0"/>
+          <a:fontRef idx="minor"/>
+        </p:style>
+      </p:sp>
+      <p:sp>
+        <p:nvSpPr>
+          <p:cNvPr id="121" name=""/>
+          <p:cNvSpPr/>
+          <p:nvPr/>
+        </p:nvSpPr>
+        <p:spPr>
+          <a:xfrm>
+            <a:off x="8012520" y="829800"/>
+            <a:ext cx="1360080" cy="999000"/>
+          </a:xfrm>
+          <a:prstGeom prst="rect">
+            <a:avLst/>
+          </a:prstGeom>
+          <a:noFill/>
+          <a:ln w="0">
+            <a:noFill/>
+          </a:ln>
+        </p:spPr>
+        <p:style>
+          <a:lnRef idx="0"/>
+          <a:fillRef idx="0"/>
+          <a:effectRef idx="0"/>
+          <a:fontRef idx="minor"/>
+        </p:style>
+        <p:txBody>
+          <a:bodyPr lIns="90000" rIns="90000" tIns="45000" bIns="45000" anchor="t">
+            <a:noAutofit/>
+          </a:bodyPr>
+          <a:p>
+            <a:pPr>
+              <a:lnSpc>
+                <a:spcPct val="100000"/>
+              </a:lnSpc>
+              <a:buNone/>
+            </a:pPr>
+            <a:r>
+              <a:rPr b="0" lang="en-US" sz="1800" spc="-1" strike="noStrike">
+                <a:solidFill>
+                  <a:srgbClr val="000000"/>
+                </a:solidFill>
+                <a:latin typeface="Arial"/>
+                <a:ea typeface="DejaVu Sans"/>
+              </a:rPr>
+              <a:t>Access to 1D/2D/3D output </a:t>
+            </a:r>
+            <a:endParaRPr b="0" lang="en-US" sz="1800" spc="-1" strike="noStrike">
+              <a:latin typeface="Arial"/>
+            </a:endParaRPr>
+          </a:p>
+        </p:txBody>
       </p:sp>
     </p:spTree>
   </p:cSld>
@@ -7029,7 +7026,7 @@
       </p:grpSpPr>
       <p:pic>
         <p:nvPicPr>
-          <p:cNvPr id="117" name="" descr=""/>
+          <p:cNvPr id="122" name="" descr=""/>
           <p:cNvPicPr/>
           <p:nvPr/>
         </p:nvPicPr>
@@ -7040,7 +7037,7 @@
         <p:spPr>
           <a:xfrm>
             <a:off x="4572000" y="133200"/>
-            <a:ext cx="2833920" cy="2742480"/>
+            <a:ext cx="2833560" cy="2742120"/>
           </a:xfrm>
           <a:prstGeom prst="rect">
             <a:avLst/>
@@ -7052,7 +7049,7 @@
       </p:pic>
       <p:pic>
         <p:nvPicPr>
-          <p:cNvPr id="118" name="" descr=""/>
+          <p:cNvPr id="123" name="" descr=""/>
           <p:cNvPicPr/>
           <p:nvPr/>
         </p:nvPicPr>
@@ -7063,7 +7060,7 @@
         <p:spPr>
           <a:xfrm>
             <a:off x="685800" y="139680"/>
-            <a:ext cx="2660040" cy="2573640"/>
+            <a:ext cx="2659680" cy="2573280"/>
           </a:xfrm>
           <a:prstGeom prst="rect">
             <a:avLst/>
@@ -7075,7 +7072,7 @@
       </p:pic>
       <p:sp>
         <p:nvSpPr>
-          <p:cNvPr id="119" name=""/>
+          <p:cNvPr id="124" name=""/>
           <p:cNvSpPr/>
           <p:nvPr/>
         </p:nvSpPr>
@@ -7104,7 +7101,7 @@
       </p:sp>
       <p:sp>
         <p:nvSpPr>
-          <p:cNvPr id="120" name=""/>
+          <p:cNvPr id="125" name=""/>
           <p:cNvSpPr/>
           <p:nvPr/>
         </p:nvSpPr>
@@ -7133,14 +7130,14 @@
       </p:sp>
       <p:sp>
         <p:nvSpPr>
-          <p:cNvPr id="121" name=""/>
+          <p:cNvPr id="126" name=""/>
           <p:cNvSpPr/>
           <p:nvPr/>
         </p:nvSpPr>
         <p:spPr>
           <a:xfrm>
             <a:off x="1092960" y="2610720"/>
-            <a:ext cx="963720" cy="489240"/>
+            <a:ext cx="963360" cy="488880"/>
           </a:xfrm>
           <a:prstGeom prst="rect">
             <a:avLst/>
@@ -7185,14 +7182,14 @@
       </p:sp>
       <p:sp>
         <p:nvSpPr>
-          <p:cNvPr id="122" name=""/>
+          <p:cNvPr id="127" name=""/>
           <p:cNvSpPr/>
           <p:nvPr/>
         </p:nvSpPr>
         <p:spPr>
           <a:xfrm>
             <a:off x="1092960" y="1833480"/>
-            <a:ext cx="963720" cy="489240"/>
+            <a:ext cx="963360" cy="488880"/>
           </a:xfrm>
           <a:prstGeom prst="rect">
             <a:avLst/>
@@ -7237,7 +7234,7 @@
       </p:sp>
       <p:sp>
         <p:nvSpPr>
-          <p:cNvPr id="123" name=""/>
+          <p:cNvPr id="128" name=""/>
           <p:cNvSpPr/>
           <p:nvPr/>
         </p:nvSpPr>
@@ -7266,7 +7263,7 @@
       </p:sp>
       <p:pic>
         <p:nvPicPr>
-          <p:cNvPr id="124" name="" descr=""/>
+          <p:cNvPr id="129" name="" descr=""/>
           <p:cNvPicPr/>
           <p:nvPr/>
         </p:nvPicPr>
@@ -7277,7 +7274,7 @@
         <p:spPr>
           <a:xfrm>
             <a:off x="4572000" y="2876400"/>
-            <a:ext cx="2833920" cy="2742480"/>
+            <a:ext cx="2833560" cy="2742120"/>
           </a:xfrm>
           <a:prstGeom prst="rect">
             <a:avLst/>
@@ -7289,7 +7286,7 @@
       </p:pic>
       <p:pic>
         <p:nvPicPr>
-          <p:cNvPr id="125" name="" descr=""/>
+          <p:cNvPr id="130" name="" descr=""/>
           <p:cNvPicPr/>
           <p:nvPr/>
         </p:nvPicPr>
@@ -7300,7 +7297,7 @@
         <p:spPr>
           <a:xfrm>
             <a:off x="545760" y="2927520"/>
-            <a:ext cx="2833920" cy="2742480"/>
+            <a:ext cx="2833560" cy="2742120"/>
           </a:xfrm>
           <a:prstGeom prst="rect">
             <a:avLst/>
@@ -7312,7 +7309,7 @@
       </p:pic>
       <p:sp>
         <p:nvSpPr>
-          <p:cNvPr id="126" name=""/>
+          <p:cNvPr id="131" name=""/>
           <p:cNvSpPr/>
           <p:nvPr/>
         </p:nvSpPr>
@@ -7341,7 +7338,7 @@
       </p:sp>
       <p:sp>
         <p:nvSpPr>
-          <p:cNvPr id="127" name=""/>
+          <p:cNvPr id="132" name=""/>
           <p:cNvSpPr/>
           <p:nvPr/>
         </p:nvSpPr>
@@ -7370,14 +7367,14 @@
       </p:sp>
       <p:sp>
         <p:nvSpPr>
-          <p:cNvPr id="128" name=""/>
+          <p:cNvPr id="133" name=""/>
           <p:cNvSpPr/>
           <p:nvPr/>
         </p:nvSpPr>
         <p:spPr>
           <a:xfrm>
             <a:off x="4765320" y="5023080"/>
-            <a:ext cx="963720" cy="489240"/>
+            <a:ext cx="963360" cy="488880"/>
           </a:xfrm>
           <a:prstGeom prst="rect">
             <a:avLst/>
@@ -7422,14 +7419,14 @@
       </p:sp>
       <p:sp>
         <p:nvSpPr>
-          <p:cNvPr id="129" name=""/>
+          <p:cNvPr id="134" name=""/>
           <p:cNvSpPr/>
           <p:nvPr/>
         </p:nvSpPr>
         <p:spPr>
           <a:xfrm>
             <a:off x="3577680" y="4159440"/>
-            <a:ext cx="1150200" cy="489240"/>
+            <a:ext cx="1149840" cy="488880"/>
           </a:xfrm>
           <a:prstGeom prst="rect">
             <a:avLst/>
@@ -7474,14 +7471,14 @@
       </p:sp>
       <p:sp>
         <p:nvSpPr>
-          <p:cNvPr id="130" name=""/>
+          <p:cNvPr id="135" name=""/>
           <p:cNvSpPr/>
           <p:nvPr/>
         </p:nvSpPr>
         <p:spPr>
           <a:xfrm>
             <a:off x="3614040" y="1459800"/>
-            <a:ext cx="1150200" cy="489240"/>
+            <a:ext cx="1149840" cy="488880"/>
           </a:xfrm>
           <a:prstGeom prst="rect">
             <a:avLst/>
@@ -7526,7 +7523,7 @@
       </p:sp>
       <p:sp>
         <p:nvSpPr>
-          <p:cNvPr id="131" name=""/>
+          <p:cNvPr id="136" name=""/>
           <p:cNvSpPr/>
           <p:nvPr/>
         </p:nvSpPr>
@@ -7555,7 +7552,7 @@
       </p:sp>
       <p:sp>
         <p:nvSpPr>
-          <p:cNvPr id="132" name=""/>
+          <p:cNvPr id="137" name=""/>
           <p:cNvSpPr/>
           <p:nvPr/>
         </p:nvSpPr>
@@ -7614,7 +7611,7 @@
       </p:grpSpPr>
       <p:pic>
         <p:nvPicPr>
-          <p:cNvPr id="133" name="" descr=""/>
+          <p:cNvPr id="138" name="" descr=""/>
           <p:cNvPicPr/>
           <p:nvPr/>
         </p:nvPicPr>
@@ -7625,7 +7622,7 @@
         <p:spPr>
           <a:xfrm>
             <a:off x="1826640" y="1700280"/>
-            <a:ext cx="6495120" cy="2313360"/>
+            <a:ext cx="6494760" cy="2313000"/>
           </a:xfrm>
           <a:prstGeom prst="rect">
             <a:avLst/>
@@ -7667,7 +7664,7 @@
       </p:grpSpPr>
       <p:pic>
         <p:nvPicPr>
-          <p:cNvPr id="134" name="" descr=""/>
+          <p:cNvPr id="139" name="" descr=""/>
           <p:cNvPicPr/>
           <p:nvPr/>
         </p:nvPicPr>
@@ -7678,7 +7675,7 @@
         <p:spPr>
           <a:xfrm>
             <a:off x="694800" y="1417320"/>
-            <a:ext cx="3419640" cy="2925720"/>
+            <a:ext cx="3419280" cy="2925360"/>
           </a:xfrm>
           <a:prstGeom prst="rect">
             <a:avLst/>
@@ -7720,7 +7717,7 @@
       </p:grpSpPr>
       <p:pic>
         <p:nvPicPr>
-          <p:cNvPr id="135" name="" descr=""/>
+          <p:cNvPr id="140" name="" descr=""/>
           <p:cNvPicPr/>
           <p:nvPr/>
         </p:nvPicPr>
@@ -7731,7 +7728,7 @@
         <p:spPr>
           <a:xfrm>
             <a:off x="1143000" y="279000"/>
-            <a:ext cx="3638880" cy="2925720"/>
+            <a:ext cx="3638520" cy="2925360"/>
           </a:xfrm>
           <a:prstGeom prst="rect">
             <a:avLst/>
@@ -7743,7 +7740,7 @@
       </p:pic>
       <p:pic>
         <p:nvPicPr>
-          <p:cNvPr id="136" name="" descr=""/>
+          <p:cNvPr id="141" name="" descr=""/>
           <p:cNvPicPr/>
           <p:nvPr/>
         </p:nvPicPr>
@@ -7754,7 +7751,7 @@
         <p:spPr>
           <a:xfrm>
             <a:off x="5257800" y="276120"/>
-            <a:ext cx="3638880" cy="2925720"/>
+            <a:ext cx="3638520" cy="2925360"/>
           </a:xfrm>
           <a:prstGeom prst="rect">
             <a:avLst/>
@@ -7766,7 +7763,7 @@
       </p:pic>
       <p:sp>
         <p:nvSpPr>
-          <p:cNvPr id="137" name=""/>
+          <p:cNvPr id="142" name=""/>
           <p:cNvSpPr/>
           <p:nvPr/>
         </p:nvSpPr>
@@ -7795,7 +7792,7 @@
       </p:sp>
       <p:pic>
         <p:nvPicPr>
-          <p:cNvPr id="138" name="" descr=""/>
+          <p:cNvPr id="143" name="" descr=""/>
           <p:cNvPicPr/>
           <p:nvPr/>
         </p:nvPicPr>
@@ -7806,7 +7803,7 @@
         <p:spPr>
           <a:xfrm>
             <a:off x="6571800" y="3196080"/>
-            <a:ext cx="3163680" cy="2468880"/>
+            <a:ext cx="3163320" cy="2468520"/>
           </a:xfrm>
           <a:prstGeom prst="rect">
             <a:avLst/>
@@ -7818,7 +7815,7 @@
       </p:pic>
       <p:pic>
         <p:nvPicPr>
-          <p:cNvPr id="139" name="" descr=""/>
+          <p:cNvPr id="144" name="" descr=""/>
           <p:cNvPicPr/>
           <p:nvPr/>
         </p:nvPicPr>
@@ -7829,7 +7826,7 @@
         <p:spPr>
           <a:xfrm>
             <a:off x="2027880" y="3230640"/>
-            <a:ext cx="3072240" cy="2468880"/>
+            <a:ext cx="3071880" cy="2468520"/>
           </a:xfrm>
           <a:prstGeom prst="rect">
             <a:avLst/>

</xml_diff>

<commit_message>
cookie consent, free access
</commit_message>
<xml_diff>
--- a/doc/images/Monomer.pptx
+++ b/doc/images/Monomer.pptx
@@ -73,7 +73,7 @@
         <p:txBody>
           <a:bodyPr/>
           <a:p>
-            <a:fld id="{4944200B-27B0-472E-B12C-1D6CA266E87C}" type="slidenum">
+            <a:fld id="{75C12FE1-63D4-408F-8812-9063C1526B83}" type="slidenum">
               <a:t>&lt;#&gt;</a:t>
             </a:fld>
           </a:p>
@@ -261,7 +261,7 @@
         <p:txBody>
           <a:bodyPr/>
           <a:p>
-            <a:fld id="{C93E96F1-4351-4DDF-B24F-BF271F84213E}" type="slidenum">
+            <a:fld id="{FBCB32BE-0C9D-459B-9534-C83825F84AAD}" type="slidenum">
               <a:t>&lt;#&gt;</a:t>
             </a:fld>
           </a:p>
@@ -517,7 +517,7 @@
         <p:txBody>
           <a:bodyPr/>
           <a:p>
-            <a:fld id="{894DE672-710D-4C7A-830A-DA6337C4C69D}" type="slidenum">
+            <a:fld id="{8A20586C-DCF6-450F-99CF-93F11112E17C}" type="slidenum">
               <a:t>&lt;#&gt;</a:t>
             </a:fld>
           </a:p>
@@ -841,7 +841,7 @@
         <p:txBody>
           <a:bodyPr/>
           <a:p>
-            <a:fld id="{23ADF548-47C1-4A95-B56B-8F59EB2A75DE}" type="slidenum">
+            <a:fld id="{15384C77-8B2E-4205-B8AF-735C8CBD4932}" type="slidenum">
               <a:t>&lt;#&gt;</a:t>
             </a:fld>
           </a:p>
@@ -924,7 +924,7 @@
         <p:txBody>
           <a:bodyPr/>
           <a:p>
-            <a:fld id="{602C1933-522F-4AA8-B3E0-47B78F813EFF}" type="slidenum">
+            <a:fld id="{23BFB94D-A015-4894-B26E-04B5A3006B5B}" type="slidenum">
               <a:t>&lt;#&gt;</a:t>
             </a:fld>
           </a:p>
@@ -1081,7 +1081,7 @@
         <p:txBody>
           <a:bodyPr/>
           <a:p>
-            <a:fld id="{EA45151E-0EAC-4573-BCE7-B39C4D984079}" type="slidenum">
+            <a:fld id="{2DD2FF55-3E93-4262-B0E9-D3A374B26D4F}" type="slidenum">
               <a:t>&lt;#&gt;</a:t>
             </a:fld>
           </a:p>
@@ -1235,7 +1235,7 @@
         <p:txBody>
           <a:bodyPr/>
           <a:p>
-            <a:fld id="{5B92F725-615C-4C04-BADB-3ACE1417E36F}" type="slidenum">
+            <a:fld id="{6B11FC52-862C-46F5-94D8-4ACF655BD941}" type="slidenum">
               <a:t>&lt;#&gt;</a:t>
             </a:fld>
           </a:p>
@@ -1423,7 +1423,7 @@
         <p:txBody>
           <a:bodyPr/>
           <a:p>
-            <a:fld id="{E5FE3753-0460-4248-94EE-40D74B0CDF51}" type="slidenum">
+            <a:fld id="{E70E4EE0-F79F-4C5A-A149-15D7EE3B28B8}" type="slidenum">
               <a:t>&lt;#&gt;</a:t>
             </a:fld>
           </a:p>
@@ -1543,7 +1543,7 @@
         <p:txBody>
           <a:bodyPr/>
           <a:p>
-            <a:fld id="{D016315A-FB8A-437F-9060-10C078DF9B51}" type="slidenum">
+            <a:fld id="{DC51B458-DEDC-46FD-9A96-059F8B223F3D}" type="slidenum">
               <a:t>&lt;#&gt;</a:t>
             </a:fld>
           </a:p>
@@ -1663,7 +1663,7 @@
         <p:txBody>
           <a:bodyPr/>
           <a:p>
-            <a:fld id="{4C272D02-2AF3-4005-8CB4-150675199459}" type="slidenum">
+            <a:fld id="{982F1779-18BB-4578-958D-E73BE2635195}" type="slidenum">
               <a:t>&lt;#&gt;</a:t>
             </a:fld>
           </a:p>
@@ -1885,7 +1885,7 @@
         <p:txBody>
           <a:bodyPr/>
           <a:p>
-            <a:fld id="{0FFE5CA5-5F5A-4703-80E3-42DFA979CE30}" type="slidenum">
+            <a:fld id="{EDCBA852-6137-4070-B264-2A3221381804}" type="slidenum">
               <a:t>&lt;#&gt;</a:t>
             </a:fld>
           </a:p>
@@ -2042,7 +2042,7 @@
         <p:txBody>
           <a:bodyPr/>
           <a:p>
-            <a:fld id="{7C60E375-21F1-4756-B815-CD7DFA435391}" type="slidenum">
+            <a:fld id="{235CDB38-AD6D-4A72-A114-09517C08B1A1}" type="slidenum">
               <a:t>&lt;#&gt;</a:t>
             </a:fld>
           </a:p>
@@ -2264,7 +2264,7 @@
         <p:txBody>
           <a:bodyPr/>
           <a:p>
-            <a:fld id="{EFD9E324-CC90-4414-A571-ADBFBA83F8C7}" type="slidenum">
+            <a:fld id="{32A86B70-C8E4-46A1-843C-1D25D0522CFC}" type="slidenum">
               <a:t>&lt;#&gt;</a:t>
             </a:fld>
           </a:p>
@@ -2486,7 +2486,7 @@
         <p:txBody>
           <a:bodyPr/>
           <a:p>
-            <a:fld id="{F8AFA795-6D76-4551-8676-D28780EC7885}" type="slidenum">
+            <a:fld id="{F4616EB4-852D-4CFB-B13C-4DE6CB8A707C}" type="slidenum">
               <a:t>&lt;#&gt;</a:t>
             </a:fld>
           </a:p>
@@ -2674,7 +2674,7 @@
         <p:txBody>
           <a:bodyPr/>
           <a:p>
-            <a:fld id="{A23A6BF3-8B1F-4713-A0D5-B3EF5B79F0CD}" type="slidenum">
+            <a:fld id="{38773510-0716-4ABF-BA4D-A05F96181F36}" type="slidenum">
               <a:t>&lt;#&gt;</a:t>
             </a:fld>
           </a:p>
@@ -2930,7 +2930,7 @@
         <p:txBody>
           <a:bodyPr/>
           <a:p>
-            <a:fld id="{6FD6000A-D83B-428B-B72D-D154B5E90D0B}" type="slidenum">
+            <a:fld id="{7184E4F0-EFA6-4E48-9173-A03E94D16011}" type="slidenum">
               <a:t>&lt;#&gt;</a:t>
             </a:fld>
           </a:p>
@@ -3254,7 +3254,7 @@
         <p:txBody>
           <a:bodyPr/>
           <a:p>
-            <a:fld id="{8F161E61-E599-4624-93CD-ED75E5CBEC80}" type="slidenum">
+            <a:fld id="{40454D63-3583-45B3-9F4F-9784184B6833}" type="slidenum">
               <a:t>&lt;#&gt;</a:t>
             </a:fld>
           </a:p>
@@ -3408,7 +3408,7 @@
         <p:txBody>
           <a:bodyPr/>
           <a:p>
-            <a:fld id="{94B52A9B-F3E7-47DB-BF8F-FF09BDC22457}" type="slidenum">
+            <a:fld id="{45D29468-CDE2-4664-B69B-D6693E696F4D}" type="slidenum">
               <a:t>&lt;#&gt;</a:t>
             </a:fld>
           </a:p>
@@ -3596,7 +3596,7 @@
         <p:txBody>
           <a:bodyPr/>
           <a:p>
-            <a:fld id="{8262BF16-7074-4B9D-B327-53941B18A639}" type="slidenum">
+            <a:fld id="{28F71DFC-A56F-4BFE-BA27-37B9170A4836}" type="slidenum">
               <a:t>&lt;#&gt;</a:t>
             </a:fld>
           </a:p>
@@ -3716,7 +3716,7 @@
         <p:txBody>
           <a:bodyPr/>
           <a:p>
-            <a:fld id="{113F9391-5503-48BA-8D22-00757942F98F}" type="slidenum">
+            <a:fld id="{CC7D82FF-4E2B-4101-B674-759934E7E087}" type="slidenum">
               <a:t>&lt;#&gt;</a:t>
             </a:fld>
           </a:p>
@@ -3836,7 +3836,7 @@
         <p:txBody>
           <a:bodyPr/>
           <a:p>
-            <a:fld id="{47929BD5-8770-47AC-AB41-6DFA31C1C188}" type="slidenum">
+            <a:fld id="{6E276355-1C5E-42DB-B5B1-9D040B246930}" type="slidenum">
               <a:t>&lt;#&gt;</a:t>
             </a:fld>
           </a:p>
@@ -4058,7 +4058,7 @@
         <p:txBody>
           <a:bodyPr/>
           <a:p>
-            <a:fld id="{D4E5BDB2-0838-4DF7-9ED9-B518E90948C6}" type="slidenum">
+            <a:fld id="{A9C5B865-9C62-4ACE-BF76-812E4C34B0E3}" type="slidenum">
               <a:t>&lt;#&gt;</a:t>
             </a:fld>
           </a:p>
@@ -4280,7 +4280,7 @@
         <p:txBody>
           <a:bodyPr/>
           <a:p>
-            <a:fld id="{DE636A17-9CE3-471C-93CC-C0D4F5CE3B27}" type="slidenum">
+            <a:fld id="{B041036E-F9C7-46FC-BC98-196CC1E3140C}" type="slidenum">
               <a:t>&lt;#&gt;</a:t>
             </a:fld>
           </a:p>
@@ -4502,7 +4502,7 @@
         <p:txBody>
           <a:bodyPr/>
           <a:p>
-            <a:fld id="{F3A4B884-8912-42EF-9EA0-170BD82C4F5D}" type="slidenum">
+            <a:fld id="{D6005D8B-4E2E-46CB-8C2C-6AE21C59999C}" type="slidenum">
               <a:t>&lt;#&gt;</a:t>
             </a:fld>
           </a:p>
@@ -4674,7 +4674,7 @@
                 <a:tab algn="l" pos="0"/>
               </a:tabLst>
             </a:pPr>
-            <a:fld id="{1021506B-D106-4780-B073-F87F07CD7E6F}" type="slidenum">
+            <a:fld id="{7DCDEE0E-434F-4276-BFF3-56002205CD9E}" type="slidenum">
               <a:rPr b="0" lang="en-US" sz="1400" spc="-1" strike="noStrike">
                 <a:solidFill>
                   <a:srgbClr val="000000"/>
@@ -4771,211 +4771,37 @@
               <a:rPr b="0" lang="en-US" sz="4400" spc="-1" strike="noStrike">
                 <a:latin typeface="Arial"/>
               </a:rPr>
-              <a:t>C</a:t>
+              <a:t>Click </a:t>
             </a:r>
             <a:r>
               <a:rPr b="0" lang="en-US" sz="4400" spc="-1" strike="noStrike">
                 <a:latin typeface="Arial"/>
               </a:rPr>
-              <a:t>l</a:t>
+              <a:t>to edit </a:t>
             </a:r>
             <a:r>
               <a:rPr b="0" lang="en-US" sz="4400" spc="-1" strike="noStrike">
                 <a:latin typeface="Arial"/>
               </a:rPr>
-              <a:t>i</a:t>
+              <a:t>the </a:t>
             </a:r>
             <a:r>
               <a:rPr b="0" lang="en-US" sz="4400" spc="-1" strike="noStrike">
                 <a:latin typeface="Arial"/>
               </a:rPr>
-              <a:t>c</a:t>
+              <a:t>title </a:t>
             </a:r>
             <a:r>
               <a:rPr b="0" lang="en-US" sz="4400" spc="-1" strike="noStrike">
                 <a:latin typeface="Arial"/>
               </a:rPr>
-              <a:t>k</a:t>
+              <a:t>text </a:t>
             </a:r>
             <a:r>
               <a:rPr b="0" lang="en-US" sz="4400" spc="-1" strike="noStrike">
                 <a:latin typeface="Arial"/>
               </a:rPr>
-              <a:t> </a:t>
-            </a:r>
-            <a:r>
-              <a:rPr b="0" lang="en-US" sz="4400" spc="-1" strike="noStrike">
-                <a:latin typeface="Arial"/>
-              </a:rPr>
-              <a:t>t</a:t>
-            </a:r>
-            <a:r>
-              <a:rPr b="0" lang="en-US" sz="4400" spc="-1" strike="noStrike">
-                <a:latin typeface="Arial"/>
-              </a:rPr>
-              <a:t>o</a:t>
-            </a:r>
-            <a:r>
-              <a:rPr b="0" lang="en-US" sz="4400" spc="-1" strike="noStrike">
-                <a:latin typeface="Arial"/>
-              </a:rPr>
-              <a:t> </a:t>
-            </a:r>
-            <a:r>
-              <a:rPr b="0" lang="en-US" sz="4400" spc="-1" strike="noStrike">
-                <a:latin typeface="Arial"/>
-              </a:rPr>
-              <a:t>e</a:t>
-            </a:r>
-            <a:r>
-              <a:rPr b="0" lang="en-US" sz="4400" spc="-1" strike="noStrike">
-                <a:latin typeface="Arial"/>
-              </a:rPr>
-              <a:t>d</a:t>
-            </a:r>
-            <a:r>
-              <a:rPr b="0" lang="en-US" sz="4400" spc="-1" strike="noStrike">
-                <a:latin typeface="Arial"/>
-              </a:rPr>
-              <a:t>i</a:t>
-            </a:r>
-            <a:r>
-              <a:rPr b="0" lang="en-US" sz="4400" spc="-1" strike="noStrike">
-                <a:latin typeface="Arial"/>
-              </a:rPr>
-              <a:t>t</a:t>
-            </a:r>
-            <a:r>
-              <a:rPr b="0" lang="en-US" sz="4400" spc="-1" strike="noStrike">
-                <a:latin typeface="Arial"/>
-              </a:rPr>
-              <a:t> </a:t>
-            </a:r>
-            <a:r>
-              <a:rPr b="0" lang="en-US" sz="4400" spc="-1" strike="noStrike">
-                <a:latin typeface="Arial"/>
-              </a:rPr>
-              <a:t>t</a:t>
-            </a:r>
-            <a:r>
-              <a:rPr b="0" lang="en-US" sz="4400" spc="-1" strike="noStrike">
-                <a:latin typeface="Arial"/>
-              </a:rPr>
-              <a:t>h</a:t>
-            </a:r>
-            <a:r>
-              <a:rPr b="0" lang="en-US" sz="4400" spc="-1" strike="noStrike">
-                <a:latin typeface="Arial"/>
-              </a:rPr>
-              <a:t>e</a:t>
-            </a:r>
-            <a:r>
-              <a:rPr b="0" lang="en-US" sz="4400" spc="-1" strike="noStrike">
-                <a:latin typeface="Arial"/>
-              </a:rPr>
-              <a:t> </a:t>
-            </a:r>
-            <a:r>
-              <a:rPr b="0" lang="en-US" sz="4400" spc="-1" strike="noStrike">
-                <a:latin typeface="Arial"/>
-              </a:rPr>
-              <a:t>t</a:t>
-            </a:r>
-            <a:r>
-              <a:rPr b="0" lang="en-US" sz="4400" spc="-1" strike="noStrike">
-                <a:latin typeface="Arial"/>
-              </a:rPr>
-              <a:t>i</a:t>
-            </a:r>
-            <a:r>
-              <a:rPr b="0" lang="en-US" sz="4400" spc="-1" strike="noStrike">
-                <a:latin typeface="Arial"/>
-              </a:rPr>
-              <a:t>t</a:t>
-            </a:r>
-            <a:r>
-              <a:rPr b="0" lang="en-US" sz="4400" spc="-1" strike="noStrike">
-                <a:latin typeface="Arial"/>
-              </a:rPr>
-              <a:t>l</a:t>
-            </a:r>
-            <a:r>
-              <a:rPr b="0" lang="en-US" sz="4400" spc="-1" strike="noStrike">
-                <a:latin typeface="Arial"/>
-              </a:rPr>
-              <a:t>e</a:t>
-            </a:r>
-            <a:r>
-              <a:rPr b="0" lang="en-US" sz="4400" spc="-1" strike="noStrike">
-                <a:latin typeface="Arial"/>
-              </a:rPr>
-              <a:t> </a:t>
-            </a:r>
-            <a:r>
-              <a:rPr b="0" lang="en-US" sz="4400" spc="-1" strike="noStrike">
-                <a:latin typeface="Arial"/>
-              </a:rPr>
-              <a:t>t</a:t>
-            </a:r>
-            <a:r>
-              <a:rPr b="0" lang="en-US" sz="4400" spc="-1" strike="noStrike">
-                <a:latin typeface="Arial"/>
-              </a:rPr>
-              <a:t>e</a:t>
-            </a:r>
-            <a:r>
-              <a:rPr b="0" lang="en-US" sz="4400" spc="-1" strike="noStrike">
-                <a:latin typeface="Arial"/>
-              </a:rPr>
-              <a:t>x</a:t>
-            </a:r>
-            <a:r>
-              <a:rPr b="0" lang="en-US" sz="4400" spc="-1" strike="noStrike">
-                <a:latin typeface="Arial"/>
-              </a:rPr>
-              <a:t>t</a:t>
-            </a:r>
-            <a:r>
-              <a:rPr b="0" lang="en-US" sz="4400" spc="-1" strike="noStrike">
-                <a:latin typeface="Arial"/>
-              </a:rPr>
-              <a:t> </a:t>
-            </a:r>
-            <a:r>
-              <a:rPr b="0" lang="en-US" sz="4400" spc="-1" strike="noStrike">
-                <a:latin typeface="Arial"/>
-              </a:rPr>
-              <a:t>f</a:t>
-            </a:r>
-            <a:r>
-              <a:rPr b="0" lang="en-US" sz="4400" spc="-1" strike="noStrike">
-                <a:latin typeface="Arial"/>
-              </a:rPr>
-              <a:t>o</a:t>
-            </a:r>
-            <a:r>
-              <a:rPr b="0" lang="en-US" sz="4400" spc="-1" strike="noStrike">
-                <a:latin typeface="Arial"/>
-              </a:rPr>
-              <a:t>r</a:t>
-            </a:r>
-            <a:r>
-              <a:rPr b="0" lang="en-US" sz="4400" spc="-1" strike="noStrike">
-                <a:latin typeface="Arial"/>
-              </a:rPr>
-              <a:t>m</a:t>
-            </a:r>
-            <a:r>
-              <a:rPr b="0" lang="en-US" sz="4400" spc="-1" strike="noStrike">
-                <a:latin typeface="Arial"/>
-              </a:rPr>
-              <a:t>a</a:t>
-            </a:r>
-            <a:r>
-              <a:rPr b="0" lang="en-US" sz="4400" spc="-1" strike="noStrike">
-                <a:latin typeface="Arial"/>
-              </a:rPr>
-              <a:t>t</a:t>
+              <a:t>format</a:t>
             </a:r>
             <a:endParaRPr b="0" lang="en-US" sz="4400" spc="-1" strike="noStrike">
               <a:latin typeface="Arial"/>
@@ -5326,7 +5152,7 @@
                 <a:tab algn="l" pos="0"/>
               </a:tabLst>
             </a:pPr>
-            <a:fld id="{E86538C1-FC87-4234-B074-DF79CAE44C16}" type="slidenum">
+            <a:fld id="{DF991BE6-D8E3-45B7-BC0D-ABD63DBF20E7}" type="slidenum">
               <a:rPr b="0" lang="en-US" sz="1400" spc="-1" strike="noStrike">
                 <a:solidFill>
                   <a:srgbClr val="000000"/>
@@ -5423,7 +5249,37 @@
               <a:rPr b="0" lang="en-US" sz="4400" spc="-1" strike="noStrike">
                 <a:latin typeface="Arial"/>
               </a:rPr>
-              <a:t>Click to edit the title text format</a:t>
+              <a:t>Click </a:t>
+            </a:r>
+            <a:r>
+              <a:rPr b="0" lang="en-US" sz="4400" spc="-1" strike="noStrike">
+                <a:latin typeface="Arial"/>
+              </a:rPr>
+              <a:t>to edit </a:t>
+            </a:r>
+            <a:r>
+              <a:rPr b="0" lang="en-US" sz="4400" spc="-1" strike="noStrike">
+                <a:latin typeface="Arial"/>
+              </a:rPr>
+              <a:t>the </a:t>
+            </a:r>
+            <a:r>
+              <a:rPr b="0" lang="en-US" sz="4400" spc="-1" strike="noStrike">
+                <a:latin typeface="Arial"/>
+              </a:rPr>
+              <a:t>title </a:t>
+            </a:r>
+            <a:r>
+              <a:rPr b="0" lang="en-US" sz="4400" spc="-1" strike="noStrike">
+                <a:latin typeface="Arial"/>
+              </a:rPr>
+              <a:t>text </a:t>
+            </a:r>
+            <a:r>
+              <a:rPr b="0" lang="en-US" sz="4400" spc="-1" strike="noStrike">
+                <a:latin typeface="Arial"/>
+              </a:rPr>
+              <a:t>format</a:t>
             </a:r>
             <a:endParaRPr b="0" lang="en-US" sz="4400" spc="-1" strike="noStrike">
               <a:latin typeface="Arial"/>
@@ -6400,32 +6256,9 @@
           </a:p>
         </p:txBody>
       </p:sp>
-      <p:pic>
-        <p:nvPicPr>
-          <p:cNvPr id="178" name="" descr=""/>
-          <p:cNvPicPr/>
-          <p:nvPr/>
-        </p:nvPicPr>
-        <p:blipFill>
-          <a:blip r:embed="rId4"/>
-          <a:stretch/>
-        </p:blipFill>
-        <p:spPr>
-          <a:xfrm>
-            <a:off x="4074480" y="3885840"/>
-            <a:ext cx="1869120" cy="1072080"/>
-          </a:xfrm>
-          <a:prstGeom prst="rect">
-            <a:avLst/>
-          </a:prstGeom>
-          <a:ln w="0">
-            <a:noFill/>
-          </a:ln>
-        </p:spPr>
-      </p:pic>
-      <p:sp>
-        <p:nvSpPr>
-          <p:cNvPr id="179" name=""/>
+      <p:sp>
+        <p:nvSpPr>
+          <p:cNvPr id="178" name=""/>
           <p:cNvSpPr txBox="1"/>
           <p:nvPr/>
         </p:nvSpPr>
@@ -6480,7 +6313,7 @@
       </p:sp>
       <p:sp>
         <p:nvSpPr>
-          <p:cNvPr id="180" name=""/>
+          <p:cNvPr id="179" name=""/>
           <p:cNvSpPr/>
           <p:nvPr/>
         </p:nvSpPr>
@@ -6509,7 +6342,7 @@
       </p:sp>
       <p:sp>
         <p:nvSpPr>
-          <p:cNvPr id="181" name=""/>
+          <p:cNvPr id="180" name=""/>
           <p:cNvSpPr/>
           <p:nvPr/>
         </p:nvSpPr>
@@ -6561,7 +6394,7 @@
       </p:sp>
       <p:sp>
         <p:nvSpPr>
-          <p:cNvPr id="182" name=""/>
+          <p:cNvPr id="181" name=""/>
           <p:cNvSpPr/>
           <p:nvPr/>
         </p:nvSpPr>
@@ -6588,6 +6421,29 @@
           <a:fontRef idx="minor"/>
         </p:style>
       </p:sp>
+      <p:pic>
+        <p:nvPicPr>
+          <p:cNvPr id="182" name="" descr=""/>
+          <p:cNvPicPr/>
+          <p:nvPr/>
+        </p:nvPicPr>
+        <p:blipFill>
+          <a:blip r:embed="rId4"/>
+          <a:stretch/>
+        </p:blipFill>
+        <p:spPr>
+          <a:xfrm>
+            <a:off x="4074480" y="3885840"/>
+            <a:ext cx="1869120" cy="1072080"/>
+          </a:xfrm>
+          <a:prstGeom prst="rect">
+            <a:avLst/>
+          </a:prstGeom>
+          <a:ln w="0">
+            <a:noFill/>
+          </a:ln>
+        </p:spPr>
+      </p:pic>
     </p:spTree>
   </p:cSld>
   <mc:AlternateContent>

</xml_diff>